<commit_message>
Make credit case cash scope and funding assumptions explicit
</commit_message>
<xml_diff>
--- a/examples/keshun-2025/deliverables/research-brief.pptx
+++ b/examples/keshun-2025/deliverables/research-brief.pptx
@@ -197,9 +197,9 @@
           </c:marker>
           <c:cat>
             <c:multiLvlStrRef>
-              <c:f>Sheet1!$A$2:$A$4</c:f>
+              <c:f>Sheet1!$A$2:$A$6</c:f>
               <c:multiLvlStrCache>
-                <c:ptCount val="3"/>
+                <c:ptCount val="5"/>
                 <c:lvl>
                   <c:pt idx="0">
                     <c:v>2026-06</c:v>
@@ -210,16 +210,22 @@
                   <c:pt idx="2">
                     <c:v>2026-12</c:v>
                   </c:pt>
+                  <c:pt idx="3">
+                    <c:v>2027-03</c:v>
+                  </c:pt>
+                  <c:pt idx="4">
+                    <c:v>2027-06</c:v>
+                  </c:pt>
                 </c:lvl>
               </c:multiLvlStrCache>
             </c:multiLvlStrRef>
           </c:cat>
           <c:val>
             <c:numRef>
-              <c:f>Sheet1!$B$2:$B$4</c:f>
+              <c:f>Sheet1!$B$2:$B$6</c:f>
               <c:numCache>
                 <c:formatCode>0.00</c:formatCode>
-                <c:ptCount val="3"/>
+                <c:ptCount val="5"/>
                 <c:pt idx="0">
                   <c:v>9.2686062725</c:v>
                 </c:pt>
@@ -228,6 +234,12 @@
                 </c:pt>
                 <c:pt idx="2">
                   <c:v>7.0258351029999995</c:v>
+                </c:pt>
+                <c:pt idx="3">
+                  <c:v>5.5450257040999995</c:v>
+                </c:pt>
+                <c:pt idx="4">
+                  <c:v>2.726631919</c:v>
                 </c:pt>
               </c:numCache>
             </c:numRef>
@@ -243,7 +255,7 @@
               <c:strCache>
                 <c:ptCount val="1"/>
                 <c:pt idx="0">
-                  <c:v>恶化</c:v>
+                  <c:v>收款另延5%至窗后</c:v>
                 </c:pt>
               </c:strCache>
             </c:strRef>
@@ -305,9 +317,9 @@
           </c:marker>
           <c:cat>
             <c:multiLvlStrRef>
-              <c:f>Sheet1!$A$2:$A$4</c:f>
+              <c:f>Sheet1!$A$2:$A$6</c:f>
               <c:multiLvlStrCache>
-                <c:ptCount val="3"/>
+                <c:ptCount val="5"/>
                 <c:lvl>
                   <c:pt idx="0">
                     <c:v>2026-06</c:v>
@@ -318,113 +330,11 @@
                   <c:pt idx="2">
                     <c:v>2026-12</c:v>
                   </c:pt>
-                </c:lvl>
-              </c:multiLvlStrCache>
-            </c:multiLvlStrRef>
-          </c:cat>
-          <c:val>
-            <c:numRef>
-              <c:f>Sheet1!$C$2:$C$4</c:f>
-              <c:numCache>
-                <c:formatCode>0.00</c:formatCode>
-                <c:ptCount val="3"/>
-                <c:pt idx="0">
-                  <c:v>6.509529258400001</c:v>
-                </c:pt>
-                <c:pt idx="1">
-                  <c:v>-3.3750750381</c:v>
-                </c:pt>
-                <c:pt idx="2">
-                  <c:v>-1.8544336184</c:v>
-                </c:pt>
-              </c:numCache>
-            </c:numRef>
-          </c:val>
-          <c:smooth val="0"/>
-        </c:ser>
-        <c:ser>
-          <c:idx val="2"/>
-          <c:order val="2"/>
-          <c:tx>
-            <c:strRef>
-              <c:f>Sheet1!$D$1</c:f>
-              <c:strCache>
-                <c:ptCount val="1"/>
-                <c:pt idx="0">
-                  <c:v>改善</c:v>
-                </c:pt>
-              </c:strCache>
-            </c:strRef>
-          </c:tx>
-          <c:spPr>
-            <a:solidFill>
-              <a:srgbClr val="8A9970"/>
-            </a:solidFill>
-            <a:ln w="25400" cap="flat">
-              <a:solidFill>
-                <a:srgbClr val="8A9970"/>
-              </a:solidFill>
-              <a:prstDash val="solid"/>
-              <a:round/>
-            </a:ln>
-            <a:effectLst/>
-          </c:spPr>
-          <c:invertIfNegative val="0"/>
-          <c:dLbls>
-            <c:numFmt formatCode="#,##0" sourceLinked="0"/>
-            <c:txPr>
-              <a:bodyPr/>
-              <a:lstStyle/>
-              <a:p>
-                <a:pPr>
-                  <a:defRPr b="0" i="0" strike="noStrike" sz="1200" u="none">
-                    <a:solidFill>
-                      <a:srgbClr val="000000"/>
-                    </a:solidFill>
-                    <a:latin typeface="Arial"/>
-                  </a:defRPr>
-                </a:pPr>
-              </a:p>
-            </c:txPr>
-            <c:showLegendKey val="0"/>
-            <c:showVal val="0"/>
-            <c:showCatName val="0"/>
-            <c:showSerName val="0"/>
-            <c:showPercent val="0"/>
-            <c:showBubbleSize val="0"/>
-            <c:showLeaderLines val="0"/>
-          </c:dLbls>
-          <c:marker>
-            <c:symbol val="circle"/>
-            <c:size val="6"/>
-            <c:spPr>
-              <a:solidFill>
-                <a:srgbClr val="8A9970"/>
-              </a:solidFill>
-              <a:ln w="9525" cap="flat">
-                <a:solidFill>
-                  <a:srgbClr val="8A9970"/>
-                </a:solidFill>
-                <a:prstDash val="solid"/>
-                <a:round/>
-              </a:ln>
-              <a:effectLst/>
-            </c:spPr>
-          </c:marker>
-          <c:cat>
-            <c:multiLvlStrRef>
-              <c:f>Sheet1!$A$2:$A$4</c:f>
-              <c:multiLvlStrCache>
-                <c:ptCount val="3"/>
-                <c:lvl>
-                  <c:pt idx="0">
-                    <c:v>2026-06</c:v>
+                  <c:pt idx="3">
+                    <c:v>2027-03</c:v>
                   </c:pt>
-                  <c:pt idx="1">
-                    <c:v>2026-09</c:v>
-                  </c:pt>
-                  <c:pt idx="2">
-                    <c:v>2026-12</c:v>
+                  <c:pt idx="4">
+                    <c:v>2027-06</c:v>
                   </c:pt>
                 </c:lvl>
               </c:multiLvlStrCache>
@@ -432,18 +342,24 @@
           </c:cat>
           <c:val>
             <c:numRef>
-              <c:f>Sheet1!$D$2:$D$4</c:f>
+              <c:f>Sheet1!$C$2:$C$6</c:f>
               <c:numCache>
                 <c:formatCode>0.00</c:formatCode>
-                <c:ptCount val="3"/>
+                <c:ptCount val="5"/>
                 <c:pt idx="0">
-                  <c:v>10.459656406599999</c:v>
+                  <c:v>9.2686062725</c:v>
                 </c:pt>
                 <c:pt idx="1">
-                  <c:v>3.5030793521</c:v>
+                  <c:v>0.8085502098999999</c:v>
                 </c:pt>
                 <c:pt idx="2">
-                  <c:v>10.9858274621</c:v>
+                  <c:v>5.1571669201</c:v>
+                </c:pt>
+                <c:pt idx="3">
+                  <c:v>2.9386289424000003</c:v>
+                </c:pt>
+                <c:pt idx="4">
+                  <c:v>-0.6776776606999999</c:v>
                 </c:pt>
               </c:numCache>
             </c:numRef>
@@ -1057,8 +973,8 @@
           <a:p>
             <a:r>
               <a:rPr lang="en-US" dirty="0"/>
-              <a:t>{"id":"ks_r_recommendation","title":"基准研究建议：主体与科顺转债BBB+，负面展望","question":"所选境内方法下，证据如何形成具体建议？","conclusion":"以信息截止日的公开证据和明示判断，基准建议主体及科顺转债为BBB+、负面展望。经营C、财务F4的指示单元格为a-/bbb+，选择bbb+；不计可证实的额外支持增益，普通无担保直接债项暂同级。建议以常态融资渠道仍运行、未证实到期不支付，且实际付款日前资金与用途安排足以覆盖为条件。母公司可调度资金和持续承诺后果未核实，不能作为无条件正式评级发布。","mechanism":"环境3.25 分、自身竞争力3.78 分，财务主方案4.17 分；先权金额为3.74 分仍属F4。选较弱端基于最新负EBITDA、母公司负经营现金、第四季回款依赖及资金用途约束；已进基础因素的弱项不重复扣档。","status":"conditional","evidence":["ks_r_e_business","ks_r_e_finance","ks_r_e_matrix","ks_a_ebitda_2025","ks_d_c_book_ratio"],"counterevidence":["ks_a_e_q1","ks_a_e_control"],"alternatives":["区间代表值和历史适配具有判断空间；可比三年数据或可靠前瞻可能改变档位。","无保留审计及季度盈利、银行新增借款支持持续经营，但不能单独排除现金或合同限制。"],"changes_if":"若更新事实使经营D、财务仍F4，研究分支为BB+；经营C而财务F5为BBB-；两者同时恶化为BB。若证实近期无法按约付款，立即退出上述常态分支，不能只保留负面展望。","figure_refs":["ks_r_environment_score","ks_r_competitive_score","ks_r_financial_score","ks_r_financial_score_alternative","ks_a_ebitda_2025","ks_d_c_book_ratio"]}
-{"id":"ks_r_liquidity","title":"季度现金压力决定跟踪顺序","question":"年末正现金是否掩盖更早缺口？","conclusion":"从三月末实际集团现金接续的无新增融资模型中，基准季度低点1.44 亿元人民币，恶化低点-3.38 亿元人民币；基准再少收4.88%客户现金即触及季度末零现金。基准另预留用途资金后低点-5.06 亿元人民币。这些是条件值，不能替代六月实际数或月内、母公司支付证明。","mechanism":"经营采购和票据结算在CFO内只扣一次；融资本金和现金利息另扣，未把非现金AP转借款再扣为现金。募集金恢复用途是现金限制敏感性，不是新增外部债本金。负数后续行只显示未融资缺口，晚收款不能抹去先前支付失败。","status":"conditional","evidence":["ks_d_l_e_cash_actual","ks_d_l_e_season","ks_r_base_cash_min","ks_r_worse_cash_min"],"counterevidence":["ks_a_e_q1","ks_a_e_maturity"],"alternatives":["银行续贷、资产变现或真实现金上划可能补足缺口，但须有可执行额度、条件和时点。","实际采购、建设支出或回款季节性可能不同于研究假设，需用实际付款台账替换。"],"changes_if":"若现金短缺由已落实融资或可合法延后支出覆盖，重跑现金表并判断是否足以维持BBB+；若缺口在已核实付款日仍存在，先确认具体偿付事件并重定主体及受影响债项。","figure_refs":["ks_r_base_cash_min","ks_r_worse_cash_min","ks_r_base_receipt_boundary","ks_r_base_reserve650"]}</a:t>
+              <a:t>{"id":"ks_r_recommendation","title":"条件研究建议：主体与科顺转债BBB+、负面；现金范围桥待核","question":"所选境内方法下，证据如何形成具体建议？","conclusion":"现金季节锚的范围桥尚未闭合；以下数字仅为Δ_A=Δ_H=Γ=0条件参照。以信息截止日的公开证据和明示判断，基准建议主体及科顺转债为BBB+、负面展望。经营C、财务F4的指示单元格为a-/bbb+，选择bbb+；不计可证实的额外支持增益，普通无担保直接债项暂同级。建议以常态融资渠道仍运行、未证实到期不支付，且实际付款日前资金与用途安排足以覆盖为条件。母公司可调度资金和持续承诺后果未核实，不能作为无条件正式评级发布。","mechanism":"环境3.25 分、自身竞争力3.78 分。年度同定义指标先30/70加权后分档的财务代表值3.74 分落F4；先权会计金额得3.74 分，本案档位相同。固定现有定性判断，量化档内合成范围从3.46 分（含）至4.01 分（不含），跨F5/F4，不能声称BBB+是唯一可推结果。C/F4选较弱端基于最新负EBITDA、母公司负经营现金、第四季回款依赖及用途约束；已进基础因素的弱项不重复扣档。 一年资金容量结果另见ks_horizon_find_horizon：未核还本和用途参数不能填零，融资截距不等于已落实来源。若付款日前所需发行人资源无法落实，建议的资金前提失效，须重新定级。 现金容量还须完成H1/年报版本桥及持续经营范围校正；原数字为Δ_H=Δ_A=0条件分支，不能充作已验证资金覆盖或据此固定评级。","status":"conditional","evidence":["ks_r_e_business","ks_r_e_finance","ks_r_e_matrix","ks_a_ebitda_2025","ks_d_c_book_ratio","ks_horizon_base_peak_funding_intercept_U650","ks_horizon_collection_delay_5pct_peak_funding_intercept_U650","ks_horizon_e_ar_scope","ks_horizon_e_decontrol_scope"],"counterevidence":["ks_a_e_q1","ks_a_e_control"],"alternatives":["本次量化档内下界已落F5；若有依据的择分或完整可比三年/前瞻证据支持F5，则按已列C/F5分支重评。中点代表值支持F4的研究建议，但不能以条件性文字代替缺失三年及定性判断的核验。","无保留审计及季度盈利、银行新增借款支持持续经营，但不能单独排除现金或合同限制。"],"changes_if":"若更新事实使经营D、财务仍F4，研究分支为BB+；经营C而财务F5为BBB-；两者同时恶化为BB。若证实近期无法按约付款，立即退出上述常态分支，不能只保留负面展望。 须先核实Δ_A、Δ_H及Γ并重跑全部时点和营运缓冲；零调整选点未证明实际资金覆盖，也不构成已证实现金必然更差。","figure_refs":["ks_r_environment_score","ks_r_competitive_score","ks_r_financial_score","ks_r_financial_score_alternative","ks_r_financial_lower","ks_r_financial_upper","ks_a_ebitda_2025","ks_d_c_book_ratio","ks_horizon_base_peak_funding_intercept_U650","ks_horizon_collection_delay_5pct_peak_funding_intercept_U650"]}
+{"id":"ks_r_liquidity","title":"季度现金压力决定跟踪顺序","question":"年末正现金是否掩盖更早缺口？","conclusion":"现金季节锚的范围桥尚未闭合；以下数字仅为Δ_A=Δ_H=Γ=0条件参照。从三月末实际集团现金接续的无新增融资模型中，基准季度低点1.44 亿元人民币，恶化低点-3.38 亿元人民币；基准再少收4.88%客户现金即触及季度末零现金。基准另预留用途资金后低点-5.06 亿元人民币。这些是条件值，不能替代六月实际数或月内、母公司支付证明。","mechanism":"经营采购和票据结算在CFO内只扣一次；融资本金和现金利息另扣，未把非现金AP转借款再扣为现金。募集金恢复用途是现金限制敏感性，不是新增外部债本金。负数后续行只显示未融资缺口，晚收款不能抹去先前支付失败。 2027-01-09用途恢复另有静态事件桥；一年展望的季节性延伸见ks_horizon_q_base及回款延期分支。它们单列未知D/X/P/U、营运缓冲及发行人资金条件，不与原用途预留叠扣，也不证明实际连续付款覆盖。","status":"conditional","evidence":["ks_d_l_e_cash_actual","ks_d_l_e_season","ks_r_base_cash_min","ks_r_worse_cash_min","ks_d_e_fund_new","ks_horizon_e_ar_scope","ks_horizon_e_decontrol_scope"],"counterevidence":["ks_a_e_q1","ks_a_e_maturity"],"alternatives":["银行续贷、资产变现或真实现金上划可能补足缺口，但须有可执行额度、条件和时点。","实际采购、建设支出或回款季节性可能不同于研究假设，需用实际付款台账替换。"],"changes_if":"若现金短缺由已落实融资或可合法延后支出覆盖，重跑现金表并判断是否足以维持BBB+；若缺口在已核实付款日仍存在，先确认具体偿付事件并重定主体及受影响债项。 须先核实Δ_A、Δ_H及Γ并重跑全部时点和营运缓冲；零调整选点未证明实际资金覆盖，也不构成已证实现金必然更差。","figure_refs":["ks_r_base_cash_min","ks_r_worse_cash_min","ks_r_base_receipt_boundary","ks_r_base_reserve650"]}</a:t>
             </a:r>
             <a:endParaRPr lang="en-US" dirty="0"/>
           </a:p>
@@ -1146,7 +1062,7 @@
           <a:p>
             <a:r>
               <a:rPr lang="en-US" dirty="0"/>
-              <a:t>{"id":"ks_r_followup","title":"展望与后续评级行动有明确决定边界","question":"哪些变化真正改变建议，而不只是更新比率？","conclusion":"负面展望反映未来约一年中的行业需求、回收、用途约束与融资压力。经营D/F4对应BB+，C/F5对应BBB-，D/F5对应BB；持续改善达到C/F3且资金及承诺问题解决时才讨论A分支。现有因子区间上确界跨F3本身不是升级证据。","mechanism":"跟踪先更新月度银行现金、实际用途占用、母公司到期表和持续承诺解释，再更新半年度/年度亏损、应收回收、订单及融资。三年完整重述和更可靠预测会改变加权依据；对应结果应重算而非沿用此次分数。没有设置后台监控、没有真实委员会投票。","status":"conditional","evidence":["ks_r_e_definitions","ks_r_e_matrix","ks_r_financial_lower","ks_r_financial_upper","ks_d_e_commitment"],"counterevidence":["ks_a_e_q1"],"alternatives":["季度业绩改善可使展望转稳，但需要完整期间现金而不只是利润。","正式解释若证明承诺无新增现金后果，会关闭该项不确定性，其他经营财务风险仍需重评。"],"changes_if":"按本研究截止日安排下一次检查于下一份实际半年度披露及任何提前到期、用途变更或支持事件；若已发生应立即反映的偿付问题，不等待下一年度或用展望推迟调整。","figure_refs":["ks_r_financial_lower","ks_r_financial_upper"]}
+              <a:t>{"id":"ks_r_followup","title":"展望与后续评级行动有明确决定边界","question":"哪些变化真正改变建议，而不只是更新比率？","conclusion":"负面展望反映未来约一年中的行业需求、回收、用途约束与融资压力。经营D/F4对应BB+，C/F5对应BBB-，D/F5对应BB；持续改善达到C/F3且资金及承诺问题解决时才讨论A分支。当前固定定性判断的量化档内范围跨F5/F4，已显示下行择分敏感性；没有由本次区间上端支持F3。","mechanism":"跟踪先更新月度银行现金、实际用途占用、母公司到期表和持续承诺解释，再更新半年度/年度亏损、应收回收、订单及融资。三年完整重述和更可靠预测会改变加权依据；对应结果应重算而非沿用此次分数。没有设置后台监控、没有真实委员会投票。 临时补流按2027-01-09十二个月边界及更早项目需要核查；延伸至2027年6月的条件资金容量须代入实际还本、其他净用途、项目耗用和用途占用，再检验发行人可调度资金及可落实融资。","status":"conditional","evidence":["ks_r_e_definitions","ks_r_e_matrix","ks_r_financial_lower","ks_r_financial_upper","ks_d_e_commitment","ks_d_e_fund_new","ks_project_e_schedule"],"counterevidence":["ks_a_e_q1"],"alternatives":["季度业绩改善可使展望转稳，但需要完整期间现金而不只是利润。","正式解释若证明承诺无新增现金后果，会关闭该项不确定性，其他经营财务风险仍需重评。"],"changes_if":"按本研究截止日安排下一次检查于下一份实际半年度披露及任何提前到期、用途变更或支持事件；若已发生应立即反映的偿付问题，不等待下一年度或用展望推迟调整。","figure_refs":["ks_r_financial_lower","ks_r_financial_upper"]}
 {"id":"ks_r_rating_chain"}</a:t>
             </a:r>
             <a:endParaRPr lang="en-US" dirty="0"/>
@@ -1235,9 +1151,9 @@
           <a:p>
             <a:r>
               <a:rPr lang="en-US" dirty="0"/>
-              <a:t>{"id":"ks_r_recommendation","title":"基准研究建议：主体与科顺转债BBB+，负面展望","question":"所选境内方法下，证据如何形成具体建议？","conclusion":"以信息截止日的公开证据和明示判断，基准建议主体及科顺转债为BBB+、负面展望。经营C、财务F4的指示单元格为a-/bbb+，选择bbb+；不计可证实的额外支持增益，普通无担保直接债项暂同级。建议以常态融资渠道仍运行、未证实到期不支付，且实际付款日前资金与用途安排足以覆盖为条件。母公司可调度资金和持续承诺后果未核实，不能作为无条件正式评级发布。","mechanism":"环境3.25 分、自身竞争力3.78 分，财务主方案4.17 分；先权金额为3.74 分仍属F4。选较弱端基于最新负EBITDA、母公司负经营现金、第四季回款依赖及资金用途约束；已进基础因素的弱项不重复扣档。","status":"conditional","evidence":["ks_r_e_business","ks_r_e_finance","ks_r_e_matrix","ks_a_ebitda_2025","ks_d_c_book_ratio"],"counterevidence":["ks_a_e_q1","ks_a_e_control"],"alternatives":["区间代表值和历史适配具有判断空间；可比三年数据或可靠前瞻可能改变档位。","无保留审计及季度盈利、银行新增借款支持持续经营，但不能单独排除现金或合同限制。"],"changes_if":"若更新事实使经营D、财务仍F4，研究分支为BB+；经营C而财务F5为BBB-；两者同时恶化为BB。若证实近期无法按约付款，立即退出上述常态分支，不能只保留负面展望。","figure_refs":["ks_r_environment_score","ks_r_competitive_score","ks_r_financial_score","ks_r_financial_score_alternative","ks_a_ebitda_2025","ks_d_c_book_ratio"]}
+              <a:t>{"id":"ks_r_recommendation","title":"条件研究建议：主体与科顺转债BBB+、负面；现金范围桥待核","question":"所选境内方法下，证据如何形成具体建议？","conclusion":"现金季节锚的范围桥尚未闭合；以下数字仅为Δ_A=Δ_H=Γ=0条件参照。以信息截止日的公开证据和明示判断，基准建议主体及科顺转债为BBB+、负面展望。经营C、财务F4的指示单元格为a-/bbb+，选择bbb+；不计可证实的额外支持增益，普通无担保直接债项暂同级。建议以常态融资渠道仍运行、未证实到期不支付，且实际付款日前资金与用途安排足以覆盖为条件。母公司可调度资金和持续承诺后果未核实，不能作为无条件正式评级发布。","mechanism":"环境3.25 分、自身竞争力3.78 分。年度同定义指标先30/70加权后分档的财务代表值3.74 分落F4；先权会计金额得3.74 分，本案档位相同。固定现有定性判断，量化档内合成范围从3.46 分（含）至4.01 分（不含），跨F5/F4，不能声称BBB+是唯一可推结果。C/F4选较弱端基于最新负EBITDA、母公司负经营现金、第四季回款依赖及用途约束；已进基础因素的弱项不重复扣档。 一年资金容量结果另见ks_horizon_find_horizon：未核还本和用途参数不能填零，融资截距不等于已落实来源。若付款日前所需发行人资源无法落实，建议的资金前提失效，须重新定级。 现金容量还须完成H1/年报版本桥及持续经营范围校正；原数字为Δ_H=Δ_A=0条件分支，不能充作已验证资金覆盖或据此固定评级。","status":"conditional","evidence":["ks_r_e_business","ks_r_e_finance","ks_r_e_matrix","ks_a_ebitda_2025","ks_d_c_book_ratio","ks_horizon_base_peak_funding_intercept_U650","ks_horizon_collection_delay_5pct_peak_funding_intercept_U650","ks_horizon_e_ar_scope","ks_horizon_e_decontrol_scope"],"counterevidence":["ks_a_e_q1","ks_a_e_control"],"alternatives":["本次量化档内下界已落F5；若有依据的择分或完整可比三年/前瞻证据支持F5，则按已列C/F5分支重评。中点代表值支持F4的研究建议，但不能以条件性文字代替缺失三年及定性判断的核验。","无保留审计及季度盈利、银行新增借款支持持续经营，但不能单独排除现金或合同限制。"],"changes_if":"若更新事实使经营D、财务仍F4，研究分支为BB+；经营C而财务F5为BBB-；两者同时恶化为BB。若证实近期无法按约付款，立即退出上述常态分支，不能只保留负面展望。 须先核实Δ_A、Δ_H及Γ并重跑全部时点和营运缓冲；零调整选点未证明实际资金覆盖，也不构成已证实现金必然更差。","figure_refs":["ks_r_environment_score","ks_r_competitive_score","ks_r_financial_score","ks_r_financial_score_alternative","ks_r_financial_lower","ks_r_financial_upper","ks_a_ebitda_2025","ks_d_c_book_ratio","ks_horizon_base_peak_funding_intercept_U650","ks_horizon_collection_delay_5pct_peak_funding_intercept_U650"]}
 {"id":"ks_r_support_assessment","title":"外部支持：不计未经证实的评级增益","question":"哪些支持能力与意愿证据能够改变独立信用？","conclusion":"基准不计额外支持增益。自然人控制及对特定银行义务的保证未证明本债或全部偿债需要有及时支持；普通政府补助未证明困难时救助。该选择是现有证据下的研究处理，不是“民企无支持”或未来不会支持的事实判断。","mechanism":"政府路径分别核持股/控制、地方重要性、违约声誉影响、成本收益和支持历史：已知自然人控制、可替代竞争及普通补助，未识别具体救助方、独立财力及承诺。企业法人股东分支不能机械套自然人；个人保证有具体对象和财力限制。支持可能性不能与能力分开，也不能把多项潜在支持累加。","status":"conditional","evidence":["ks_r_e_support","ks_b_e_ownership","ks_a_e_related"],"counterevidence":["ks_a_e_related","ks_a_e_post"],"alternatives":["地方就业、技术或项目重要性可能增加协助意愿，但需具体规模和可执行资金支持。","股东可投入资金，但股权质押、已有保证和未核个人资源使支持额度未定。"],"changes_if":"取得具体支持方独立偿债能力、合法决策、覆盖义务、付款触发及到账时间，再按同一支持方法重做提升；不把普通授信或既有补助重新加成一档。","figure_refs":[]}
-{"id":"ks_r_adjustments","title":"个体调整逐项判断及不重复计入","question":"基础因子之外是否还有改变结果的增量事项？","conclusion":"未来投资及基金承诺、ESG、表外义务、信用记录与其他事项逐项保留。当前研究不在已反映的亏损、资产质量和治理弱项之外再机械扣档；持续承诺的具体后果和用途恢复若形成新增近期现金需要，基准评级条件即失效，必须重新分析。","mechanism":"项目延期和基金调用影响前瞻资本需求；污染/事故、劳工质量披露只代表公司声明和制度，未有监管数据证明风险不重大。担保需与基础债务去重，实际代偿须计入现金。已知付息并不证明所有借款/贸易义务正常；原件两项小额/项目差异需核原因，不能自动转成舞弊分。","status":"conditional","evidence":["ks_r_e_matrix","ks_a_e_related","ks_a_e_governance","ks_a_e_fixed","ks_b_e_fund","ks_d_e_commitment"],"counterevidence":["ks_a_e_audit","ks_a_e_control"],"alternatives":["整改、投资收缩或真实回款改善可以减轻增量风险，但只有实施证据才能纳入。","新的监管处罚、质量赔偿或已到期代偿可能同时削弱现金与融资渠道，不能只在治理文字中描述。"],"changes_if":"新事实先量化对现金、资产和基础因素的影响，再识别未被反映的增量风险；若需个体档差，说明具体传导及不重复计入依据。不能把所有未知事项直接当中性已核实。","figure_refs":[]}</a:t>
+{"id":"ks_r_adjustments","title":"个体调整逐项判断及不重复计入","question":"基础因子之外是否还有改变结果的增量事项？","conclusion":"未来投资及基金承诺、ESG、表外义务、信用记录与其他事项逐项保留。当前研究不在已反映的亏损、资产质量和治理弱项之外再机械扣档；持续承诺的具体后果和用途恢复若形成未覆盖的近期付款或不可调度约束，基准评级条件即失效，必须重新分析。","mechanism":"项目延期和基金调用影响前瞻资本需求；污染/事故、劳工质量披露只代表公司声明和制度，未有监管数据证明风险不重大。担保需与基础债务去重，实际代偿须计入现金。已知付息并不证明所有借款/贸易义务正常；原件两项小额/项目差异需核原因，不能自动转成舞弊分。","status":"conditional","evidence":["ks_r_e_matrix","ks_a_e_related","ks_a_e_governance","ks_a_e_fixed","ks_b_e_fund","ks_d_e_commitment"],"counterevidence":["ks_a_e_audit","ks_a_e_control"],"alternatives":["整改、投资收缩或真实回款改善可以减轻增量风险，但只有实施证据才能纳入。","新的监管处罚、质量赔偿或已到期代偿可能同时削弱现金与融资渠道，不能只在治理文字中描述。"],"changes_if":"新事实先量化对现金、资产和基础因素的影响，再识别未被反映的增量风险；若需个体档差，说明具体传导及不重复计入依据。不能把所有未知事项直接当中性已核实。","figure_refs":[]}</a:t>
             </a:r>
             <a:endParaRPr lang="en-US" dirty="0"/>
           </a:p>
@@ -1503,7 +1419,7 @@
           <a:p>
             <a:r>
               <a:rPr lang="en-US" dirty="0"/>
-              <a:t>{"id":"ks_a_find_cfo","title":"现金质量、季节性及分红","question":"正经营现金能覆盖投入和分配吗？","conclusion":"全年CFO3.20 亿元人民币，扣现金资本开支后1.47 亿元人民币，再扣已分红后-2.41 亿元人民币。末季贡献11.44 亿元人民币，期间现金波动明显。","mechanism":"间接桥中大额非现金减值并不产生现金；供应商负债和押金等融资作用支撑现金，全年正值不能掩盖前三季流出和融资依赖。","status":"supported","evidence":["ks_a_e_cf","ks_a_e_indirect","ks_a_e_summary","ks_a_e_equity","ks_a_indirect_cfo_2025"],"counterevidence":[],"alternatives":["利润至经营现金的改善可能由非现金信用损失加回形成，不能把加回项目视为经营盈利恢复。","应收净额下降也可能由核销和抵债形成；年末集中收款与下一季现金流出并存时，全年正经营现金不能证明期内无缺口。"],"changes_if":"取得按客户的季度及月度银行收现、非现金重组和供应商付款桥，并证明现金覆盖利息、必要资本投入和分红后仍有余量，才提高现金生成质量判断。","figure_refs":["ks_a_cfo_2025","ks_a_fcf_2025","ks_a_fcf_after_div","ks_a_quarter4_cfo","ks_a_indirect_cfo_2025"]}
+              <a:t>{"id":"ks_a_find_cfo","title":"现金质量、季节性及分红","question":"正经营现金能覆盖投入和分配吗？","conclusion":"全年CFO3.20 亿元人民币，扣现金资本开支后1.47 亿元人民币，再扣已分红后-2.41 亿元人民币。末季贡献11.44 亿元人民币，期间现金波动明显。","mechanism":"间接桥中大额非现金减值并不产生现金；经营性应付项目合计形成正向调节，但其贡献同比减少。尚未取得组成、结算、非现金及范围变动的分解，不能将该合计或保证金收付直接归因为供应商融资或客户押金提供现金。全年正值仍须结合前三季流出和融资依赖判断。","status":"supported","evidence":["ks_a_e_cf","ks_a_e_indirect","ks_a_e_summary","ks_a_e_equity","ks_a_indirect_cfo_2025"],"counterevidence":[],"alternatives":["利润至经营现金的改善可能由非现金信用损失加回形成，不能把加回项目视为经营盈利恢复。","应收净额下降也可能由核销和抵债形成；年末集中收款与下一季现金流出并存时，全年正经营现金不能证明期内无缺口。"],"changes_if":"取得按客户的季度及月度银行收现、非现金重组和供应商付款桥，并证明现金覆盖利息、必要资本投入和分红后仍有余量，才提高现金生成质量判断。","figure_refs":["ks_a_cfo_2025","ks_a_fcf_2025","ks_a_fcf_after_div","ks_a_quarter4_cfo","ks_a_indirect_cfo_2025"]}
 {"id":"ks_a_find_q1","title":"期后季度改善与年度约束","question":"年度弱项是否在研究截止日前消除？","conclusion":"未经审计Q1归母利润6,355.24 万元人民币、毛利率27.51%，CFO仍-5,518.29 万元人民币。季度现金年初桥闭合；信用减值继续且缺完整债务及受限现金附注，不按一季乘四替换全年。","mechanism":"季节性、原材料预付、银行长短债置换和年度末集中减值会令季度盈利与全年偿债能力不同；部分上年季度比较仍是原披露范围。解释19号实施未披露重大影响。","status":"conditional","evidence":["ks_a_e_q1","ks_a_e_policy26","ks_a_q1_cashbridge","ks_a_missing_q1_debt","ks_a_missing_q1_freecash"],"counterevidence":[],"alternatives":["季节性收付款和提前采购可以使季度利润与经营现金方向不同；不能直接把改善同比推广至全年。","季度表尚缺完整利息、受限现金和同控可比明细，短期借款增加也可能是期限置换而非净融资能力增强。"],"changes_if":"取得半年度完整附注后，用原年度及一季度桥拆出季节性、范围、应收回款与新债；持续现金改善且债务到期与资金用途匹配才支持提高判断。","figure_refs":["ks_a_q1_parentincome","ks_a_q1_gm","ks_a_q1_cfo","ks_a_q1_cashbridge","ks_a_missing_q1_debt","ks_a_missing_q1_freecash"]}
 {"id":"ks_a_e_indirect","source":"ks_a_s_25","locator":"第208—209页，净利润调节为CFO，单位元","observation":"净利加减非现金损益、递延税、营运资本及其他；经营性应收项目调整为现金流流出，不可由BS净应收下降反推相反符号。","reliability":"发行人正式披露；财务报表经审计，但本分析未复做审计程序"}</a:t>
             </a:r>
@@ -1593,7 +1509,8 @@
           <a:p>
             <a:r>
               <a:rPr lang="en-US" dirty="0"/>
-              <a:t>{"id":"ks_r_liquidity","title":"季度现金压力决定跟踪顺序","question":"年末正现金是否掩盖更早缺口？","conclusion":"从三月末实际集团现金接续的无新增融资模型中，基准季度低点1.44 亿元人民币，恶化低点-3.38 亿元人民币；基准再少收4.88%客户现金即触及季度末零现金。基准另预留用途资金后低点-5.06 亿元人民币。这些是条件值，不能替代六月实际数或月内、母公司支付证明。","mechanism":"经营采购和票据结算在CFO内只扣一次；融资本金和现金利息另扣，未把非现金AP转借款再扣为现金。募集金恢复用途是现金限制敏感性，不是新增外部债本金。负数后续行只显示未融资缺口，晚收款不能抹去先前支付失败。","status":"conditional","evidence":["ks_d_l_e_cash_actual","ks_d_l_e_season","ks_r_base_cash_min","ks_r_worse_cash_min"],"counterevidence":["ks_a_e_q1","ks_a_e_maturity"],"alternatives":["银行续贷、资产变现或真实现金上划可能补足缺口，但须有可执行额度、条件和时点。","实际采购、建设支出或回款季节性可能不同于研究假设，需用实际付款台账替换。"],"changes_if":"若现金短缺由已落实融资或可合法延后支出覆盖，重跑现金表并判断是否足以维持BBB+；若缺口在已核实付款日仍存在，先确认具体偿付事件并重定主体及受影响债项。","figure_refs":["ks_r_base_cash_min","ks_r_worse_cash_min","ks_r_base_receipt_boundary","ks_r_base_reserve650"]}</a:t>
+              <a:t>{"id":"ks_horizon_find_horizon","title":"一年展望须跨过2027年1月恢复用途及上半年营运低谷","question":"2026末正现金能否证明一年展望付款覆盖？","conclusion":"现金季节锚的范围桥尚未闭合；以下数字仅为Δ_A=Δ_H=Γ=0条件参照。不能。在未扣未知2027到期本金及其他净支出前，基准2027六月末集团资金池仅2.73 亿元人民币。恢复6.5亿元用途并保留15日经营缓冲时，累计融资需求截距为6.89 亿元人民币；实际融资需求须代入D、X、P及实际占用U重算，不能称该截距为已证实缺口。","mechanism":"年末回款后的上半年经营消耗、资本开支、利息和用途隔离继续占用资源。Q1复制最近同季原表；Q2毛分项仍缺同控桥，所列金额只在Δ_H=0时成立。Δ_A同时影响承接的2026年末余额。实际融资需求在范围调整及D/X/P/U未代入前为null。","status":"conditional","evidence":["ks_horizon_e_h125","ks_horizon_e_q125","ks_a_e_q1","ks_a_e_ar","ks_d_e_fund_new","ks_horizon_e_ar_scope","ks_horizon_e_decontrol_scope"],"counterevidence":["ks_a_e_q1"],"alternatives":["融资承诺落实、回款提前或可证明项目专户资金按用途支付可改善容量；必须按到款日及用途逐笔确认。"],"changes_if":"取得Δ_H、Δ_A及持续经营范围桥、真实D/X/P/U和逐日预算后按同一公式更新；未取得前不能据旧数值证明评级资金前提。若任一付款日已核实资源不足且无已落实来源，原BBB+/负面的付款覆盖前提失效。 须先核实Δ_A、Δ_H及Γ并重跑全部时点和营运缓冲；零调整选点未证明实际资金覆盖，也不构成已证实现金必然更差。","figure_refs":["ks_horizon_base_end_group_pool_before_unknown_DX","ks_horizon_base_peak_funding_intercept_U650"]}
+{"id":"ks_horizon_find_stress","title":"真实回款压力经现金和融资需要进入信用变化条件","question":"除因素分值变动外，业务压力如何影响建议？","conclusion":"现金季节锚的范围桥尚未闭合；以下数字仅为Δ_A=Δ_H=Γ=0条件参照。账龄拉长和房地产工程旧款风险支持测试收款继续延后；将预计销售收款的5%延至2027-06-30后且窗内不追收，使2026全年条件CFO从396253333.07元降至209386514.78元，并提高延伸期资金缺口。此为时点敏感性，不是5%违约概率、永久坏账或利润预测。","mechanism":"历史应收风险→预计销售收款延期→CFO下降→用途恢复后营运容量缩小→付款日前新融资需求增加；贷款若取得，其新利息和本金必须反馈进下一期现金路径。 未闭合的范围调整同时改变预计毛收款、付款和压力金额；先按版本桥重算，不能用净CFO相同消去毛额调整。 净额约束下不同毛收付折减系数仍产生现金影响；实际延期金额随调整后的客户收款重算，当前压力额不是同口径已验证金额。","status":"conditional","evidence":["ks_horizon_e_h125","ks_horizon_e_q125","ks_a_e_q1","ks_a_e_ar","ks_d_e_fund_new","ks_horizon_e_ar_scope","ks_horizon_e_decontrol_scope"],"counterevidence":["ks_a_e_q1"],"alternatives":["在同一有证据业务链上，延期收款先降低CFO及自由现金容量，再增加必须在付款日前取得的新融资；不得只将定性分数调低半分。","如果所需资金由无条件可提取授信或合法上划实际落实，并持续满足U、M和逐笔债务，支持原BBB+/负面条件建议继续作为研究分支；不构成上调证据。","如缺口不能由届时确定可得来源覆盖，或临时补流到期恢复用途挤占必要经营付款，原建议的付款覆盖前提失效，需就流动性重大弱化作个体调整/重评；若证实无法按期付款，退出常态矩阵，不用负面展望代替支付风险判断。","本压力是收款时点风险，不自动降低EBITDA或提高违约损失；补融资若以债务取得，后续利息和本金会继续压缩容量。只有新的全年可比盈利、资本及现金短债输入重算支持F5时，才进入原C/F5→BBB-分支；季度CFO不能直接映射F5。"],"changes_if":"持续恢复回款并证明付款覆盖可支持稳定展望的进一步研究；付款覆盖前提失败须重评。没有完整全年损益及债务预测，不从半年CFO或模型分数的任意±0.5直接推出评级级差。 须先核实Δ_A、Δ_H及Γ并重跑全部时点和营运缓冲；零调整选点未证明实际资金覆盖，也不构成已证实现金必然更差。","figure_refs":[]}</a:t>
             </a:r>
             <a:endParaRPr lang="en-US" dirty="0"/>
           </a:p>
@@ -1682,7 +1599,8 @@
             <a:r>
               <a:rPr lang="en-US" dirty="0"/>
               <a:t>{"id":"ks_d_n_funds","title":"补流归还恢复专款用途，不新增转债本金","question":"募集资金占用和归还如何影响流动性，如何避免与本金双计？","conclusion":"年末尚未使用募集资金 13.61 亿元人民币 中，12.75 亿元人民币 已暂用于补流，专户余额为 8,643.12 万元人民币。旧一期实际使用的 13.00 亿元人民币 已于2026-01-06前归还；新一期2026-01-09批准上限 13.00 亿元人民币，实际截止日占用尚未确定。归还募集专户是恢复资金用途约束，不是新增对外金融债偿还，不能再加到转债本金上。","mechanism":"新一期从批准日起至多十二个月、项目需用时须提前归还，按日期推得最长至2027-01-09。实际占用若被营运资金锁定，会产生调回可用资金的压力；集团内部账户转移本身不减少合并现金，但会减少可自由用于一般偿债的资金。批准额度不能替代实际用款和归还流水。","status":"conditional","evidence":["ks_d_e_fund_balance","ks_d_c_fund_balance_parts","ks_d_c_fund_balance_receipts","ks_d_e_fund_return","ks_d_e_fund_new","ks_d_f_fund_temp_cutoff"],"counterevidence":["ks_d_e_fund_correction","ks_d_e_fund_delay","ks_d_e_sponsor_performance"],"alternatives":["若新一期实际支用低于批准额度，潜在需调回金额相应较低；不能预填最大额度为实际债务。","若可及时收回营运资金并恢复专户，用途恢复压力较小；这不代表资金可不受限制用于付本息。"],"changes_if":"取得截止日及到期前专户/一般户对账、逐笔支用归还、项目支付计划和资金可调回证据后量化用途恢复缺口；清除旧一期占用不能自动证明新一期占用为零。","figure_refs":["ks_d_f_fund_total","ks_d_f_fund_temp_2025","ks_d_f_fund_special_2025","ks_d_f_fund_returned","ks_d_f_fund_new_cap","ks_d_c_fund_balance_parts","ks_d_c_fund_balance_receipts","ks_d_f_fund_temp_cutoff"]}
-{"id":"ks_r_liquidity","title":"季度现金压力决定跟踪顺序","question":"年末正现金是否掩盖更早缺口？","conclusion":"从三月末实际集团现金接续的无新增融资模型中，基准季度低点1.44 亿元人民币，恶化低点-3.38 亿元人民币；基准再少收4.88%客户现金即触及季度末零现金。基准另预留用途资金后低点-5.06 亿元人民币。这些是条件值，不能替代六月实际数或月内、母公司支付证明。","mechanism":"经营采购和票据结算在CFO内只扣一次；融资本金和现金利息另扣，未把非现金AP转借款再扣为现金。募集金恢复用途是现金限制敏感性，不是新增外部债本金。负数后续行只显示未融资缺口，晚收款不能抹去先前支付失败。","status":"conditional","evidence":["ks_d_l_e_cash_actual","ks_d_l_e_season","ks_r_base_cash_min","ks_r_worse_cash_min"],"counterevidence":["ks_a_e_q1","ks_a_e_maturity"],"alternatives":["银行续贷、资产变现或真实现金上划可能补足缺口，但须有可执行额度、条件和时点。","实际采购、建设支出或回款季节性可能不同于研究假设，需用实际付款台账替换。"],"changes_if":"若现金短缺由已落实融资或可合法延后支出覆盖，重跑现金表并判断是否足以维持BBB+；若缺口在已核实付款日仍存在，先确认具体偿付事件并重定主体及受影响债项。","figure_refs":["ks_r_base_cash_min","ks_r_worse_cash_min","ks_r_base_receipt_boundary","ks_r_base_reserve650"]}</a:t>
+{"id":"ks_project_n_restore_event","title":"年度模型之后还有临时补流恢复用途的事件边界","question":"2026年末条件正现金能否证明下一次用途恢复已经覆盖？","conclusion":"现金季节锚的范围桥尚未闭合；以下数字仅为Δ_A=Δ_H=Γ=0条件参照。2026-006要求自2026-01-09批准日起不超过12个月并随项目需要提前归还。按2027-01-09的12个月边界核查，若沿用2026末基准集团现金且九日净变动、调度扣减、其他到期付款及营运底额均为零，可恢复用途的静态容量参照为7.03 亿元人民币；恢复650百万元后余5,258.35 万元人民币，按授权全额恢复则需额外资源5.97 亿元人民币。实际占用未知，以上不代表届时真实缺口或连续12个月已覆盖。","mechanism":"恢复专户先减少可自由使用资金，并不必然减少集团总现金或偿还一笔外部债务。项目付款、预留及归还记录按同一资金流去重；不能将本事件再叠加到已扣的6.5/13亿元用途预留。须将年末条件集团现金桥接到归还义务主体在事件日可调度金额，加减九日有证据收支及其他支付，不能把合并余额当母公司已到手资金。","status":"conditional","evidence":["ks_d_e_fund_new","ks_d_e_fund_return","ks_r_base_cash_end","ks_project_g_restore_max","ks_project_g_restore_cap_gap"],"counterevidence":["ks_d_e_fund_return","ks_a_e_q1"],"alternatives":["实际占用低于授权上限、已在年末归还或有可执行九日净流入，均可能关闭该事件的资源差额。","项目提前要求资金、九日其他支出或子公司现金无法上划，会把有效边界提前或降低上限；不得以未证实的下一轮补流授权弥补。"],"changes_if":"先取得实际占用和归还期限/需求、发行人可调度额及九日来源用途。当时需要恢复用途额超过经核实可调度额且无按时落实的合法安排时，重做近端流动性与承诺后果判断；不能只看年末正余额维持原判断，也不能直接把用途恢复缺口认定为债券已违约。 须先核实Δ_A、Δ_H及Γ并重跑全部时点和营运缓冲；零调整选点未证明实际资金覆盖，也不构成已证实现金必然更差。","figure_refs":["ks_project_g_restore_max","ks_project_g_restore650_after","ks_project_g_restore_cap_gap","ks_r_base_cash_end"]}
+{"id":"ks_horizon_find_horizon","title":"一年展望须跨过2027年1月恢复用途及上半年营运低谷","question":"2026末正现金能否证明一年展望付款覆盖？","conclusion":"现金季节锚的范围桥尚未闭合；以下数字仅为Δ_A=Δ_H=Γ=0条件参照。不能。在未扣未知2027到期本金及其他净支出前，基准2027六月末集团资金池仅2.73 亿元人民币。恢复6.5亿元用途并保留15日经营缓冲时，累计融资需求截距为6.89 亿元人民币；实际融资需求须代入D、X、P及实际占用U重算，不能称该截距为已证实缺口。","mechanism":"年末回款后的上半年经营消耗、资本开支、利息和用途隔离继续占用资源。Q1复制最近同季原表；Q2毛分项仍缺同控桥，所列金额只在Δ_H=0时成立。Δ_A同时影响承接的2026年末余额。实际融资需求在范围调整及D/X/P/U未代入前为null。","status":"conditional","evidence":["ks_horizon_e_h125","ks_horizon_e_q125","ks_a_e_q1","ks_a_e_ar","ks_d_e_fund_new","ks_horizon_e_ar_scope","ks_horizon_e_decontrol_scope"],"counterevidence":["ks_a_e_q1"],"alternatives":["融资承诺落实、回款提前或可证明项目专户资金按用途支付可改善容量；必须按到款日及用途逐笔确认。"],"changes_if":"取得Δ_H、Δ_A及持续经营范围桥、真实D/X/P/U和逐日预算后按同一公式更新；未取得前不能据旧数值证明评级资金前提。若任一付款日已核实资源不足且无已落实来源，原BBB+/负面的付款覆盖前提失效。 须先核实Δ_A、Δ_H及Γ并重跑全部时点和营运缓冲；零调整选点未证明实际资金覆盖，也不构成已证实现金必然更差。","figure_refs":["ks_horizon_base_end_group_pool_before_unknown_DX","ks_horizon_base_peak_funding_intercept_U650"]}</a:t>
             </a:r>
             <a:endParaRPr lang="en-US" dirty="0"/>
           </a:p>
@@ -1772,7 +1690,9 @@
               <a:rPr lang="en-US" dirty="0"/>
               <a:t>{"id":"ks_r_parent_risk","title":"集团资源不能直接当作发行人已到手现金","question":"母公司怎样实际取得偿债资源？","conclusion":"母公司年末现金减短借及一年内非流动账面代理后余量1.05 亿元人民币，不能证明完整短期覆盖；与固定本金未来到期价的静态差额为-12.24 亿元人民币。后者说明未来需产现、上划或融资的量级，并非债券在本年到期或已经发生缺口。缺一季末母公司表，集团一季现金不替代。","mechanism":"发行人自身经营现金为负，投资收益现金不等于每年可重复的全部子公司分红。集团内票据及往来在合并层抵销，但现金移转仍依赖对手现金、合法决策、少数股东权益、融资约束和实际到账。","status":"conditional","evidence":["ks_a_e_parent","ks_r_parent_screen","ks_r_parent_maturity_gap"],"counterevidence":["ks_d_l_f_parent_investment_cash","ks_a_e_equity"],"alternatives":["子公司分红或往来回收能改善母公司资金，但不能按合并余额自动推算。","债券未来转换可能降低现金本金，须等真实转股事实确认，不能预先免偿。"],"changes_if":"取得主要子公司的可分配现金、债务和用途限制、上划决议及实际到账后，重建发行人月度来源用途；若可上划路径受阻且本部不足，主体与直接债项结论须同步下调。","figure_refs":["ks_r_parent_screen","ks_r_parent_maturity_gap"]}
 {"id":"ks_d_e_issue_coupon","source":"ks_d_s_m1","locator":"PDF p39–40，发行规模、期限、票面利率、还本付息条款","observation":"募集书发行规模上限219800.00万元，每张100元；债券期限2023-08-04至2029-08-03。六个计息年度票息依次为0.30%、0.50%、1.00%、1.50%、1.80%、2.00%；每满一年为付息日，节假日或休息日顺延且不另计息，登记日为付息日前一交易日，付息日后五个交易日内支付。登记日前及当日申请转股不再享有本年度及以后利息。","reliability":"官方原件正文；报告披露不等同于本次独立审计或法律鉴证。"}
-{"id":"ks_d_e_maturity_call","source":"ks_d_s_m1","locator":"PDF p43，赎回条款","observation":"到期后五个交易日内按票面面值115%赎回未转股债券，含最后一期利息。转股期内连续三十个交易日至少十五日收盘价不低于当期转股价130%，或未转股余额不足3000万元，发行人可按面值加应计利息赎回。","reliability":"官方原件正文；报告披露不等同于本次独立审计或法律鉴证。"}</a:t>
+{"id":"ks_d_e_maturity_call","source":"ks_d_s_m1","locator":"PDF p43，赎回条款","observation":"到期后五个交易日内按票面面值115%赎回未转股债券，含最后一期利息。转股期内连续三十个交易日至少十五日收盘价不低于当期转股价130%，或未转股余额不足3000万元，发行人可按面值加应计利息赎回。","reliability":"官方原件正文；报告披露不等同于本次独立审计或法律鉴证。"}
+{"id":"ks_project_n_model","title":"旧项目末年测算不足以证明最终合同的偿债覆盖","question":"募集说明书项目测算是否仍能构成可用偿债来源？","conclusion":"正式合同115%已进入现有现金时间表，无需追加债务。原项目T+6测算采用104%比较额，且其中79.48%税前净现金来自固定资产余值和流动资金终期回收；扣除此两项后的原模型余额5.02 亿元人民币不是标准经营现金流。该历史项目预测不能直接列作截止日已落实的母公司偿债资金。","mechanism":"同份文件第14/67页旧预测与第43页最终条款并列。按旧表满额面值重新套用115%会改变旧表覆盖结论，但既有2026—2029需求已用115%，不再追加差额。项目末年强行变现还需税费、权属/抵押与债权顺位、出售成交和营运资金净回收日期；清算回收不能与同一资产继续经营的现金流重复计算。原表是税前、项目层及T+6相对期间，不能跳过公司层及付款日的桥。","status":"supported","evidence":["ks_project_e_old_model","ks_d_e_maturity_call","ks_project_c_terminal_share","ks_project_c_corrected_old_gap","ks_d_g_cash_2029"],"counterevidence":["ks_d_e_general_performance","ks_a_e_q1"],"alternatives":["原104%可能是募集方案定价前的示意测算沿用，现有资料不足以判断原因、修订义务或主观意图；正式合同支付价格仍按115%。","此前留存项目现金、其他业务产现、可执行融资或真实转股均可能改变发行人总体覆盖；不能把旧末年单表差额等同集团资金缺口，也不能先假定这些资源已到账。"],"changes_if":"取得与最终条款、实际工程节点和截至信息日经营假设一致的逐月税后项目及发行人来源用途表，完成净可变现及资金上划桥后才纳入偿债来源。若旧预测从未进入现有量化来源，移除其信用论据不改变现有现金数值或机械改变档位。","figure_refs":["ks_project_c_terminal_share","ks_project_c_without_terminal","ks_project_c_corrected_old_gap","ks_d_g_cash_2029"]}
+{"id":"ks_project_n_timing","title":"项目延期压缩偿债前的投产回收窗口，临时补流归还须单独排期","question":"投入进度如何传导至未来支付及评级条件？","conclusion":"2025末四项建设升级的累计募集投入比例12.63%；未投入计划额度13.34 亿元人民币不是即期负债。四项预定可使用日均延至2028-12-31，与2029-08-03合同到期相隔215个自然日；可使用不等于满产、收款或已获处置价。2026-01-09新一期临时补流批准不超过12个月且项目需要时提前归还，不能因项目延期而把该用途义务推迟至2028年。","mechanism":"需求较弱→放慢投资可减少近期资本支出，却可能使新产能经营回款晚于债项支付；建设计划恢复→先需资金及营运周转→需将暂时补流从一般经营资金中恢复用途→先查母公司可调度现金。尚未投入额度、临时补流恢复用途与债券本金不是三笔可相加的外部债务。源表38.82%包括永久补流，不能证明项目已接近四成完工。","status":"conditional","evidence":["ks_project_e_progress","ks_project_e_schedule","ks_project_e_tracking","ks_d_e_fund_new","ks_d_e_issue_coupon","ks_d_e_maturity_call"],"counterevidence":["ks_project_e_schedule","ks_d_e_fund_return","ks_d_e_general_performance"],"alternatives":["谨慎减慢建设、保留现有产能及改进自研生产线可能降低过剩产能和近期现金消耗；项目可行性须由订单、成本及投产证据验证。","需求恢复可能加快建设和回款，但首先要求资金归位、采购付款及调试；若收款晚于合同付款日，全年或全生命周期盈利不能补救时点缺口。"],"changes_if":"不从原测算差异单独推导等级或展望变更，也不重复计入已进入基础因素的需求、盈利和治理事项；若经核实恢复用途/项目付款使近期发行人资金不能覆盖，则先更新月度现金和可执行融资，再判断常态评级是否仍适用。只有新的可比前瞻导致因素跨档或基础因素未计入的现金约束，才明确新的因素/调整路径。","figure_refs":["ks_project_c_project_ratio","ks_project_c_project_remaining"]}</a:t>
             </a:r>
             <a:endParaRPr lang="en-US" dirty="0"/>
           </a:p>
@@ -1863,7 +1783,8 @@
               <a:t>{"id":"ks_a_e_ar","source":"ks_a_s_25","locator":"第165—168页，应收账款，单位元；账龄、单项与组合及准备滚动","observation":"应收账款账龄延长，单项信用减值与组合按不同方法；本年坏账核销与非现金抵债影响净额变化，净额下降不能直接视为现金回收。","reliability":"发行人正式披露；财务报表经审计，但本分析未复做审计程序"}
 {"id":"ks_a_e_fixed","source":"ks_a_s_25","locator":"第182—190、204页，投资性房地产、固定资产、在建、使用权、无形、商誉、抵债房产及资产减值","observation":"闲置固定资产、抵债房产、部分无证房屋、减值及建设进度；滁州一期重要CIP滚动原表列位已图像复读仍不能闭合，不能擅自改值。","reliability":"发行人正式披露；财务报表经审计，但本分析未复做审计程序"}
 {"id":"ks_d_n_covenant","title":"持续承诺的履约解释尚未闭合","question":"年末累计债券余额承诺是否在适用口径下超限，超限是否触发救济？","conclusion":"年末账面债券 23.13 亿元人民币 除合并总权益 40.52 亿元人民币 得 57.09%，高于原文所列 50.00%；差额为 2.87 亿元人民币。公司同时披露长期有效且正常履行、债券未违约。现有公开材料没有逐项解释冲突，因此保留重大待解释事项，不能认定已违约、自动加速或已获豁免。","mechanism":"发行时法规解释采用合并账面余额与合并总权益，但发行条件解释不自动解决单独持续承诺的范围。即使用面值替代账面，敏感性仍为 54.24%。利息计提与摊销使债券账面金额高于面值，不能把二者混用。一般良好履约声明没有给出期间、排除项或调节表。","status":"unresolved","evidence":["ks_d_e_commitment","ks_d_e_commitment_origin","ks_d_e_issuance_law","ks_d_f_bond_book_2025","ks_d_f_equity_total_2025","ks_d_c_book_ratio","ks_d_c_book_excess","ks_d_g_face_equity_ratio"],"counterevidence":["ks_d_e_bond_accounting","ks_d_e_general_performance","ks_d_e_sponsor_performance","ks_d_e_temporary_report"],"alternatives":["承诺可能存在已签协议中的特定适用期间或定义，需要以原协议及正式解释证明。","披露可能存在履约状态与财务数值不一致，需要特定更正或补充。","可能存在合法变更、豁免或调节事项，但现有材料未取得，不能推定其存在。"],"changes_if":"取得原承诺适用期间、累计余额及净资产定义、逐期计算调节表、正式解释和依法有效的变更/豁免文件后，按相同原始数字重作结论；仅重复一般“正常履行”不能关闭差异。","figure_refs":["ks_d_f_bond_book_2025","ks_d_f_equity_total_2025","ks_d_c_book_ratio","ks_d_f_covenant_limit","ks_d_c_book_excess","ks_d_g_face_equity_ratio"]}
-{"id":"ks_r_bond_bucket_finding","title":"年报债券期限表不能直接代替已核合同时间轴","question":"短期票息与远期兑付的期限分配是否一致？","conclusion":"年报一年内未折现应付债券现金流为1,098.92 万元人民币；同日面值保持不变的合同第三年票息为2,197.83 万元人民币，两者差-1,098.91 万元人民币。其他期限栏也存在条件比较差额，未取得表内假设解释。","mechanism":"资料时点、计息年度和现金支付日期分别核验。票息不是期末有效利率利息费用；到期含末息价也不能再加最后一期利息。差额不通过改写原表、改变面值或重复扣息调平。","status":"unresolved","evidence":["ks_r_e_bond_buckets","ks_d_e_issue_coupon","ks_d_e_maturity_call"],"counterevidence":["ks_a_e_audit"],"alternatives":["表格可能采用不同转股/行权或列报假设，须由发行人给出对应明细，不能由分析者臆造。","计息年度滚动或分桶口径也可能影响显示；目前没有足够证据确定原因。"],"changes_if":"取得发行人未折现表的本金、票息、日期、转股及行权假设明细后对齐比较，更新现金预算；不以原表一年内金额直接替代本年合同付息需求。","figure_refs":["ks_r_bucket_within_one_year","ks_r_bucket_2026_contract","ks_r_bucket_2026_gap"]}</a:t>
+{"id":"ks_r_bond_bucket_finding","title":"年报债券期限表不能直接代替已核合同时间轴","question":"短期票息与远期兑付的期限分配是否一致？","conclusion":"年报一年内未折现应付债券现金流为1,098.92 万元人民币；同日面值保持不变的合同第三年票息为2,197.83 万元人民币，两者差-1,098.91 万元人民币。其他期限栏也存在条件比较差额，未取得表内假设解释。","mechanism":"资料时点、计息年度和现金支付日期分别核验。票息不是期末有效利率利息费用；到期含末息价也不能再加最后一期利息。差额不通过改写原表、改变面值或重复扣息调平。","status":"unresolved","evidence":["ks_r_e_bond_buckets","ks_d_e_issue_coupon","ks_d_e_maturity_call"],"counterevidence":["ks_a_e_audit"],"alternatives":["表格可能采用不同转股/行权或列报假设，须由发行人给出对应明细，不能由分析者臆造。","计息年度滚动或分桶口径也可能影响显示；目前没有足够证据确定原因。"],"changes_if":"取得发行人未折现表的本金、票息、日期、转股及行权假设明细后对齐比较，更新现金预算；不以原表一年内金额直接替代本年合同付息需求。","figure_refs":["ks_r_bucket_within_one_year","ks_r_bucket_2026_contract","ks_r_bucket_2026_gap"]}
+{"id":"ks_project_n_put","title":"延期、用途变更与回售的触发条件分开检验","question":"项目变化是否会把2029债项现金提前？","conclusion":"原文只披露进度延期且用途、主体、方式等未变，保荐核查支持未变相改用途；截至所读资料，不能认定附加回售已经触发。普通价格回售仅适用于最后两个计息年度，自2027-08-04进入首个适用年度，不能在2026-06-30仅凭股价低位当作已可回售。","mechanism":"附加回售另需项目实施较承诺重大变化并符合被视作或认定改变用途的条件，不受普通回售最后两年限制。若真实触发且持有人依法申报，现金额为被回售面值B加B×当年票息i×计息日数t/365，替换该部分之后票息和到期兑付，不把115%到期价加在回售价上。并须核公告、申报窗口、有效行权及实际面值；缺签署协议不能凭会议条款推定交叉违约或自动加速。","status":"conditional","evidence":["ks_d_e_put","ks_d_e_issue_coupon","ks_project_e_schedule","ks_d_e_face_q1"],"counterevidence":["ks_d_e_general_performance","ks_project_e_tracking"],"alternatives":["依法批准且仅改变建设进度可能不构成用途变更；该解释有现有核查支持，但不是对未来执行的免责。","若实际建设内容、主体或资金用途随后实质改变，合同触发分析必须重做，不能只沿用原延期公告结论。"],"changes_if":"获得截止日前有效用途变更文件/认定及回售公告时，按有效行权规模重建发行人逐日现金和替代债券时间轴；若提前现金在付款日前无法覆盖，重定主体及受影响债项，不用负面展望替代即时行动。仅增加待核信息而未证明触发，不将面值搬进2026年已到期债务。","figure_refs":[]}</a:t>
             </a:r>
             <a:endParaRPr lang="en-US" dirty="0"/>
           </a:p>
@@ -2446,7 +2367,7 @@
                   <a:srgbClr val="FFFFFF"/>
                 </a:solidFill>
               </a:rPr>
-              <a:t>以付款日前可调度资金及用途安排足以覆盖、未证实到期不支付为条件。母公司未来资金与持续承诺后果尚待核实，不能作为无条件正式评级发布。</a:t>
+              <a:t>以付款日前资金及用途安排足以覆盖为条件。历史毛现金流的范围调整、母公司未来资金及持续承诺后果尚待核实；模型数值尚不能证明实际付款覆盖。</a:t>
             </a:r>
             <a:endParaRPr lang="en-US" sz="2200" dirty="0"/>
           </a:p>
@@ -3614,7 +3535,7 @@
                   <a:srgbClr val="FFFFFF"/>
                 </a:solidFill>
               </a:rPr>
-              <a:t>先取得实际银行现金与用途对账、母公司付款日、持续承诺后果和可执行融资；再更新回款、亏损、订单及完整重述。改善必须由完整期间和后续证据支持，不能仅靠区间选高分升级。</a:t>
+              <a:t>补齐跨版本现金分项与合并范围桥、银行现金与用途对账、母公司付款日、持续承诺后果和可执行融资，再重算资金边界与评级条件。改善须由完整期间和后续证据支持。</a:t>
             </a:r>
             <a:endParaRPr lang="en-US" sz="2100" dirty="0"/>
           </a:p>
@@ -4020,7 +3941,7 @@
                   <a:srgbClr val="213B45"/>
                 </a:solidFill>
               </a:rPr>
-              <a:t>财务研究分 4.17 分</a:t>
+              <a:t>财务研究分 3.74 分</a:t>
             </a:r>
             <a:endParaRPr lang="en-US" sz="1200" dirty="0"/>
           </a:p>
@@ -4225,7 +4146,7 @@
                   <a:srgbClr val="A34638"/>
                 </a:solidFill>
               </a:rPr>
-              <a:t>方法局限会影响决定：财务仅以可比两年30/70合成，是研究适配；本企业并非只存续两年。三年重述细项、定性区间与计算顺序都需敏感性核验。</a:t>
+              <a:t>同定义年度指标先30/70加权、再分档；缺完整三年重述，仍属研究适配。固定现有定性分值的量化档内范围为[3.46125, 4.01125)，跨F5/F4，不能把代表值当唯一结果。</a:t>
             </a:r>
             <a:endParaRPr lang="en-US" sz="1800" dirty="0"/>
           </a:p>
@@ -6988,7 +6909,7 @@
                   <a:srgbClr val="213B45"/>
                 </a:solidFill>
               </a:rPr>
-              <a:t>季度现金低点比年末余额更先约束支付</a:t>
+              <a:t>一年条件资金容量：范围调整仍须补证</a:t>
             </a:r>
             <a:endParaRPr lang="en-US" sz="3000" dirty="0"/>
           </a:p>
@@ -7060,7 +6981,7 @@
                   <a:srgbClr val="5C6C71"/>
                 </a:solidFill>
               </a:rPr>
-              <a:t>底稿记录：ks_r_liquidity；原页、公式及完整限制见报告和Excel。</a:t>
+              <a:t>底稿记录：ks_horizon_find_horizon / ks_horizon_find_stress；原页、公式及完整限制见报告和Excel。</a:t>
             </a:r>
             <a:endParaRPr lang="en-US" sz="1000" dirty="0"/>
           </a:p>
@@ -7112,7 +7033,7 @@
                   <a:srgbClr val="213B45"/>
                 </a:solidFill>
               </a:rPr>
-              <a:t>基准最低</a:t>
+              <a:t>2027六月末资金池</a:t>
             </a:r>
             <a:endParaRPr lang="en-US" sz="2200" dirty="0"/>
           </a:p>
@@ -7126,7 +7047,7 @@
                   <a:srgbClr val="213B45"/>
                 </a:solidFill>
               </a:rPr>
-              <a:t>1.44 亿元人民币</a:t>
+              <a:t>基准 2.73 亿元人民币</a:t>
             </a:r>
             <a:endParaRPr lang="en-US" sz="2200" dirty="0"/>
           </a:p>
@@ -7146,7 +7067,7 @@
                   <a:srgbClr val="213B45"/>
                 </a:solidFill>
               </a:rPr>
-              <a:t>既定客户收款再降</a:t>
+              <a:t>延期分支</a:t>
             </a:r>
             <a:endParaRPr lang="en-US" sz="2200" dirty="0"/>
           </a:p>
@@ -7160,57 +7081,43 @@
                   <a:srgbClr val="213B45"/>
                 </a:solidFill>
               </a:rPr>
-              <a:t>4.88%</a:t>
+              <a:t>-6,776.78 万元人民币</a:t>
             </a:r>
             <a:endParaRPr lang="en-US" sz="2200" dirty="0"/>
           </a:p>
+        </p:txBody>
+      </p:sp>
+      <p:sp>
+        <p:nvSpPr>
+          <p:cNvPr id="8" name="Text 4"/>
+          <p:cNvSpPr/>
+          <p:nvPr/>
+        </p:nvSpPr>
+        <p:spPr>
+          <a:xfrm>
+            <a:off x="548640" y="5495544"/>
+            <a:ext cx="11064240" cy="384048"/>
+          </a:xfrm>
+          <a:prstGeom prst="rect">
+            <a:avLst/>
+          </a:prstGeom>
+          <a:noFill/>
+          <a:ln/>
+        </p:spPr>
+        <p:txBody>
+          <a:bodyPr wrap="square" lIns="0" tIns="0" rIns="0" bIns="0" rtlCol="0" anchor="t"/>
+          <a:lstStyle/>
           <a:p>
             <a:pPr indent="0" marL="0">
               <a:buNone/>
             </a:pPr>
             <a:r>
-              <a:rPr lang="en-US" sz="2200" dirty="0">
-                <a:solidFill>
-                  <a:srgbClr val="213B45"/>
+              <a:rPr lang="en-US" sz="1300" dirty="0">
+                <a:solidFill>
+                  <a:srgbClr val="A34638"/>
                 </a:solidFill>
               </a:rPr>
-              <a:t>即触及季度末零现金</a:t>
-            </a:r>
-            <a:endParaRPr lang="en-US" sz="2200" dirty="0"/>
-          </a:p>
-        </p:txBody>
-      </p:sp>
-      <p:sp>
-        <p:nvSpPr>
-          <p:cNvPr id="8" name="Text 4"/>
-          <p:cNvSpPr/>
-          <p:nvPr/>
-        </p:nvSpPr>
-        <p:spPr>
-          <a:xfrm>
-            <a:off x="548640" y="5495544"/>
-            <a:ext cx="11064240" cy="384048"/>
-          </a:xfrm>
-          <a:prstGeom prst="rect">
-            <a:avLst/>
-          </a:prstGeom>
-          <a:noFill/>
-          <a:ln/>
-        </p:spPr>
-        <p:txBody>
-          <a:bodyPr wrap="square" lIns="0" tIns="0" rIns="0" bIns="0" rtlCol="0" anchor="t"/>
-          <a:lstStyle/>
-          <a:p>
-            <a:pPr indent="0" marL="0">
-              <a:buNone/>
-            </a:pPr>
-            <a:r>
-              <a:rPr lang="en-US" sz="1300" dirty="0">
-                <a:solidFill>
-                  <a:srgbClr val="A34638"/>
-                </a:solidFill>
-              </a:rPr>
-              <a:t>以3月末合并实际现金为起点；之后均为无新增融资的条件路径。负数后的行只表示未融资缺口延续，后期回款不证明此前已安全支付。</a:t>
+              <a:t>图示固定两版历史调整ΔA=ΔH=0、持续范围调整Γ=0；实际未知。各线还须扣未核还本D、净用途X、营运缓冲及用途隔离；季度末余额不证明月内付款覆盖。</a:t>
             </a:r>
             <a:endParaRPr lang="en-US" sz="1300" dirty="0"/>
           </a:p>
@@ -7278,7 +7185,7 @@
                   <a:srgbClr val="213B45"/>
                 </a:solidFill>
               </a:rPr>
-              <a:t>募集资金用途限制，须与外部还债分开</a:t>
+              <a:t>用途恢复与营运缓冲改变需要落实的融资</a:t>
             </a:r>
             <a:endParaRPr lang="en-US" sz="3000" dirty="0"/>
           </a:p>
@@ -7350,7 +7257,7 @@
                   <a:srgbClr val="5C6C71"/>
                 </a:solidFill>
               </a:rPr>
-              <a:t>底稿记录：ks_d_n_funds / ks_r_liquidity；原页、公式及完整限制见报告和Excel。</a:t>
+              <a:t>底稿记录：ks_d_n_funds / ks_project_n_restore_event / ks_horizon_find_horizon；原页、公式及完整限制见报告和Excel。</a:t>
             </a:r>
             <a:endParaRPr lang="en-US" sz="1000" dirty="0"/>
           </a:p>
@@ -7411,7 +7318,7 @@
                   <a:srgbClr val="213B45"/>
                 </a:solidFill>
               </a:rPr>
-              <a:t>基准：不新增用途预留</a:t>
+              <a:t>基准：用途占用6.5亿元</a:t>
             </a:r>
             <a:endParaRPr lang="en-US" sz="1400" dirty="0"/>
           </a:p>
@@ -7447,7 +7354,7 @@
                   <a:srgbClr val="237F72"/>
                 </a:solidFill>
               </a:rPr>
-              <a:t>1.44 亿元人民币</a:t>
+              <a:t>6.89 亿元人民币</a:t>
             </a:r>
             <a:endParaRPr lang="en-US" sz="2500" dirty="0"/>
           </a:p>
@@ -7483,7 +7390,7 @@
                   <a:srgbClr val="213B45"/>
                 </a:solidFill>
               </a:rPr>
-              <a:t>集团季度最低余额</a:t>
+              <a:t>累计融资截距；15日研究缓冲</a:t>
             </a:r>
             <a:endParaRPr lang="en-US" sz="1200" dirty="0"/>
           </a:p>
@@ -7544,7 +7451,7 @@
                   <a:srgbClr val="213B45"/>
                 </a:solidFill>
               </a:rPr>
-              <a:t>基准：另预留6.5亿元</a:t>
+              <a:t>基准：用途占用13亿元</a:t>
             </a:r>
             <a:endParaRPr lang="en-US" sz="1400" dirty="0"/>
           </a:p>
@@ -7580,7 +7487,7 @@
                   <a:srgbClr val="A34638"/>
                 </a:solidFill>
               </a:rPr>
-              <a:t>-5.06 亿元人民币</a:t>
+              <a:t>13.39 亿元人民币</a:t>
             </a:r>
             <a:endParaRPr lang="en-US" sz="2500" dirty="0"/>
           </a:p>
@@ -7616,7 +7523,7 @@
                   <a:srgbClr val="213B45"/>
                 </a:solidFill>
               </a:rPr>
-              <a:t>条件用途敏感性；非实际占用</a:t>
+              <a:t>参数敏感性；非实际占用</a:t>
             </a:r>
             <a:endParaRPr lang="en-US" sz="1200" dirty="0"/>
           </a:p>
@@ -7677,7 +7584,7 @@
                   <a:srgbClr val="213B45"/>
                 </a:solidFill>
               </a:rPr>
-              <a:t>恶化：不新增用途预留</a:t>
+              <a:t>另延5%：用途占用6.5亿元</a:t>
             </a:r>
             <a:endParaRPr lang="en-US" sz="1400" dirty="0"/>
           </a:p>
@@ -7713,7 +7620,7 @@
                   <a:srgbClr val="A34638"/>
                 </a:solidFill>
               </a:rPr>
-              <a:t>-3.38 亿元人民币</a:t>
+              <a:t>10.30 亿元人民币</a:t>
             </a:r>
             <a:endParaRPr lang="en-US" sz="2500" dirty="0"/>
           </a:p>
@@ -7749,7 +7656,7 @@
                   <a:srgbClr val="213B45"/>
                 </a:solidFill>
               </a:rPr>
-              <a:t>尚未落实补缺融资</a:t>
+              <a:t>未当作已承诺融资</a:t>
             </a:r>
             <a:endParaRPr lang="en-US" sz="1200" dirty="0"/>
           </a:p>
@@ -7785,7 +7692,7 @@
                   <a:srgbClr val="213B45"/>
                 </a:solidFill>
               </a:rPr>
-              <a:t>恢复专户或用途约束是内部现金调度，不是新增一笔债券本金。实际补流占用和项目付款时点未知；已受限余额与未来恢复额必须先核对重合。</a:t>
+              <a:t>临时补流须在2027-01-09十二个月边界及更早项目需要前恢复用途。归还专户是内部调度，须与已有用途预留去重；实际占用仍未知。</a:t>
             </a:r>
             <a:endParaRPr lang="en-US" sz="2200" dirty="0"/>
           </a:p>
@@ -7821,7 +7728,7 @@
                   <a:srgbClr val="A34638"/>
                 </a:solidFill>
               </a:rPr>
-              <a:t>现金模型中的银行本金、非转债利息与季度分配是研究预算，尚非已核实的逐笔合同到期表。季度末为正也不能证明月内足够。</a:t>
+              <a:t>截距固定ΔA=ΔH=Γ=D=X=P=0，实际参数未知。范围调整须同时改变经营收付与缓冲；还本、净用途及合格项目耗用须另核并去重。实际融资需求尚不能定值。</a:t>
             </a:r>
             <a:endParaRPr lang="en-US" sz="1900" dirty="0"/>
           </a:p>
@@ -7961,7 +7868,7 @@
                   <a:srgbClr val="5C6C71"/>
                 </a:solidFill>
               </a:rPr>
-              <a:t>底稿记录：ks_r_parent_risk / ks_d_e_issue_coupon / ks_d_e_maturity_call；原页、公式及完整限制见报告和Excel。</a:t>
+              <a:t>底稿记录：ks_r_parent_risk / ks_d_e_issue_coupon / ks_d_e_maturity_call / ks_project_n_model / ks_project_n_timing；原页、公式及完整限制见报告和Excel。</a:t>
             </a:r>
             <a:endParaRPr lang="en-US" sz="1000" dirty="0"/>
           </a:p>
@@ -8910,7 +8817,7 @@
                   <a:srgbClr val="213B45"/>
                 </a:solidFill>
               </a:rPr>
-              <a:t>到期价已含末期利息，不再加末息。未来转股尚未发生，不提前免除本金。母公司上划须核对子公司自身资金、可分配金额、法律决策及到账路径。</a:t>
+              <a:t>115%已含末息。旧项目末年净现金中79.48%依赖终期回收，不能列为已落实偿债资金。四项建设募集投入12.63%、均延至2028年末；还须证明现金可调度至发行人。</a:t>
             </a:r>
             <a:endParaRPr lang="en-US" sz="1900" dirty="0"/>
           </a:p>
@@ -9050,7 +8957,7 @@
                   <a:srgbClr val="5C6C71"/>
                 </a:solidFill>
               </a:rPr>
-              <a:t>底稿记录：ks_a_e_ar / ks_a_e_fixed / ks_d_n_covenant / ks_r_bond_bucket_finding；原页、公式及完整限制见报告和Excel。</a:t>
+              <a:t>底稿记录：ks_a_e_ar / ks_a_e_fixed / ks_d_n_covenant / ks_r_bond_bucket_finding / ks_project_n_put；原页、公式及完整限制见报告和Excel。</a:t>
             </a:r>
             <a:endParaRPr lang="en-US" sz="1000" dirty="0"/>
           </a:p>

</xml_diff>

<commit_message>
Deepen tax and bank credit analysis and validate cash paths
</commit_message>
<xml_diff>
--- a/examples/keshun-2025/deliverables/research-brief.pptx
+++ b/examples/keshun-2025/deliverables/research-brief.pptx
@@ -1243,7 +1243,8 @@
               <a:rPr lang="en-US" dirty="0"/>
               <a:t>{"id":"ks_a_e_is","source":"ks_a_s_25","locator":"第107—109页，合并利润表，单位元，2025年度/2024年度","observation":"成本费用、减值、投资及公允价值、税项和损益归属均按原符号保留。","reliability":"发行人正式披露；财务报表经审计，但本分析未复做审计程序"}
 {"id":"ks_b_market_position","title":"有全国覆盖的防水竞争者，未证实市场支配力","question":"发行人品牌和规模是否足以穿越行业需求收缩？","conclusion":"科顺全国网络、研发和工程经验支持较强细分竞争力；规模明显小于东方雨虹，不能给出未经核实的全国市场份额。","mechanism":"科顺防水材料收入46.60 亿元人民币，东方雨虹同名分类191.72 亿元人民币；科顺/北新卷材收入分别30.72 亿元人民币和33.14 亿元人民币，分类及并购口径不同。市场地位研究中心4.00 分（六分制研究刻度）、相邻3.50 分（六分制研究刻度）至4.50 分（六分制研究刻度）；这是分析者判断。","status":"supported","evidence":["ks_b_e_operations","ks_b_e_yuhong","ks_b_e_bnbm"],"counterevidence":["ks_b_e_structure"],"alternatives":["主动压缩高风险客户也可导致收入下滑，不能只解释为份额丧失。"],"changes_if":"若可核实活跃渠道、同口径销量份额和多期间收款质量共同改善，可上移判断；若主要渠道失效或相对同业持续衰退则下移。","figure_refs":["ks_b_materials25","ks_b_yh_materials","ks_b_sheet25","ks_b_bn_sheet","ks_b_score_market_center","ks_b_score_market_low","ks_b_score_market_high"]}
-{"id":"ks_a_find_earnings","title":"减值与盈利质量","question":"是否把信用损失全部作为一次性剔除？","conclusion":"净亏损-5.48 亿元人民币，信用与资产损失合计7.87 亿元人民币，会计EBITDA-2.11 亿元人民币。信用损失连续多年存在，不在基础偿债收益中自动全额加回；上期公允价值及补偿收益影响亦需保留。","mechanism":"经营利润、非现金重估、债务重组、税务利益与现金各不相同。会计EBITDA加入折旧及利息但保留资产质量成本，不以减值前利润替代可持续现金。","status":"supported","evidence":["ks_a_e_is","ks_a_e_revenue","ks_a_e_debtassets","ks_a_ebitda_2025","ks_a_perf_fv_2024"],"counterevidence":[],"alternatives":["集中确认历史客户损失可使当期亏损高于近期经营现金消耗，但损失对应的现金不可回收并不会因非现金性质消失。","非经常重估或补偿收益可能短期抵销主营亏损，必须观察对应资产变现和后续冲回。"],"changes_if":"按客户和年度拆分新增信用损失、已计提损失与实际回收，并证明常态业务现金足以覆盖利息及必要投入后，才调整可持续盈利判断。","figure_refs":["ks_a_netincome_2025","ks_a_cf_imp_2025","ks_a_ebitda_2025","ks_a_perf_fv_2024"]}</a:t>
+{"id":"ks_a_find_earnings","title":"减值与盈利质量","question":"是否把信用损失全部作为一次性剔除？","conclusion":"净亏损-5.48 亿元人民币，信用与资产损失合计7.87 亿元人民币，会计EBITDA-2.11 亿元人民币。信用损失连续多年存在，不在基础偿债收益中自动全额加回；上期公允价值及补偿收益影响亦需保留。","mechanism":"经营利润、非现金重估、债务重组、税务利益与现金各不相同。会计EBITDA加入折旧及利息但保留资产质量成本，不以减值前利润替代可持续现金。","status":"supported","evidence":["ks_a_e_is","ks_a_e_revenue","ks_a_e_debtassets","ks_a_ebitda_2025","ks_a_perf_fv_2024"],"counterevidence":[],"alternatives":["集中确认历史客户损失可使当期亏损高于近期经营现金消耗，但损失对应的现金不可回收并不会因非现金性质消失。","非经常重估或补偿收益可能短期抵销主营亏损，必须观察对应资产变现和后续冲回。"],"changes_if":"按客户和年度拆分新增信用损失、已计提损失与实际回收，并证明常态业务现金足以覆盖利息及必要投入后，才调整可持续盈利判断。","figure_refs":["ks_a_netincome_2025","ks_a_cf_imp_2025","ks_a_ebitda_2025","ks_a_perf_fv_2024"]}
+{"id":"ks_a_find_tax","title":"递延税可实现性、利润缓冲与资本质量","question":"递延税资产对亏损和资本的支撑能否兑现为偿债能力？","conclusion":"列报DTA（抵销后）5.03 亿元人民币占总权益12.41%；DTA减DTL净税资产4.66 亿元人民币占总权益11.51%，两种口径不能混用。减值及亏损DTA占抵销前DTA80.11%。当期递延税收益1.03 亿元人民币缓冲亏损；仅剔除该收益并保留当期税费，合并净利润展示为-6.51 亿元人民币，不代表现金流入。","mechanism":"减值DTA增加7,302.10 万元人民币、亏损DTA增加3,772.57 万元人民币，合计1.11 亿元人民币，加其余类别净变化-1,787.41 万元人民币形成抵销前DTA增加9,287.27 万元人民币。两类期末DTA合计4.30 亿元人民币；已确认亏损DTA7,146.12 万元人民币对应亏损税基4.42 亿元人民币。CAS18要求按纳税主体可用应税利润、期限及适用税率确认和复核。未确认差异与亏损3.88 亿元人民币是税基，不能直接当DTA减记额；年报第189—190页的到期表仅列未确认亏损，不能替代已确认亏损期限。损益递延税收益含多类DTA与DTL变动，不能全部归于亏损DTA。","status":"conditional","evidence":["ks_a_e_tax","ks_tax_e_balance","ks_tax_e_cas18","ks_tax_e_pl_cash","ks_a_taxroll","ks_tax_gross_dta_increase","ks_tax_key_share","ks_a_dta_equity","ks_tax_netasset_equity","ks_tax_loss_equity","ks_tax_income_without_deferred"],"counterevidence":["ks_a_taxcurrent","ks_a_unrecognizeddta"],"alternatives":["部分可抵扣差异可由同一纳税主体未来应税利润及应税暂时性差异转回支持；合并亏损本身不证明全部DTA失效。","集团内其他主体盈利不能未经税法依据抵扣亏损，同一未来应税利润不能在多类DTA中重复使用。"],"changes_if":"取得分主体、税区、亏损发生及到期年度、差异转回和抵扣限制后，若可用应税利润不足，则重估相关DTA；亏损DTA占总权益1.76%。经证实需减记时相应降低损益和权益，不再追加一次假定税盾；按选用信用方法评价资本缓冲，并与减值情景去重。未落实的税资产不进入可调度现金，不能据税收益上调偿债能力。","figure_refs":["ks_a_dta_2025","ks_a_dta_equity","ks_tax_netasset_2025","ks_tax_netasset_equity","ks_tax_key_share","ks_tax_deferred_benefit","ks_tax_income_without_deferred","ks_tax_impairment_increase","ks_tax_loss_increase","ks_tax_key_increase","ks_tax_other_increase","ks_tax_gross_dta_increase","ks_tax_key_dta","ks_a_dtaloss","ks_a_taxlossbasis","ks_a_unrecognizeddta","ks_tax_loss_equity","ks_a_taxroll"]}</a:t>
             </a:r>
             <a:endParaRPr lang="en-US" dirty="0"/>
           </a:p>
@@ -4286,7 +4287,7 @@
                   <a:srgbClr val="5C6C71"/>
                 </a:solidFill>
               </a:rPr>
-              <a:t>底稿记录：ks_a_e_is / ks_b_market_position / ks_a_find_earnings；原页、公式及完整限制见报告和Excel。</a:t>
+              <a:t>底稿记录：ks_a_e_is / ks_b_market_position / ks_a_find_earnings / ks_a_find_tax；原页、公式及完整限制见报告和Excel。</a:t>
             </a:r>
             <a:endParaRPr lang="en-US" sz="1000" dirty="0"/>
           </a:p>
@@ -4736,7 +4737,7 @@
         <p:spPr>
           <a:xfrm>
             <a:off x="548640" y="4681728"/>
-            <a:ext cx="11064240" cy="777240"/>
+            <a:ext cx="11064240" cy="914400"/>
           </a:xfrm>
           <a:prstGeom prst="rect">
             <a:avLst/>
@@ -4752,14 +4753,14 @@
               <a:buNone/>
             </a:pPr>
             <a:r>
-              <a:rPr lang="en-US" sz="1900" dirty="0">
+              <a:rPr lang="en-US" sz="1800" dirty="0">
                 <a:solidFill>
                   <a:srgbClr val="213B45"/>
                 </a:solidFill>
               </a:rPr>
-              <a:t>反证保留：季度收入及利润初步改善、无保留审计意见；它们不能单独排除旧应收损失、资金限制或短期付款风险。</a:t>
-            </a:r>
-            <a:endParaRPr lang="en-US" sz="1900" dirty="0"/>
+              <a:t>递延税收益 1.03 亿元人民币 缓冲当期亏损，未形成现金流入；DTA可实现性仍须按纳税主体核验。季度改善和无保留审计意见不能单独排除旧应收损失或付款风险。</a:t>
+            </a:r>
+            <a:endParaRPr lang="en-US" sz="1800" dirty="0"/>
           </a:p>
         </p:txBody>
       </p:sp>

</xml_diff>

<commit_message>
Connect earnings changes and credit evidence across case deliverables
</commit_message>
<xml_diff>
--- a/examples/keshun-2025/deliverables/research-brief.pptx
+++ b/examples/keshun-2025/deliverables/research-brief.pptx
@@ -973,8 +973,8 @@
           <a:p>
             <a:r>
               <a:rPr lang="en-US" dirty="0"/>
-              <a:t>{"id":"ks_r_recommendation","title":"条件研究建议：主体与科顺转债BBB+、负面；现金范围桥待核","question":"所选境内方法下，证据如何形成具体建议？","conclusion":"现金季节锚的范围桥尚未闭合；以下数字仅为Δ_A=Δ_H=Γ=0条件参照。以信息截止日的公开证据和明示判断，基准建议主体及科顺转债为BBB+、负面展望。经营C、财务F4的指示单元格为a-/bbb+，选择bbb+；不计可证实的额外支持增益，普通无担保直接债项暂同级。建议以常态融资渠道仍运行、未证实到期不支付，且实际付款日前资金与用途安排足以覆盖为条件。母公司可调度资金和持续承诺后果未核实，不能作为无条件正式评级发布。","mechanism":"环境3.25 分、自身竞争力3.78 分。年度同定义指标先30/70加权后分档的财务代表值3.74 分落F4；先权会计金额得3.74 分，本案档位相同。固定现有定性判断，量化档内合成范围从3.46 分（含）至4.01 分（不含），跨F5/F4，不能声称BBB+是唯一可推结果。C/F4选较弱端基于最新负EBITDA、母公司负经营现金、第四季回款依赖及用途约束；已进基础因素的弱项不重复扣档。 一年资金容量结果另见ks_horizon_find_horizon：未核还本和用途参数不能填零，融资截距不等于已落实来源。若付款日前所需发行人资源无法落实，建议的资金前提失效，须重新定级。 现金容量还须完成H1/年报版本桥及持续经营范围校正；原数字为Δ_H=Δ_A=0条件分支，不能充作已验证资金覆盖或据此固定评级。","status":"conditional","evidence":["ks_r_e_business","ks_r_e_finance","ks_r_e_matrix","ks_a_ebitda_2025","ks_d_c_book_ratio","ks_horizon_base_peak_funding_intercept_U650","ks_horizon_collection_delay_5pct_peak_funding_intercept_U650","ks_horizon_e_ar_scope","ks_horizon_e_decontrol_scope"],"counterevidence":["ks_a_e_q1","ks_a_e_control"],"alternatives":["本次量化档内下界已落F5；若有依据的择分或完整可比三年/前瞻证据支持F5，则按已列C/F5分支重评。中点代表值支持F4的研究建议，但不能以条件性文字代替缺失三年及定性判断的核验。","无保留审计及季度盈利、银行新增借款支持持续经营，但不能单独排除现金或合同限制。"],"changes_if":"若更新事实使经营D、财务仍F4，研究分支为BB+；经营C而财务F5为BBB-；两者同时恶化为BB。若证实近期无法按约付款，立即退出上述常态分支，不能只保留负面展望。 须先核实Δ_A、Δ_H及Γ并重跑全部时点和营运缓冲；零调整选点未证明实际资金覆盖，也不构成已证实现金必然更差。","figure_refs":["ks_r_environment_score","ks_r_competitive_score","ks_r_financial_score","ks_r_financial_score_alternative","ks_r_financial_lower","ks_r_financial_upper","ks_a_ebitda_2025","ks_d_c_book_ratio","ks_horizon_base_peak_funding_intercept_U650","ks_horizon_collection_delay_5pct_peak_funding_intercept_U650"]}
-{"id":"ks_r_liquidity","title":"季度现金压力决定跟踪顺序","question":"年末正现金是否掩盖更早缺口？","conclusion":"现金季节锚的范围桥尚未闭合；以下数字仅为Δ_A=Δ_H=Γ=0条件参照。从三月末实际集团现金接续的无新增融资模型中，基准季度低点1.44 亿元人民币，恶化低点-3.38 亿元人民币；基准再少收4.88%客户现金即触及季度末零现金。基准另预留用途资金后低点-5.06 亿元人民币。这些是条件值，不能替代六月实际数或月内、母公司支付证明。","mechanism":"经营采购和票据结算在CFO内只扣一次；融资本金和现金利息另扣，未把非现金AP转借款再扣为现金。募集金恢复用途是现金限制敏感性，不是新增外部债本金。负数后续行只显示未融资缺口，晚收款不能抹去先前支付失败。 2027-01-09用途恢复另有静态事件桥；一年展望的季节性延伸见ks_horizon_q_base及回款延期分支。它们单列未知D/X/P/U、营运缓冲及发行人资金条件，不与原用途预留叠扣，也不证明实际连续付款覆盖。","status":"conditional","evidence":["ks_d_l_e_cash_actual","ks_d_l_e_season","ks_r_base_cash_min","ks_r_worse_cash_min","ks_d_e_fund_new","ks_horizon_e_ar_scope","ks_horizon_e_decontrol_scope"],"counterevidence":["ks_a_e_q1","ks_a_e_maturity"],"alternatives":["银行续贷、资产变现或真实现金上划可能补足缺口，但须有可执行额度、条件和时点。","实际采购、建设支出或回款季节性可能不同于研究假设，需用实际付款台账替换。"],"changes_if":"若现金短缺由已落实融资或可合法延后支出覆盖，重跑现金表并判断是否足以维持BBB+；若缺口在已核实付款日仍存在，先确认具体偿付事件并重定主体及受影响债项。 须先核实Δ_A、Δ_H及Γ并重跑全部时点和营运缓冲；零调整选点未证明实际资金覆盖，也不构成已证实现金必然更差。","figure_refs":["ks_r_base_cash_min","ks_r_worse_cash_min","ks_r_base_receipt_boundary","ks_r_base_reserve650"]}</a:t>
+              <a:t>{"id":"ks_r_recommendation","title":"条件研究建议：主体与科顺转债BBB+、负面；现金范围桥待核","question":"所选境内方法下，证据如何形成具体建议？","conclusion":"现金季节锚的范围桥尚未闭合；以下数字仅为Δ_A=Δ_H=Γ=0条件参照。以信息截止日的公开证据和明示判断，基准建议主体及科顺转债为BBB+、负面展望。经营C、财务F4的指示单元格为a-/bbb+，选择bbb+；不计可证实的额外支持增益，普通无担保直接债项暂同级。建议以常态融资渠道仍运行、未证实到期不支付，且实际付款日前资金与用途安排足以覆盖为条件。母公司可调度资金和持续承诺后果未核实，不能作为无条件正式评级发布。","mechanism":"环境3.25 分、自身竞争力3.78 分。年度同定义指标先30/70加权后分档的财务代表值3.74 分落F4；先权会计金额得3.74 分，本案档位相同。固定现有定性判断，量化档内合成范围从3.46 分（含）至4.01 分（不含），跨F5/F4，不能声称BBB+是唯一可推结果。C/F4选较弱端基于最新负EBITDA、母公司负经营现金、第四季回款依赖及用途约束；已进基础因素的弱项不重复扣档。 一年资金容量结果另见ks_horizon_find_horizon：未核还本和用途参数不能填零，融资截距不等于已落实来源。若付款日前所需发行人资源无法落实，建议的资金前提失效，须重新定级。 现金容量还须完成H1/年报版本桥及持续经营范围校正；原数字为Δ_H=Δ_A=0条件分支，不能充作已验证资金覆盖或据此固定评级。 年报未用银行借款10.8亿元与跟踪报告未用授信47亿元的冲突另见ks_credit_find_facilities，尚未形成银行合同桥；不能以额度披露或现有再融资4.65研究分证明付款资金已落实。","status":"conditional","evidence":["ks_r_e_business","ks_r_e_finance","ks_r_e_matrix","ks_a_ebitda_2025","ks_d_c_book_ratio","ks_horizon_base_peak_funding_intercept_U650","ks_horizon_collection_delay_5pct_peak_funding_intercept_U650","ks_horizon_e_ar_scope","ks_horizon_e_decontrol_scope","ks_credit_e_facilities"],"counterevidence":["ks_a_e_q1","ks_a_e_control"],"alternatives":["本次量化档内下界已落F5；若有依据的择分或完整可比三年/前瞻证据支持F5，则按已列C/F5分支重评。中点代表值支持F4的研究建议，但不能以条件性文字代替缺失三年及定性判断的核验。","无保留审计及季度盈利、银行新增借款支持持续经营，但不能单独排除现金或合同限制。"],"changes_if":"若更新事实使经营D、财务仍F4，研究分支为BB+；经营C而财务F5为BBB-；两者同时恶化为BB。若证实近期无法按约付款，立即退出上述常态分支，不能只保留负面展望。 须先核实Δ_A、Δ_H及Γ并重跑全部时点和营运缓冲；零调整选点未证明实际资金覆盖，也不构成已证实现金必然更差。","figure_refs":["ks_r_environment_score","ks_r_competitive_score","ks_r_financial_score","ks_r_financial_score_alternative","ks_r_financial_lower","ks_r_financial_upper","ks_a_ebitda_2025","ks_d_c_book_ratio","ks_horizon_base_peak_funding_intercept_U650","ks_horizon_collection_delay_5pct_peak_funding_intercept_U650"]}
+{"id":"ks_r_liquidity","title":"季度现金压力决定跟踪顺序","question":"年末正现金是否掩盖更早缺口？","conclusion":"现金季节锚的范围桥尚未闭合；以下数字仅为Δ_A=Δ_H=Γ=0条件参照。从三月末实际集团现金接续的无新增融资模型中，基准季度低点1.44 亿元人民币，恶化低点-3.38 亿元人民币；基准再少收4.88%客户现金即触及季度末零现金。基准另预留用途资金后低点-5.06 亿元人民币。这些是条件值，不能替代六月实际数或月内、母公司支付证明。","mechanism":"经营采购和票据结算在CFO内只扣一次；融资本金和现金利息另扣，未把非现金AP转借款再扣为现金。募集金恢复用途是现金限制敏感性，不是新增外部债本金。负数后续行只显示未融资缺口，晚收款不能抹去先前支付失败。 2027-01-09用途恢复另有静态事件桥；一年展望的季节性延伸见ks_horizon_q_base及回款延期分支。它们单列未知D/X/P/U、营运缓冲及发行人资金条件，不与原用途预留叠扣，也不证明实际连续付款覆盖。 年报未用银行借款10.8亿元与跟踪报告未用授信47亿元的冲突另见ks_credit_find_facilities，尚未形成银行合同桥；不能以额度披露或现有再融资4.65研究分证明付款资金已落实。","status":"conditional","evidence":["ks_d_l_e_cash_actual","ks_d_l_e_season","ks_r_base_cash_min","ks_r_worse_cash_min","ks_d_e_fund_new","ks_horizon_e_ar_scope","ks_horizon_e_decontrol_scope","ks_credit_e_facilities"],"counterevidence":["ks_a_e_q1","ks_a_e_maturity"],"alternatives":["银行续贷、资产变现或真实现金上划可能补足缺口，但须有可执行额度、条件和时点。","实际采购、建设支出或回款季节性可能不同于研究假设，需用实际付款台账替换。"],"changes_if":"若现金短缺由已落实融资或可合法延后支出覆盖，重跑现金表并判断是否足以维持BBB+；若缺口在已核实付款日仍存在，先确认具体偿付事件并重定主体及受影响债项。 须先核实Δ_A、Δ_H及Γ并重跑全部时点和营运缓冲；零调整选点未证明实际资金覆盖，也不构成已证实现金必然更差。","figure_refs":["ks_r_base_cash_min","ks_r_worse_cash_min","ks_r_base_receipt_boundary","ks_r_base_reserve650"]}</a:t>
             </a:r>
             <a:endParaRPr lang="en-US" dirty="0"/>
           </a:p>
@@ -1062,8 +1062,9 @@
           <a:p>
             <a:r>
               <a:rPr lang="en-US" dirty="0"/>
-              <a:t>{"id":"ks_r_followup","title":"展望与后续评级行动有明确决定边界","question":"哪些变化真正改变建议，而不只是更新比率？","conclusion":"负面展望反映未来约一年中的行业需求、回收、用途约束与融资压力。经营D/F4对应BB+，C/F5对应BBB-，D/F5对应BB；持续改善达到C/F3且资金及承诺问题解决时才讨论A分支。当前固定定性判断的量化档内范围跨F5/F4，已显示下行择分敏感性；没有由本次区间上端支持F3。","mechanism":"跟踪先更新月度银行现金、实际用途占用、母公司到期表和持续承诺解释，再更新半年度/年度亏损、应收回收、订单及融资。三年完整重述和更可靠预测会改变加权依据；对应结果应重算而非沿用此次分数。没有设置后台监控、没有真实委员会投票。 临时补流按2027-01-09十二个月边界及更早项目需要核查；延伸至2027年6月的条件资金容量须代入实际还本、其他净用途、项目耗用和用途占用，再检验发行人可调度资金及可落实融资。","status":"conditional","evidence":["ks_r_e_definitions","ks_r_e_matrix","ks_r_financial_lower","ks_r_financial_upper","ks_d_e_commitment","ks_d_e_fund_new","ks_project_e_schedule"],"counterevidence":["ks_a_e_q1"],"alternatives":["季度业绩改善可使展望转稳，但需要完整期间现金而不只是利润。","正式解释若证明承诺无新增现金后果，会关闭该项不确定性，其他经营财务风险仍需重评。"],"changes_if":"按本研究截止日安排下一次检查于下一份实际半年度披露及任何提前到期、用途变更或支持事件；若已发生应立即反映的偿付问题，不等待下一年度或用展望推迟调整。","figure_refs":["ks_r_financial_lower","ks_r_financial_upper"]}
-{"id":"ks_r_rating_chain"}</a:t>
+              <a:t>{"id":"ks_r_followup","title":"展望与后续评级行动有明确决定边界","question":"哪些变化真正改变建议，而不只是更新比率？","conclusion":"负面展望反映未来约一年中的行业需求、回收、用途约束与融资压力。经营D/F4对应BB+，C/F5对应BBB-，D/F5对应BB；持续改善达到C/F3且资金及承诺问题解决时才讨论A分支。当前固定定性判断的量化档内范围跨F5/F4，已显示下行择分敏感性；没有由本次区间上端支持F3。","mechanism":"跟踪先更新月度银行现金、实际用途占用、母公司到期表和持续承诺解释，再更新半年度/年度亏损、应收回收、订单及融资。三年完整重述和更可靠预测会改变加权依据；对应结果应重算而非沿用此次分数。没有设置后台监控、没有真实委员会投票。 临时补流按2027-01-09十二个月边界及更早项目需要核查；延伸至2027年6月的条件资金容量须代入实际还本、其他净用途、项目耗用和用途占用，再检验发行人可调度资金及可落实融资。 优先关闭10.8/47亿元额度冲突、年末39户保证至三月及六月的存续滚动，并核保证支持的实际收现和期后追偿。","status":"conditional","evidence":["ks_r_e_definitions","ks_r_e_matrix","ks_r_financial_lower","ks_r_financial_upper","ks_d_e_commitment","ks_d_e_fund_new","ks_project_e_schedule","ks_credit_e_facilities","ks_credit_e_dealer_schedule","ks_credit_e_guarantee_q1"],"counterevidence":["ks_a_e_q1"],"alternatives":["季度业绩改善可使展望转稳，但需要完整期间现金而不只是利润。","正式解释若证明承诺无新增现金后果，会关闭该项不确定性，其他经营财务风险仍需重评。"],"changes_if":"按本研究截止日安排下一次检查于下一份实际半年度披露及任何提前到期、用途变更或支持事件；若已发生应立即反映的偿付问题，不等待下一年度或用展望推迟调整。","figure_refs":["ks_r_financial_lower","ks_r_financial_upper"]}
+{"id":"ks_r_rating_chain"}
+{"id":"ks_credit_find_facilities","title":"未用借款与授信披露冲突，融资落实条件待核","question":"年末披露额度能否支持付款日的再融资假设？","conclusion":"年报未用银行借款额度10.80 亿元人民币，跟踪报告同称2025年底的银行授信总额73.00 亿元人民币、未用47.00 亿元人民币。未用披露名义差额36.20 亿元人民币，尚未解释。两来源用词不同只是待核线索，不能据此称口径已对齐，任何一项也未作为已落实现金计入。","mechanism":"按同一法人、银行及产品对应总额、已用、未用、共享或循环额度，核抵质押、保证金、财务约束、提款前提、撤销权和有效期，再将真正可用金额匹配付款日。综合授信可能包含票据、保函或其他产品，年报借款额度也可能有不同总体；这些是候选解释，不是已查明原因。现有再融资研究分5.0/4.5及加权4.65仅保留为原条件分支，金额冲突未关闭前不能证明这一赋值或BBB+资金前提充分，也不因缺资料任意另给分。","status":"unresolved","evidence":["ks_a_e_maturity","ks_credit_e_facilities","ks_credit_facility_gap"],"counterevidence":["ks_a_e_q1"],"alternatives":["一季度实际新增借款证明当季有融资发生，但不能证明六月以后的未用额度、提款条件或母公司付款能力。","若合同总体差异完整解释差额且足额资源可按时提用，可支持融资能力；若主要是可撤销、受限或非现金产品，则应降低可依赖融资并重新评估因素和资金前提。"],"changes_if":"取得两个披露总体的逐项桥及银行直接证据，列明每个付款日已承诺可提金额、条件满足状态和现金所在法人；仍未解释部分排除已落实来源。以核实结果更新再融资因素及资金情景；先检查付款前提是否失效，再决定等级和展望，不沿用4.65作为已证实结论。","figure_refs":["ks_a_undrawn","ks_credit_facility_total","ks_credit_facility_undrawn","ks_credit_facility_gap"]}</a:t>
             </a:r>
             <a:endParaRPr lang="en-US" dirty="0"/>
           </a:p>
@@ -1151,7 +1152,7 @@
           <a:p>
             <a:r>
               <a:rPr lang="en-US" dirty="0"/>
-              <a:t>{"id":"ks_r_recommendation","title":"条件研究建议：主体与科顺转债BBB+、负面；现金范围桥待核","question":"所选境内方法下，证据如何形成具体建议？","conclusion":"现金季节锚的范围桥尚未闭合；以下数字仅为Δ_A=Δ_H=Γ=0条件参照。以信息截止日的公开证据和明示判断，基准建议主体及科顺转债为BBB+、负面展望。经营C、财务F4的指示单元格为a-/bbb+，选择bbb+；不计可证实的额外支持增益，普通无担保直接债项暂同级。建议以常态融资渠道仍运行、未证实到期不支付，且实际付款日前资金与用途安排足以覆盖为条件。母公司可调度资金和持续承诺后果未核实，不能作为无条件正式评级发布。","mechanism":"环境3.25 分、自身竞争力3.78 分。年度同定义指标先30/70加权后分档的财务代表值3.74 分落F4；先权会计金额得3.74 分，本案档位相同。固定现有定性判断，量化档内合成范围从3.46 分（含）至4.01 分（不含），跨F5/F4，不能声称BBB+是唯一可推结果。C/F4选较弱端基于最新负EBITDA、母公司负经营现金、第四季回款依赖及用途约束；已进基础因素的弱项不重复扣档。 一年资金容量结果另见ks_horizon_find_horizon：未核还本和用途参数不能填零，融资截距不等于已落实来源。若付款日前所需发行人资源无法落实，建议的资金前提失效，须重新定级。 现金容量还须完成H1/年报版本桥及持续经营范围校正；原数字为Δ_H=Δ_A=0条件分支，不能充作已验证资金覆盖或据此固定评级。","status":"conditional","evidence":["ks_r_e_business","ks_r_e_finance","ks_r_e_matrix","ks_a_ebitda_2025","ks_d_c_book_ratio","ks_horizon_base_peak_funding_intercept_U650","ks_horizon_collection_delay_5pct_peak_funding_intercept_U650","ks_horizon_e_ar_scope","ks_horizon_e_decontrol_scope"],"counterevidence":["ks_a_e_q1","ks_a_e_control"],"alternatives":["本次量化档内下界已落F5；若有依据的择分或完整可比三年/前瞻证据支持F5，则按已列C/F5分支重评。中点代表值支持F4的研究建议，但不能以条件性文字代替缺失三年及定性判断的核验。","无保留审计及季度盈利、银行新增借款支持持续经营，但不能单独排除现金或合同限制。"],"changes_if":"若更新事实使经营D、财务仍F4，研究分支为BB+；经营C而财务F5为BBB-；两者同时恶化为BB。若证实近期无法按约付款，立即退出上述常态分支，不能只保留负面展望。 须先核实Δ_A、Δ_H及Γ并重跑全部时点和营运缓冲；零调整选点未证明实际资金覆盖，也不构成已证实现金必然更差。","figure_refs":["ks_r_environment_score","ks_r_competitive_score","ks_r_financial_score","ks_r_financial_score_alternative","ks_r_financial_lower","ks_r_financial_upper","ks_a_ebitda_2025","ks_d_c_book_ratio","ks_horizon_base_peak_funding_intercept_U650","ks_horizon_collection_delay_5pct_peak_funding_intercept_U650"]}
+              <a:t>{"id":"ks_r_recommendation","title":"条件研究建议：主体与科顺转债BBB+、负面；现金范围桥待核","question":"所选境内方法下，证据如何形成具体建议？","conclusion":"现金季节锚的范围桥尚未闭合；以下数字仅为Δ_A=Δ_H=Γ=0条件参照。以信息截止日的公开证据和明示判断，基准建议主体及科顺转债为BBB+、负面展望。经营C、财务F4的指示单元格为a-/bbb+，选择bbb+；不计可证实的额外支持增益，普通无担保直接债项暂同级。建议以常态融资渠道仍运行、未证实到期不支付，且实际付款日前资金与用途安排足以覆盖为条件。母公司可调度资金和持续承诺后果未核实，不能作为无条件正式评级发布。","mechanism":"环境3.25 分、自身竞争力3.78 分。年度同定义指标先30/70加权后分档的财务代表值3.74 分落F4；先权会计金额得3.74 分，本案档位相同。固定现有定性判断，量化档内合成范围从3.46 分（含）至4.01 分（不含），跨F5/F4，不能声称BBB+是唯一可推结果。C/F4选较弱端基于最新负EBITDA、母公司负经营现金、第四季回款依赖及用途约束；已进基础因素的弱项不重复扣档。 一年资金容量结果另见ks_horizon_find_horizon：未核还本和用途参数不能填零，融资截距不等于已落实来源。若付款日前所需发行人资源无法落实，建议的资金前提失效，须重新定级。 现金容量还须完成H1/年报版本桥及持续经营范围校正；原数字为Δ_H=Δ_A=0条件分支，不能充作已验证资金覆盖或据此固定评级。 年报未用银行借款10.8亿元与跟踪报告未用授信47亿元的冲突另见ks_credit_find_facilities，尚未形成银行合同桥；不能以额度披露或现有再融资4.65研究分证明付款资金已落实。","status":"conditional","evidence":["ks_r_e_business","ks_r_e_finance","ks_r_e_matrix","ks_a_ebitda_2025","ks_d_c_book_ratio","ks_horizon_base_peak_funding_intercept_U650","ks_horizon_collection_delay_5pct_peak_funding_intercept_U650","ks_horizon_e_ar_scope","ks_horizon_e_decontrol_scope","ks_credit_e_facilities"],"counterevidence":["ks_a_e_q1","ks_a_e_control"],"alternatives":["本次量化档内下界已落F5；若有依据的择分或完整可比三年/前瞻证据支持F5，则按已列C/F5分支重评。中点代表值支持F4的研究建议，但不能以条件性文字代替缺失三年及定性判断的核验。","无保留审计及季度盈利、银行新增借款支持持续经营，但不能单独排除现金或合同限制。"],"changes_if":"若更新事实使经营D、财务仍F4，研究分支为BB+；经营C而财务F5为BBB-；两者同时恶化为BB。若证实近期无法按约付款，立即退出上述常态分支，不能只保留负面展望。 须先核实Δ_A、Δ_H及Γ并重跑全部时点和营运缓冲；零调整选点未证明实际资金覆盖，也不构成已证实现金必然更差。","figure_refs":["ks_r_environment_score","ks_r_competitive_score","ks_r_financial_score","ks_r_financial_score_alternative","ks_r_financial_lower","ks_r_financial_upper","ks_a_ebitda_2025","ks_d_c_book_ratio","ks_horizon_base_peak_funding_intercept_U650","ks_horizon_collection_delay_5pct_peak_funding_intercept_U650"]}
 {"id":"ks_r_support_assessment","title":"外部支持：不计未经证实的评级增益","question":"哪些支持能力与意愿证据能够改变独立信用？","conclusion":"基准不计额外支持增益。自然人控制及对特定银行义务的保证未证明本债或全部偿债需要有及时支持；普通政府补助未证明困难时救助。该选择是现有证据下的研究处理，不是“民企无支持”或未来不会支持的事实判断。","mechanism":"政府路径分别核持股/控制、地方重要性、违约声誉影响、成本收益和支持历史：已知自然人控制、可替代竞争及普通补助，未识别具体救助方、独立财力及承诺。企业法人股东分支不能机械套自然人；个人保证有具体对象和财力限制。支持可能性不能与能力分开，也不能把多项潜在支持累加。","status":"conditional","evidence":["ks_r_e_support","ks_b_e_ownership","ks_a_e_related"],"counterevidence":["ks_a_e_related","ks_a_e_post"],"alternatives":["地方就业、技术或项目重要性可能增加协助意愿，但需具体规模和可执行资金支持。","股东可投入资金，但股权质押、已有保证和未核个人资源使支持额度未定。"],"changes_if":"取得具体支持方独立偿债能力、合法决策、覆盖义务、付款触发及到账时间，再按同一支持方法重做提升；不把普通授信或既有补助重新加成一档。","figure_refs":[]}
 {"id":"ks_r_adjustments","title":"个体调整逐项判断及不重复计入","question":"基础因子之外是否还有改变结果的增量事项？","conclusion":"未来投资及基金承诺、ESG、表外义务、信用记录与其他事项逐项保留。当前研究不在已反映的亏损、资产质量和治理弱项之外再机械扣档；持续承诺的具体后果和用途恢复若形成未覆盖的近期付款或不可调度约束，基准评级条件即失效，必须重新分析。","mechanism":"项目延期和基金调用影响前瞻资本需求；污染/事故、劳工质量披露只代表公司声明和制度，未有监管数据证明风险不重大。担保需与基础债务去重，实际代偿须计入现金。已知付息并不证明所有借款/贸易义务正常；原件两项小额/项目差异需核原因，不能自动转成舞弊分。","status":"conditional","evidence":["ks_r_e_matrix","ks_a_e_related","ks_a_e_governance","ks_a_e_fixed","ks_b_e_fund","ks_d_e_commitment"],"counterevidence":["ks_a_e_audit","ks_a_e_control"],"alternatives":["整改、投资收缩或真实回款改善可以减轻增量风险，但只有实施证据才能纳入。","新的监管处罚、质量赔偿或已到期代偿可能同时削弱现金与融资渠道，不能只在治理文字中描述。"],"changes_if":"新事实先量化对现金、资产和基础因素的影响，再识别未被反映的增量风险；若需个体档差，说明具体传导及不重复计入依据。不能把所有未知事项直接当中性已核实。","figure_refs":[]}</a:t>
             </a:r>
@@ -1243,7 +1244,7 @@
               <a:rPr lang="en-US" dirty="0"/>
               <a:t>{"id":"ks_a_e_is","source":"ks_a_s_25","locator":"第107—109页，合并利润表，单位元，2025年度/2024年度","observation":"成本费用、减值、投资及公允价值、税项和损益归属均按原符号保留。","reliability":"发行人正式披露；财务报表经审计，但本分析未复做审计程序"}
 {"id":"ks_b_market_position","title":"有全国覆盖的防水竞争者，未证实市场支配力","question":"发行人品牌和规模是否足以穿越行业需求收缩？","conclusion":"科顺全国网络、研发和工程经验支持较强细分竞争力；规模明显小于东方雨虹，不能给出未经核实的全国市场份额。","mechanism":"科顺防水材料收入46.60 亿元人民币，东方雨虹同名分类191.72 亿元人民币；科顺/北新卷材收入分别30.72 亿元人民币和33.14 亿元人民币，分类及并购口径不同。市场地位研究中心4.00 分（六分制研究刻度）、相邻3.50 分（六分制研究刻度）至4.50 分（六分制研究刻度）；这是分析者判断。","status":"supported","evidence":["ks_b_e_operations","ks_b_e_yuhong","ks_b_e_bnbm"],"counterevidence":["ks_b_e_structure"],"alternatives":["主动压缩高风险客户也可导致收入下滑，不能只解释为份额丧失。"],"changes_if":"若可核实活跃渠道、同口径销量份额和多期间收款质量共同改善，可上移判断；若主要渠道失效或相对同业持续衰退则下移。","figure_refs":["ks_b_materials25","ks_b_yh_materials","ks_b_sheet25","ks_b_bn_sheet","ks_b_score_market_center","ks_b_score_market_low","ks_b_score_market_high"]}
-{"id":"ks_a_find_earnings","title":"减值与盈利质量","question":"是否把信用损失全部作为一次性剔除？","conclusion":"净亏损-5.48 亿元人民币，信用与资产损失合计7.87 亿元人民币，会计EBITDA-2.11 亿元人民币。信用损失连续多年存在，不在基础偿债收益中自动全额加回；上期公允价值及补偿收益影响亦需保留。","mechanism":"经营利润、非现金重估、债务重组、税务利益与现金各不相同。会计EBITDA加入折旧及利息但保留资产质量成本，不以减值前利润替代可持续现金。","status":"supported","evidence":["ks_a_e_is","ks_a_e_revenue","ks_a_e_debtassets","ks_a_ebitda_2025","ks_a_perf_fv_2024"],"counterevidence":[],"alternatives":["集中确认历史客户损失可使当期亏损高于近期经营现金消耗，但损失对应的现金不可回收并不会因非现金性质消失。","非经常重估或补偿收益可能短期抵销主营亏损，必须观察对应资产变现和后续冲回。"],"changes_if":"按客户和年度拆分新增信用损失、已计提损失与实际回收，并证明常态业务现金足以覆盖利息及必要投入后，才调整可持续盈利判断。","figure_refs":["ks_a_netincome_2025","ks_a_cf_imp_2025","ks_a_ebitda_2025","ks_a_perf_fv_2024"]}
+{"id":"ks_a_find_earnings","title":"减值与盈利质量","question":"是否把信用损失全部作为一次性剔除？","conclusion":"净亏损-5.48 亿元人民币，信用与资产损失合计7.87 亿元人民币，会计EBITDA-2.11 亿元人民币。归母利润较2024年减少5.71 亿元人民币，其中扣非恶化3.28 亿元人民币、非经常支持减少2.43 亿元人民币，后者占42.51%；不能把恶化全部归于当期一次性损失。","mechanism":"公司归母非经常损益从2.97 亿元人民币降至5,444.23 万元人民币，逐项保留税与少数股东影响；扣非归母从-2.62 亿元人民币恶化至-5.90 亿元人民币。金融资产公允价值及处置损益从1.77 亿元人民币降至203.41 万元人民币，单项应收转回从1.37 亿元人民币降至7,987.08 万元人民币。前者不等同公允价值变动科目，后者须核现金回收、抵债或估计变更，非经常分类本身不证明现金收回。两项2024税前收益合计占原会计EBITDA72.51%；仅对称扣除这两项，2024/2025 EBITDA为1.19 亿元人民币/-2.93 亿元人民币，税前利润为-2.68 亿元人民币/-6.74 亿元人民币。这是局部依赖敏感性，并未对政府补助、处置损失、重组和其他项目逐项作经济正常化，也未替换官方评级指标；已列负项不因只挑正收益而被忽略。","status":"supported","evidence":["ks_a_e_is","ks_a_e_revenue","ks_a_e_debtassets","ks_a_ebitda_2025","ks_a_perf_fv_2024","ks_earn_e_nonrec","ks_earn_nonrec_contribution","ks_earn_two_gains_share_2024","ks_earn_ebitda_sensitivity_2024","ks_earn_ebitda_sensitivity_2025"],"counterevidence":["ks_earn_reversal_2025","ks_earn_disposal_2025","ks_earn_restructuring_2025"],"alternatives":["集中确认历史客户损失会使当期亏损高于现金支出，但持续发生的信用成本不能自动全额加回。","应收转回可能来自真实收款，也可能来自抵债及估计变化；须逐笔对应现金、资产接收和准备滚动后判断。","资产处置及债务重组损失也应按经济性质对称审查；公司扣非口径、分析者正常化和机构偿债收益定义分别保留。"],"changes_if":"按客户和年度拆分新增损失、实际回收及转回依据；把金融资产损益对应到处置现金与剩余估值敞口，对持续补助和负向非经常项目作同等核查。证明常态经营收益和现金覆盖利息及必要投入后再改善盈利判断；仅观察2024正EBITDA或2025转回收益不足以成立。","figure_refs":["ks_a_netincome_2025","ks_a_cf_imp_2025","ks_a_ebitda_2025","ks_earn_parent_decline","ks_earn_deducted_decline","ks_earn_nonrec_decline","ks_earn_nonrec_contribution","ks_earn_total_2024","ks_earn_total_2025","ks_a_adjustedni_2024","ks_a_adjustedni","ks_earn_financial_2024","ks_earn_financial_2025","ks_earn_reversal_2024","ks_earn_reversal_2025","ks_earn_two_gains_share_2024","ks_earn_ebitda_sensitivity_2024","ks_earn_ebitda_sensitivity_2025","ks_earn_pbt_sensitivity_2024","ks_earn_pbt_sensitivity_2025","ks_a_perf_fv_2024"]}
 {"id":"ks_a_find_tax","title":"递延税可实现性、利润缓冲与资本质量","question":"递延税资产对亏损和资本的支撑能否兑现为偿债能力？","conclusion":"列报DTA（抵销后）5.03 亿元人民币占总权益12.41%；DTA减DTL净税资产4.66 亿元人民币占总权益11.51%，两种口径不能混用。减值及亏损DTA占抵销前DTA80.11%。当期递延税收益1.03 亿元人民币缓冲亏损；仅剔除该收益并保留当期税费，合并净利润展示为-6.51 亿元人民币，不代表现金流入。","mechanism":"减值DTA增加7,302.10 万元人民币、亏损DTA增加3,772.57 万元人民币，合计1.11 亿元人民币，加其余类别净变化-1,787.41 万元人民币形成抵销前DTA增加9,287.27 万元人民币。两类期末DTA合计4.30 亿元人民币；已确认亏损DTA7,146.12 万元人民币对应亏损税基4.42 亿元人民币。CAS18要求按纳税主体可用应税利润、期限及适用税率确认和复核。未确认差异与亏损3.88 亿元人民币是税基，不能直接当DTA减记额；年报第189—190页的到期表仅列未确认亏损，不能替代已确认亏损期限。损益递延税收益含多类DTA与DTL变动，不能全部归于亏损DTA。","status":"conditional","evidence":["ks_a_e_tax","ks_tax_e_balance","ks_tax_e_cas18","ks_tax_e_pl_cash","ks_a_taxroll","ks_tax_gross_dta_increase","ks_tax_key_share","ks_a_dta_equity","ks_tax_netasset_equity","ks_tax_loss_equity","ks_tax_income_without_deferred"],"counterevidence":["ks_a_taxcurrent","ks_a_unrecognizeddta"],"alternatives":["部分可抵扣差异可由同一纳税主体未来应税利润及应税暂时性差异转回支持；合并亏损本身不证明全部DTA失效。","集团内其他主体盈利不能未经税法依据抵扣亏损，同一未来应税利润不能在多类DTA中重复使用。"],"changes_if":"取得分主体、税区、亏损发生及到期年度、差异转回和抵扣限制后，若可用应税利润不足，则重估相关DTA；亏损DTA占总权益1.76%。经证实需减记时相应降低损益和权益，不再追加一次假定税盾；按选用信用方法评价资本缓冲，并与减值情景去重。未落实的税资产不进入可调度现金，不能据税收益上调偿债能力。","figure_refs":["ks_a_dta_2025","ks_a_dta_equity","ks_tax_netasset_2025","ks_tax_netasset_equity","ks_tax_key_share","ks_tax_deferred_benefit","ks_tax_income_without_deferred","ks_tax_impairment_increase","ks_tax_loss_increase","ks_tax_key_increase","ks_tax_other_increase","ks_tax_gross_dta_increase","ks_tax_key_dta","ks_a_dtaloss","ks_a_taxlossbasis","ks_a_unrecognizeddta","ks_tax_loss_equity","ks_a_taxroll"]}</a:t>
             </a:r>
             <a:endParaRPr lang="en-US" dirty="0"/>
@@ -1420,9 +1421,10 @@
           <a:p>
             <a:r>
               <a:rPr lang="en-US" dirty="0"/>
-              <a:t>{"id":"ks_a_find_cfo","title":"现金质量、季节性及分红","question":"正经营现金能覆盖投入和分配吗？","conclusion":"全年CFO3.20 亿元人民币，扣现金资本开支后1.47 亿元人民币，再扣已分红后-2.41 亿元人民币。末季贡献11.44 亿元人民币，期间现金波动明显。","mechanism":"间接桥中大额非现金减值并不产生现金；经营性应付项目合计形成正向调节，但其贡献同比减少。尚未取得组成、结算、非现金及范围变动的分解，不能将该合计或保证金收付直接归因为供应商融资或客户押金提供现金。全年正值仍须结合前三季流出和融资依赖判断。","status":"supported","evidence":["ks_a_e_cf","ks_a_e_indirect","ks_a_e_summary","ks_a_e_equity","ks_a_indirect_cfo_2025"],"counterevidence":[],"alternatives":["利润至经营现金的改善可能由非现金信用损失加回形成，不能把加回项目视为经营盈利恢复。","应收净额下降也可能由核销和抵债形成；年末集中收款与下一季现金流出并存时，全年正经营现金不能证明期内无缺口。"],"changes_if":"取得按客户的季度及月度银行收现、非现金重组和供应商付款桥，并证明现金覆盖利息、必要资本投入和分红后仍有余量，才提高现金生成质量判断。","figure_refs":["ks_a_cfo_2025","ks_a_fcf_2025","ks_a_fcf_after_div","ks_a_quarter4_cfo","ks_a_indirect_cfo_2025"]}
+              <a:t>{"id":"ks_a_find_cfo","title":"现金质量、季节性及分红","question":"正经营现金能覆盖投入和分配吗？","conclusion":"全年CFO3.20 亿元人民币，扣现金资本开支后1.47 亿元人民币，再扣已分红后-2.41 亿元人民币。末季贡献11.44 亿元人民币，期间现金波动明显。","mechanism":"间接桥中大额非现金减值并不产生现金；经营性应付项目合计形成正向调节，但其贡献同比减少。尚未取得组成、结算、非现金及范围变动的分解，不能将该合计或保证金收付直接归因为供应商融资或客户押金提供现金。全年正值仍须结合前三季流出和融资依赖判断。 经销商被担保贷款按公开安排用于付公司货款，跟踪报告称主要用于年底前结清应付；需核真实保证支持收现流量及可持续性。年末担保余额不是年度收现流量，不能直接扣减CFO。","status":"supported","evidence":["ks_a_e_cf","ks_a_e_indirect","ks_a_e_summary","ks_a_e_equity","ks_a_indirect_cfo_2025","ks_credit_e_dealer_use","ks_credit_e_yearend_settlement"],"counterevidence":["ks_credit_e_guarantee_q1"],"alternatives":["利润至经营现金的改善可能由非现金信用损失加回形成，不能把加回项目视为经营盈利恢复。","应收净额下降也可能由核销和抵债形成；年末集中收款与下一季现金流出并存时，全年正经营现金不能证明期内无缺口。"],"changes_if":"取得按客户的季度及月度银行收现、非现金重组和供应商付款桥，并证明现金覆盖利息、必要资本投入和分红后仍有余量，才提高现金生成质量判断。 将经销银行放款与本公司收款逐笔匹配，并与保证余额滚动/逾期情况联查，才能辨别可持续经营回款和依赖保证续作的收现。","figure_refs":["ks_a_cfo_2025","ks_a_fcf_2025","ks_a_fcf_after_div","ks_a_quarter4_cfo","ks_a_indirect_cfo_2025"]}
 {"id":"ks_a_find_q1","title":"期后季度改善与年度约束","question":"年度弱项是否在研究截止日前消除？","conclusion":"未经审计Q1归母利润6,355.24 万元人民币、毛利率27.51%，CFO仍-5,518.29 万元人民币。季度现金年初桥闭合；信用减值继续且缺完整债务及受限现金附注，不按一季乘四替换全年。","mechanism":"季节性、原材料预付、银行长短债置换和年度末集中减值会令季度盈利与全年偿债能力不同；部分上年季度比较仍是原披露范围。解释19号实施未披露重大影响。","status":"conditional","evidence":["ks_a_e_q1","ks_a_e_policy26","ks_a_q1_cashbridge","ks_a_missing_q1_debt","ks_a_missing_q1_freecash"],"counterevidence":[],"alternatives":["季节性收付款和提前采购可以使季度利润与经营现金方向不同；不能直接把改善同比推广至全年。","季度表尚缺完整利息、受限现金和同控可比明细，短期借款增加也可能是期限置换而非净融资能力增强。"],"changes_if":"取得半年度完整附注后，用原年度及一季度桥拆出季节性、范围、应收回款与新债；持续现金改善且债务到期与资金用途匹配才支持提高判断。","figure_refs":["ks_a_q1_parentincome","ks_a_q1_gm","ks_a_q1_cfo","ks_a_q1_cashbridge","ks_a_missing_q1_debt","ks_a_missing_q1_freecash"]}
-{"id":"ks_a_e_indirect","source":"ks_a_s_25","locator":"第208—209页，净利润调节为CFO，单位元","observation":"净利加减非现金损益、递延税、营运资本及其他；经营性应收项目调整为现金流流出，不可由BS净应收下降反推相反符号。","reliability":"发行人正式披露；财务报表经审计，但本分析未复做审计程序"}</a:t>
+{"id":"ks_a_e_indirect","source":"ks_a_s_25","locator":"第208—209页，净利润调节为CFO，单位元","observation":"净利加减非现金损益、递延税、营运资本及其他；经营性应收项目调整为现金流流出，不可由BS净应收下降反推相反符号。","reliability":"发行人正式披露；财务报表经审计，但本分析未复做审计程序"}
+{"id":"ks_a_find_contingent","title":"保证、诉讼、质量与关联支持","question":"表外及或有负担是否被财务比率遗漏？","conclusion":"年末集团外经销担保1.60 亿元人民币；前十笔1.23 亿元人民币、占77.08%，其中原表七笔六月担保到期金额1.04 亿元人民币。三月末公告实际集团外余额降至7,655.11 万元人民币，降幅52.18%；集团内1.21 亿元人民币另列。余额下降是反证，不证明前十笔已逐笔解除或截至六月仍无风险。","mechanism":"原表“担保到期日”不是公司代偿日；39户需从年末经新增、续期、偿还、解除和代偿分别桥至三月末及六月。经销贷款按披露用于付公司货款，年底结清应付可能改善收现却留下保证责任：同一客户压力可同时削弱销售/收款并触发代偿。不得将年末存量直接从CFO扣除。2026-016新增审批3.60 亿元人民币但协议未签，不是已发生义务或确定融资。已开保函1.66 亿元人民币、诉讼及质保义务仍单列；集团内保证与并表基础债务去重。","status":"conditional","evidence":["ks_credit_e_dealer_schedule","ks_credit_e_guarantee_q1","ks_credit_e_guarantee_approval","ks_credit_e_dealer_use","ks_credit_e_yearend_settlement","ks_a_e_liabs","ks_a_e_related"],"counterevidence":["ks_credit_e_guarantee_q1"],"alternatives":["三月末实际余额下降且公司声明无逾期、涉诉及败诉代偿，有利于风险判断；它未说明逐户变化原因或六月状态。","反担保可能有回收价值，但需核权属、顺位、可执行性及时间；先列发行人毛付款，再列有依据的追偿，不能抵销当天现金。"],"changes_if":"全查原表前十笔及新增、展期、逾期、追偿和代偿事项；取得其余29户完整台账并核全量滚动，不能外推。把贷款放款—客户付款—发票/应收结算和实际保证状态逐户连接，区分新销售、旧款回收、预收与借新还旧；将净增或有损失与实际现金时点分别进入资产/现金质量、融资及个体调整，消除与回款和已并表债务重复计算。","figure_refs":["ks_a_guarantees_external","ks_credit_dealer_top10","ks_credit_dealer_top10_share","ks_credit_dealer_june","ks_credit_guarantee_external_q1","ks_credit_guarantee_external_decline","ks_credit_guarantee_internal_q1","ks_credit_guarantee_new_approval","ks_a_guaranteeletters"]}</a:t>
             </a:r>
             <a:endParaRPr lang="en-US" dirty="0"/>
           </a:p>
@@ -2544,7 +2546,7 @@
                   <a:srgbClr val="BCD2CE"/>
                 </a:solidFill>
               </a:rPr>
-              <a:t>底稿记录：ks_r_followup / ks_r_rating_chain；原页、公式及完整限制见报告和Excel。</a:t>
+              <a:t>底稿记录：ks_r_followup / ks_r_rating_chain / ks_credit_find_facilities；原页、公式及完整限制见报告和Excel。</a:t>
             </a:r>
             <a:endParaRPr lang="en-US" sz="1000" dirty="0"/>
           </a:p>
@@ -3536,7 +3538,7 @@
                   <a:srgbClr val="FFFFFF"/>
                 </a:solidFill>
               </a:rPr>
-              <a:t>补齐跨版本现金分项与合并范围桥、银行现金与用途对账、母公司付款日、持续承诺后果和可执行融资，再重算资金边界与评级条件。改善须由完整期间和后续证据支持。</a:t>
+              <a:t>同一时点未用银行借款 10.8 亿元与未用授信 47.0 亿元尚未对齐，均不当作现金。逐项核提款条件、发行人付款日、用途及担保解除，再重算融资判断、资金边界与评级条件。</a:t>
             </a:r>
             <a:endParaRPr lang="en-US" sz="2100" dirty="0"/>
           </a:p>
@@ -4722,7 +4724,7 @@
                   <a:srgbClr val="213B45"/>
                 </a:solidFill>
               </a:rPr>
-              <a:t>渠道、产品及成本变化要连接销量、售价和回款。收入类别或毛利率的变化，不能在缺少数量与价格桥时直接命名为有机增长或提价。</a:t>
+              <a:t>归母利润减少 5.71 亿元：扣非恶化 3.28 亿元，非经常支持减少 2.43 亿元。金融资产损益及应收转回分别核对，不能把恶化全部归于一次性减值。</a:t>
             </a:r>
             <a:endParaRPr lang="en-US" sz="2200" dirty="0"/>
           </a:p>
@@ -6371,7 +6373,7 @@
                   <a:srgbClr val="5C6C71"/>
                 </a:solidFill>
               </a:rPr>
-              <a:t>底稿记录：ks_a_find_cfo / ks_a_find_q1 / ks_a_e_indirect；原页、公式及完整限制见报告和Excel。</a:t>
+              <a:t>底稿记录：ks_a_find_cfo / ks_a_find_q1 / ks_a_e_indirect / ks_a_find_contingent；原页、公式及完整限制见报告和Excel。</a:t>
             </a:r>
             <a:endParaRPr lang="en-US" sz="1000" dirty="0"/>
           </a:p>
@@ -6821,7 +6823,7 @@
         <p:spPr>
           <a:xfrm>
             <a:off x="548640" y="4736592"/>
-            <a:ext cx="11064240" cy="777240"/>
+            <a:ext cx="11064240" cy="868680"/>
           </a:xfrm>
           <a:prstGeom prst="rect">
             <a:avLst/>
@@ -6837,14 +6839,14 @@
               <a:buNone/>
             </a:pPr>
             <a:r>
-              <a:rPr lang="en-US" sz="1900" dirty="0">
+              <a:rPr lang="en-US" sz="1800" dirty="0">
                 <a:solidFill>
                   <a:srgbClr val="213B45"/>
                 </a:solidFill>
               </a:rPr>
-              <a:t>未经审计的一季度CFO仍为 -5,518.29 万元人民币。年度、季度及重述比较范围分开；不以一季乘四取代全年预测。</a:t>
-            </a:r>
-            <a:endParaRPr lang="en-US" sz="1900" dirty="0"/>
+              <a:t>经销贷款用于支付公司货款，同时保留公司保证责任；不以担保存量扣CFO。三月末集团外担保 0.77 亿元，下降 52.18%，未证明六月逐笔解除。一季度CFO -5,518.29 万元人民币。</a:t>
+            </a:r>
+            <a:endParaRPr lang="en-US" sz="1800" dirty="0"/>
           </a:p>
         </p:txBody>
       </p:sp>

</xml_diff>

<commit_message>
Connect operating shocks to cash, financing and credit factors
</commit_message>
<xml_diff>
--- a/examples/keshun-2025/deliverables/research-brief.pptx
+++ b/examples/keshun-2025/deliverables/research-brief.pptx
@@ -135,7 +135,7 @@
               <c:strCache>
                 <c:ptCount val="1"/>
                 <c:pt idx="0">
-                  <c:v>基准</c:v>
+                  <c:v>材料不涨价</c:v>
                 </c:pt>
               </c:strCache>
             </c:strRef>
@@ -227,19 +227,19 @@
                 <c:formatCode>0.00</c:formatCode>
                 <c:ptCount val="5"/>
                 <c:pt idx="0">
-                  <c:v>9.2686062725</c:v>
+                  <c:v>0</c:v>
                 </c:pt>
                 <c:pt idx="1">
-                  <c:v>1.4381306312</c:v>
+                  <c:v>1.6243680944691161</c:v>
                 </c:pt>
                 <c:pt idx="2">
-                  <c:v>7.0258351029999995</c:v>
+                  <c:v>2.7017702205419343</c:v>
                 </c:pt>
                 <c:pt idx="3">
-                  <c:v>5.5450257040999995</c:v>
+                  <c:v>7.232095895619591</c:v>
                 </c:pt>
                 <c:pt idx="4">
-                  <c:v>2.726631919</c:v>
+                  <c:v>10.505477581665769</c:v>
                 </c:pt>
               </c:numCache>
             </c:numRef>
@@ -255,7 +255,7 @@
               <c:strCache>
                 <c:ptCount val="1"/>
                 <c:pt idx="0">
-                  <c:v>收款另延5%至窗后</c:v>
+                  <c:v>材料+5%</c:v>
                 </c:pt>
               </c:strCache>
             </c:strRef>
@@ -347,19 +347,19 @@
                 <c:formatCode>0.00</c:formatCode>
                 <c:ptCount val="5"/>
                 <c:pt idx="0">
-                  <c:v>9.2686062725</c:v>
+                  <c:v>0</c:v>
                 </c:pt>
                 <c:pt idx="1">
-                  <c:v>0.8085502098999999</c:v>
+                  <c:v>2.372815537905883</c:v>
                 </c:pt>
                 <c:pt idx="2">
-                  <c:v>5.1571669201</c:v>
+                  <c:v>3.765950770951788</c:v>
                 </c:pt>
                 <c:pt idx="3">
-                  <c:v>2.9386289424000003</c:v>
+                  <c:v>8.640145275302086</c:v>
                 </c:pt>
                 <c:pt idx="4">
-                  <c:v>-0.6776776606999999</c:v>
+                  <c:v>12.342379612872984</c:v>
                 </c:pt>
               </c:numCache>
             </c:numRef>
@@ -973,8 +973,8 @@
           <a:p>
             <a:r>
               <a:rPr lang="en-US" dirty="0"/>
-              <a:t>{"id":"ks_r_recommendation","title":"条件研究建议：主体与科顺转债BBB+、负面；现金范围桥待核","question":"所选境内方法下，证据如何形成具体建议？","conclusion":"现金季节锚的范围桥尚未闭合；以下数字仅为Δ_A=Δ_H=Γ=0条件参照。以信息截止日的公开证据和明示判断，基准建议主体及科顺转债为BBB+、负面展望。经营C、财务F4的指示单元格为a-/bbb+，选择bbb+；不计可证实的额外支持增益，普通无担保直接债项暂同级。建议以常态融资渠道仍运行、未证实到期不支付，且实际付款日前资金与用途安排足以覆盖为条件。母公司可调度资金和持续承诺后果未核实，不能作为无条件正式评级发布。","mechanism":"环境3.25 分、自身竞争力3.78 分。年度同定义指标先30/70加权后分档的财务代表值3.74 分落F4；先权会计金额得3.74 分，本案档位相同。固定现有定性判断，量化档内合成范围从3.46 分（含）至4.01 分（不含），跨F5/F4，不能声称BBB+是唯一可推结果。C/F4选较弱端基于最新负EBITDA、母公司负经营现金、第四季回款依赖及用途约束；已进基础因素的弱项不重复扣档。 一年资金容量结果另见ks_horizon_find_horizon：未核还本和用途参数不能填零，融资截距不等于已落实来源。若付款日前所需发行人资源无法落实，建议的资金前提失效，须重新定级。 现金容量还须完成H1/年报版本桥及持续经营范围校正；原数字为Δ_H=Δ_A=0条件分支，不能充作已验证资金覆盖或据此固定评级。 年报未用银行借款10.8亿元与跟踪报告未用授信47亿元的冲突另见ks_credit_find_facilities，尚未形成银行合同桥；不能以额度披露或现有再融资4.65研究分证明付款资金已落实。","status":"conditional","evidence":["ks_r_e_business","ks_r_e_finance","ks_r_e_matrix","ks_a_ebitda_2025","ks_d_c_book_ratio","ks_horizon_base_peak_funding_intercept_U650","ks_horizon_collection_delay_5pct_peak_funding_intercept_U650","ks_horizon_e_ar_scope","ks_horizon_e_decontrol_scope","ks_credit_e_facilities"],"counterevidence":["ks_a_e_q1","ks_a_e_control"],"alternatives":["本次量化档内下界已落F5；若有依据的择分或完整可比三年/前瞻证据支持F5，则按已列C/F5分支重评。中点代表值支持F4的研究建议，但不能以条件性文字代替缺失三年及定性判断的核验。","无保留审计及季度盈利、银行新增借款支持持续经营，但不能单独排除现金或合同限制。"],"changes_if":"若更新事实使经营D、财务仍F4，研究分支为BB+；经营C而财务F5为BBB-；两者同时恶化为BB。若证实近期无法按约付款，立即退出上述常态分支，不能只保留负面展望。 须先核实Δ_A、Δ_H及Γ并重跑全部时点和营运缓冲；零调整选点未证明实际资金覆盖，也不构成已证实现金必然更差。","figure_refs":["ks_r_environment_score","ks_r_competitive_score","ks_r_financial_score","ks_r_financial_score_alternative","ks_r_financial_lower","ks_r_financial_upper","ks_a_ebitda_2025","ks_d_c_book_ratio","ks_horizon_base_peak_funding_intercept_U650","ks_horizon_collection_delay_5pct_peak_funding_intercept_U650"]}
-{"id":"ks_r_liquidity","title":"季度现金压力决定跟踪顺序","question":"年末正现金是否掩盖更早缺口？","conclusion":"现金季节锚的范围桥尚未闭合；以下数字仅为Δ_A=Δ_H=Γ=0条件参照。从三月末实际集团现金接续的无新增融资模型中，基准季度低点1.44 亿元人民币，恶化低点-3.38 亿元人民币；基准再少收4.88%客户现金即触及季度末零现金。基准另预留用途资金后低点-5.06 亿元人民币。这些是条件值，不能替代六月实际数或月内、母公司支付证明。","mechanism":"经营采购和票据结算在CFO内只扣一次；融资本金和现金利息另扣，未把非现金AP转借款再扣为现金。募集金恢复用途是现金限制敏感性，不是新增外部债本金。负数后续行只显示未融资缺口，晚收款不能抹去先前支付失败。 2027-01-09用途恢复另有静态事件桥；一年展望的季节性延伸见ks_horizon_q_base及回款延期分支。它们单列未知D/X/P/U、营运缓冲及发行人资金条件，不与原用途预留叠扣，也不证明实际连续付款覆盖。 年报未用银行借款10.8亿元与跟踪报告未用授信47亿元的冲突另见ks_credit_find_facilities，尚未形成银行合同桥；不能以额度披露或现有再融资4.65研究分证明付款资金已落实。","status":"conditional","evidence":["ks_d_l_e_cash_actual","ks_d_l_e_season","ks_r_base_cash_min","ks_r_worse_cash_min","ks_d_e_fund_new","ks_horizon_e_ar_scope","ks_horizon_e_decontrol_scope","ks_credit_e_facilities"],"counterevidence":["ks_a_e_q1","ks_a_e_maturity"],"alternatives":["银行续贷、资产变现或真实现金上划可能补足缺口，但须有可执行额度、条件和时点。","实际采购、建设支出或回款季节性可能不同于研究假设，需用实际付款台账替换。"],"changes_if":"若现金短缺由已落实融资或可合法延后支出覆盖，重跑现金表并判断是否足以维持BBB+；若缺口在已核实付款日仍存在，先确认具体偿付事件并重定主体及受影响债项。 须先核实Δ_A、Δ_H及Γ并重跑全部时点和营运缓冲；零调整选点未证明实际资金覆盖，也不构成已证实现金必然更差。","figure_refs":["ks_r_base_cash_min","ks_r_worse_cash_min","ks_r_base_receipt_boundary","ks_r_base_reserve650"]}</a:t>
+              <a:t>{"id":"ks_r_recommendation","title":"历史BBB+/负面条件分支与前瞻经营融资的变化条件","question":"所选境内方法下，证据如何形成具体建议？","conclusion":"以公开证据和明示判断，历史经营C、财务F4代表值的较弱端支持主体及普通无担保科顺转债BBB+、负面展望的条件研究分支，定性中心并未唯一选定。另以2026Q1实际及未来经营、收现、税款和融资预算贯穿预测：Q1减值强度延续时，材料不涨价的金额适配结果为F3，材料上涨5%为F4，分别对应条件矩阵A和BBB+；这些预测分支不构成已证实改善或评级调整。实际付款日前可调度资金、用途和合同条件未验证，不发布无条件唯一等级。","mechanism":"历史同定义年度比率先30/70加权再分档，财务代表值3.74 分，金额先加权对照3.74 分；两者均F4。固定定性判断的量化档内范围[3.46 分,4.01 分)跨F5/F4。未来条件链采用2024/25/26的20/30/50金额适配，并列年度比率对照；Q1减值及材料5%时，2026 EBITDA3.54 亿元人民币、净利润-1.28 亿元人民币、CFO2.37 亿元人民币、末债45.08 亿元人民币，至2027H1累计新融资12.34 亿元人民币。历史与预测方法适配分列；47/10.8亿元额度不当提款，集团现金不等于发行人A，资金条件失败时退出常态矩阵。","status":"conditional","evidence":["ks_r_e_business","ks_r_e_finance","ks_r_e_matrix","ks_a_ebitda_2025","ks_d_c_book_ratio","ks_horizon_base_peak_funding_intercept_U650","ks_horizon_collection_delay_5pct_peak_funding_intercept_U650","ks_horizon_e_ar_scope","ks_horizon_e_decontrol_scope","ks_credit_e_facilities","ks_econ_fig_ebitda","ks_econ_fig_net_income","ks_econ_fig_cfo","ks_econ_fig_debt","ks_econ_fig_new_finance_h1_2027","ks_econ_e_cash_tax"],"counterevidence":["ks_a_e_q1","ks_a_e_control"],"alternatives":["本次量化档内下界已落F5；若有依据的择分或完整可比三年/前瞻证据支持F5，则按已列C/F5分支重评。中点代表值支持F4的研究建议，但不能以条件性文字代替缺失三年及定性判断的核验。","无保留审计及季度盈利、银行新增借款支持持续经营，但不能单独排除现金或合同限制。"],"changes_if":"若更新事实使经营D、财务仍F4，研究分支为BB+；经营C而财务F5为BBB-；两者同时恶化为BB。若证实近期无法按约付款，立即退出上述常态分支，不能只保留负面展望。 须先核实Δ_A、Δ_H及Γ并重跑全部时点和营运缓冲；零调整选点未证明实际资金覆盖，也不构成已证实现金必然更差。","figure_refs":["ks_r_financial_score","ks_r_financial_score_alternative","ks_r_financial_lower","ks_r_financial_upper","ks_econ_fig_ebitda","ks_econ_fig_net_income","ks_econ_fig_cfo","ks_econ_fig_debt","ks_econ_fig_new_finance_h1_2027","ks_a_ebitda_2025","ks_d_c_book_ratio","ks_horizon_base_peak_funding_intercept_U650","ks_horizon_collection_delay_5pct_peak_funding_intercept_U650"]}
+{"id":"ks_r_liquidity","title":"无新增融资现金诊断与融资反馈链分列","question":"年末正现金是否掩盖更早缺口？","conclusion":"现金季节锚的范围桥尚未闭合；以下数字仅为Δ_A=Δ_H=Γ=0条件参照。从三月末实际集团现金接续的无新增融资模型中，基准季度低点1.44 亿元人民币，恶化低点-3.38 亿元人民币；基准再少收4.88%客户现金即触及季度末零现金。基准另预留用途资金后低点-5.06 亿元人民币。这些是条件值，不能替代六月实际数或月内、母公司支付证明。","mechanism":"经营采购和票据结算在CFO内只扣一次；融资本金和现金利息另扣，未把非现金AP转借款再扣为现金。募集金恢复用途是现金限制敏感性，不是新增外部债本金。负数后续行只显示未融资缺口，晚收款不能抹去先前支付失败。 2027-01-09用途恢复另有静态事件桥；一年展望的季节性延伸见ks_horizon_q_base及回款延期分支。它们单列未知D/X/P/U、营运缓冲及发行人资金条件，不与原用途预留叠扣，也不证明实际连续付款覆盖。 年报未用银行借款10.8亿元与跟踪报告未用授信47亿元的冲突另见ks_credit_find_facilities，尚未形成银行合同桥；不能以额度披露或现有再融资4.65研究分证明付款资金已落实。 该诊断保留无新增融资路径；完整经营、税款、提款与新增利息的条件反馈见ks_econ_f_chain和ks_econ_f_funding，两套金额不直接拼接或择优。","status":"conditional","evidence":["ks_d_l_e_cash_actual","ks_d_l_e_season","ks_r_base_cash_min","ks_r_worse_cash_min","ks_d_e_fund_new","ks_horizon_e_ar_scope","ks_horizon_e_decontrol_scope","ks_credit_e_facilities"],"counterevidence":["ks_a_e_q1","ks_a_e_maturity"],"alternatives":["银行续贷、资产变现或真实现金上划可能补足缺口，但须有可执行额度、条件和时点。","实际采购、建设支出或回款季节性可能不同于研究假设，需用实际付款台账替换。"],"changes_if":"若现金短缺由已落实融资或可合法延后支出覆盖，重跑现金表并判断是否足以维持BBB+；若缺口在已核实付款日仍存在，先确认具体偿付事件并重定主体及受影响债项。 须先核实Δ_A、Δ_H及Γ并重跑全部时点和营运缓冲；零调整选点未证明实际资金覆盖，也不构成已证实现金必然更差。","figure_refs":["ks_r_base_cash_min","ks_r_worse_cash_min","ks_r_base_receipt_boundary","ks_r_base_reserve650"]}</a:t>
             </a:r>
             <a:endParaRPr lang="en-US" dirty="0"/>
           </a:p>
@@ -1062,7 +1062,7 @@
           <a:p>
             <a:r>
               <a:rPr lang="en-US" dirty="0"/>
-              <a:t>{"id":"ks_r_followup","title":"展望与后续评级行动有明确决定边界","question":"哪些变化真正改变建议，而不只是更新比率？","conclusion":"负面展望反映未来约一年中的行业需求、回收、用途约束与融资压力。经营D/F4对应BB+，C/F5对应BBB-，D/F5对应BB；持续改善达到C/F3且资金及承诺问题解决时才讨论A分支。当前固定定性判断的量化档内范围跨F5/F4，已显示下行择分敏感性；没有由本次区间上端支持F3。","mechanism":"跟踪先更新月度银行现金、实际用途占用、母公司到期表和持续承诺解释，再更新半年度/年度亏损、应收回收、订单及融资。三年完整重述和更可靠预测会改变加权依据；对应结果应重算而非沿用此次分数。没有设置后台监控、没有真实委员会投票。 临时补流按2027-01-09十二个月边界及更早项目需要核查；延伸至2027年6月的条件资金容量须代入实际还本、其他净用途、项目耗用和用途占用，再检验发行人可调度资金及可落实融资。 优先关闭10.8/47亿元额度冲突、年末39户保证至三月及六月的存续滚动，并核保证支持的实际收现和期后追偿。","status":"conditional","evidence":["ks_r_e_definitions","ks_r_e_matrix","ks_r_financial_lower","ks_r_financial_upper","ks_d_e_commitment","ks_d_e_fund_new","ks_project_e_schedule","ks_credit_e_facilities","ks_credit_e_dealer_schedule","ks_credit_e_guarantee_q1"],"counterevidence":["ks_a_e_q1"],"alternatives":["季度业绩改善可使展望转稳，但需要完整期间现金而不只是利润。","正式解释若证明承诺无新增现金后果，会关闭该项不确定性，其他经营财务风险仍需重评。"],"changes_if":"按本研究截止日安排下一次检查于下一份实际半年度披露及任何提前到期、用途变更或支持事件；若已发生应立即反映的偿付问题，不等待下一年度或用展望推迟调整。","figure_refs":["ks_r_financial_lower","ks_r_financial_upper"]}
+              <a:t>{"id":"ks_r_followup","title":"展望与后续评级行动有明确决定边界","question":"哪些变化真正改变建议，而不只是更新比率？","conclusion":"负面展望反映一年内的行业需求、回收、用途与融资压力。历史固定定性量化区间跨F5/F4，上端未达F3；未来经营融资的无材料涨价分支可得C/F3及A矩阵值，材料5%分支为C/F4及BBB+，均未证明实际持续改善。只有经营现金兑现、发行人资金及合同问题解决后才讨论实际上调；若付款条件失败立即重评。经营D/F4、C/F5、D/F5的既有变化分支继续保留。","mechanism":"跟踪先更新月度银行现金、实际用途占用、母公司到期表和持续承诺解释，再更新半年度/年度亏损、应收回收、订单及融资。三年完整重述和更可靠预测会改变加权依据；对应结果应重算而非沿用此次分数。没有设置后台监控、没有真实委员会投票。 临时补流按2027-01-09十二个月边界及更早项目需要核查；延伸至2027年6月的条件资金容量须代入实际还本、其他净用途、项目耗用和用途占用，再检验发行人可调度资金及可落实融资。 优先关闭10.8/47亿元额度冲突、年末39户保证至三月及六月的存续滚动，并核保证支持的实际收现和期后追偿。","status":"conditional","evidence":["ks_r_e_definitions","ks_r_e_matrix","ks_r_financial_lower","ks_r_financial_upper","ks_d_e_commitment","ks_d_e_fund_new","ks_project_e_schedule","ks_credit_e_facilities","ks_credit_e_dealer_schedule","ks_credit_e_guarantee_q1"],"counterevidence":["ks_a_e_q1"],"alternatives":["季度业绩改善可使展望转稳，但需要完整期间现金而不只是利润。","正式解释若证明承诺无新增现金后果，会关闭该项不确定性，其他经营财务风险仍需重评。"],"changes_if":"按本研究截止日安排下一次检查于下一份实际半年度披露及任何提前到期、用途变更或支持事件；若已发生应立即反映的偿付问题，不等待下一年度或用展望推迟调整。","figure_refs":["ks_r_financial_lower","ks_r_financial_upper"]}
 {"id":"ks_r_rating_chain"}
 {"id":"ks_credit_find_facilities","title":"未用借款与授信披露冲突，融资落实条件待核","question":"年末披露额度能否支持付款日的再融资假设？","conclusion":"年报未用银行借款额度10.80 亿元人民币，跟踪报告同称2025年底的银行授信总额73.00 亿元人民币、未用47.00 亿元人民币。未用披露名义差额36.20 亿元人民币，尚未解释。两来源用词不同只是待核线索，不能据此称口径已对齐，任何一项也未作为已落实现金计入。","mechanism":"按同一法人、银行及产品对应总额、已用、未用、共享或循环额度，核抵质押、保证金、财务约束、提款前提、撤销权和有效期，再将真正可用金额匹配付款日。综合授信可能包含票据、保函或其他产品，年报借款额度也可能有不同总体；这些是候选解释，不是已查明原因。现有再融资研究分5.0/4.5及加权4.65仅保留为原条件分支，金额冲突未关闭前不能证明这一赋值或BBB+资金前提充分，也不因缺资料任意另给分。","status":"unresolved","evidence":["ks_a_e_maturity","ks_credit_e_facilities","ks_credit_facility_gap"],"counterevidence":["ks_a_e_q1"],"alternatives":["一季度实际新增借款证明当季有融资发生，但不能证明六月以后的未用额度、提款条件或母公司付款能力。","若合同总体差异完整解释差额且足额资源可按时提用，可支持融资能力；若主要是可撤销、受限或非现金产品，则应降低可依赖融资并重新评估因素和资金前提。"],"changes_if":"取得两个披露总体的逐项桥及银行直接证据，列明每个付款日已承诺可提金额、条件满足状态和现金所在法人；仍未解释部分排除已落实来源。以核实结果更新再融资因素及资金情景；先检查付款前提是否失效，再决定等级和展望，不沿用4.65作为已证实结论。","figure_refs":["ks_a_undrawn","ks_credit_facility_total","ks_credit_facility_undrawn","ks_credit_facility_gap"]}</a:t>
             </a:r>
@@ -1152,7 +1152,7 @@
           <a:p>
             <a:r>
               <a:rPr lang="en-US" dirty="0"/>
-              <a:t>{"id":"ks_r_recommendation","title":"条件研究建议：主体与科顺转债BBB+、负面；现金范围桥待核","question":"所选境内方法下，证据如何形成具体建议？","conclusion":"现金季节锚的范围桥尚未闭合；以下数字仅为Δ_A=Δ_H=Γ=0条件参照。以信息截止日的公开证据和明示判断，基准建议主体及科顺转债为BBB+、负面展望。经营C、财务F4的指示单元格为a-/bbb+，选择bbb+；不计可证实的额外支持增益，普通无担保直接债项暂同级。建议以常态融资渠道仍运行、未证实到期不支付，且实际付款日前资金与用途安排足以覆盖为条件。母公司可调度资金和持续承诺后果未核实，不能作为无条件正式评级发布。","mechanism":"环境3.25 分、自身竞争力3.78 分。年度同定义指标先30/70加权后分档的财务代表值3.74 分落F4；先权会计金额得3.74 分，本案档位相同。固定现有定性判断，量化档内合成范围从3.46 分（含）至4.01 分（不含），跨F5/F4，不能声称BBB+是唯一可推结果。C/F4选较弱端基于最新负EBITDA、母公司负经营现金、第四季回款依赖及用途约束；已进基础因素的弱项不重复扣档。 一年资金容量结果另见ks_horizon_find_horizon：未核还本和用途参数不能填零，融资截距不等于已落实来源。若付款日前所需发行人资源无法落实，建议的资金前提失效，须重新定级。 现金容量还须完成H1/年报版本桥及持续经营范围校正；原数字为Δ_H=Δ_A=0条件分支，不能充作已验证资金覆盖或据此固定评级。 年报未用银行借款10.8亿元与跟踪报告未用授信47亿元的冲突另见ks_credit_find_facilities，尚未形成银行合同桥；不能以额度披露或现有再融资4.65研究分证明付款资金已落实。","status":"conditional","evidence":["ks_r_e_business","ks_r_e_finance","ks_r_e_matrix","ks_a_ebitda_2025","ks_d_c_book_ratio","ks_horizon_base_peak_funding_intercept_U650","ks_horizon_collection_delay_5pct_peak_funding_intercept_U650","ks_horizon_e_ar_scope","ks_horizon_e_decontrol_scope","ks_credit_e_facilities"],"counterevidence":["ks_a_e_q1","ks_a_e_control"],"alternatives":["本次量化档内下界已落F5；若有依据的择分或完整可比三年/前瞻证据支持F5，则按已列C/F5分支重评。中点代表值支持F4的研究建议，但不能以条件性文字代替缺失三年及定性判断的核验。","无保留审计及季度盈利、银行新增借款支持持续经营，但不能单独排除现金或合同限制。"],"changes_if":"若更新事实使经营D、财务仍F4，研究分支为BB+；经营C而财务F5为BBB-；两者同时恶化为BB。若证实近期无法按约付款，立即退出上述常态分支，不能只保留负面展望。 须先核实Δ_A、Δ_H及Γ并重跑全部时点和营运缓冲；零调整选点未证明实际资金覆盖，也不构成已证实现金必然更差。","figure_refs":["ks_r_environment_score","ks_r_competitive_score","ks_r_financial_score","ks_r_financial_score_alternative","ks_r_financial_lower","ks_r_financial_upper","ks_a_ebitda_2025","ks_d_c_book_ratio","ks_horizon_base_peak_funding_intercept_U650","ks_horizon_collection_delay_5pct_peak_funding_intercept_U650"]}
+              <a:t>{"id":"ks_r_recommendation","title":"历史BBB+/负面条件分支与前瞻经营融资的变化条件","question":"所选境内方法下，证据如何形成具体建议？","conclusion":"以公开证据和明示判断，历史经营C、财务F4代表值的较弱端支持主体及普通无担保科顺转债BBB+、负面展望的条件研究分支，定性中心并未唯一选定。另以2026Q1实际及未来经营、收现、税款和融资预算贯穿预测：Q1减值强度延续时，材料不涨价的金额适配结果为F3，材料上涨5%为F4，分别对应条件矩阵A和BBB+；这些预测分支不构成已证实改善或评级调整。实际付款日前可调度资金、用途和合同条件未验证，不发布无条件唯一等级。","mechanism":"历史同定义年度比率先30/70加权再分档，财务代表值3.74 分，金额先加权对照3.74 分；两者均F4。固定定性判断的量化档内范围[3.46 分,4.01 分)跨F5/F4。未来条件链采用2024/25/26的20/30/50金额适配，并列年度比率对照；Q1减值及材料5%时，2026 EBITDA3.54 亿元人民币、净利润-1.28 亿元人民币、CFO2.37 亿元人民币、末债45.08 亿元人民币，至2027H1累计新融资12.34 亿元人民币。历史与预测方法适配分列；47/10.8亿元额度不当提款，集团现金不等于发行人A，资金条件失败时退出常态矩阵。","status":"conditional","evidence":["ks_r_e_business","ks_r_e_finance","ks_r_e_matrix","ks_a_ebitda_2025","ks_d_c_book_ratio","ks_horizon_base_peak_funding_intercept_U650","ks_horizon_collection_delay_5pct_peak_funding_intercept_U650","ks_horizon_e_ar_scope","ks_horizon_e_decontrol_scope","ks_credit_e_facilities","ks_econ_fig_ebitda","ks_econ_fig_net_income","ks_econ_fig_cfo","ks_econ_fig_debt","ks_econ_fig_new_finance_h1_2027","ks_econ_e_cash_tax"],"counterevidence":["ks_a_e_q1","ks_a_e_control"],"alternatives":["本次量化档内下界已落F5；若有依据的择分或完整可比三年/前瞻证据支持F5，则按已列C/F5分支重评。中点代表值支持F4的研究建议，但不能以条件性文字代替缺失三年及定性判断的核验。","无保留审计及季度盈利、银行新增借款支持持续经营，但不能单独排除现金或合同限制。"],"changes_if":"若更新事实使经营D、财务仍F4，研究分支为BB+；经营C而财务F5为BBB-；两者同时恶化为BB。若证实近期无法按约付款，立即退出上述常态分支，不能只保留负面展望。 须先核实Δ_A、Δ_H及Γ并重跑全部时点和营运缓冲；零调整选点未证明实际资金覆盖，也不构成已证实现金必然更差。","figure_refs":["ks_r_financial_score","ks_r_financial_score_alternative","ks_r_financial_lower","ks_r_financial_upper","ks_econ_fig_ebitda","ks_econ_fig_net_income","ks_econ_fig_cfo","ks_econ_fig_debt","ks_econ_fig_new_finance_h1_2027","ks_a_ebitda_2025","ks_d_c_book_ratio","ks_horizon_base_peak_funding_intercept_U650","ks_horizon_collection_delay_5pct_peak_funding_intercept_U650"]}
 {"id":"ks_r_support_assessment","title":"外部支持：不计未经证实的评级增益","question":"哪些支持能力与意愿证据能够改变独立信用？","conclusion":"基准不计额外支持增益。自然人控制及对特定银行义务的保证未证明本债或全部偿债需要有及时支持；普通政府补助未证明困难时救助。该选择是现有证据下的研究处理，不是“民企无支持”或未来不会支持的事实判断。","mechanism":"政府路径分别核持股/控制、地方重要性、违约声誉影响、成本收益和支持历史：已知自然人控制、可替代竞争及普通补助，未识别具体救助方、独立财力及承诺。企业法人股东分支不能机械套自然人；个人保证有具体对象和财力限制。支持可能性不能与能力分开，也不能把多项潜在支持累加。","status":"conditional","evidence":["ks_r_e_support","ks_b_e_ownership","ks_a_e_related"],"counterevidence":["ks_a_e_related","ks_a_e_post"],"alternatives":["地方就业、技术或项目重要性可能增加协助意愿，但需具体规模和可执行资金支持。","股东可投入资金，但股权质押、已有保证和未核个人资源使支持额度未定。"],"changes_if":"取得具体支持方独立偿债能力、合法决策、覆盖义务、付款触发及到账时间，再按同一支持方法重做提升；不把普通授信或既有补助重新加成一档。","figure_refs":[]}
 {"id":"ks_r_adjustments","title":"个体调整逐项判断及不重复计入","question":"基础因子之外是否还有改变结果的增量事项？","conclusion":"未来投资及基金承诺、ESG、表外义务、信用记录与其他事项逐项保留。当前研究不在已反映的亏损、资产质量和治理弱项之外再机械扣档；持续承诺的具体后果和用途恢复若形成未覆盖的近期付款或不可调度约束，基准评级条件即失效，必须重新分析。","mechanism":"项目延期和基金调用影响前瞻资本需求；污染/事故、劳工质量披露只代表公司声明和制度，未有监管数据证明风险不重大。担保需与基础债务去重，实际代偿须计入现金。已知付息并不证明所有借款/贸易义务正常；原件两项小额/项目差异需核原因，不能自动转成舞弊分。","status":"conditional","evidence":["ks_r_e_matrix","ks_a_e_related","ks_a_e_governance","ks_a_e_fixed","ks_b_e_fund","ks_d_e_commitment"],"counterevidence":["ks_a_e_audit","ks_a_e_control"],"alternatives":["整改、投资收缩或真实回款改善可以减轻增量风险，但只有实施证据才能纳入。","新的监管处罚、质量赔偿或已到期代偿可能同时削弱现金与融资渠道，不能只在治理文字中描述。"],"changes_if":"新事实先量化对现金、资产和基础因素的影响，再识别未被反映的增量风险；若需个体档差，说明具体传导及不重复计入依据。不能把所有未知事项直接当中性已核实。","figure_refs":[]}</a:t>
             </a:r>
@@ -1512,8 +1512,9 @@
           <a:p>
             <a:r>
               <a:rPr lang="en-US" dirty="0"/>
-              <a:t>{"id":"ks_horizon_find_horizon","title":"一年展望须跨过2027年1月恢复用途及上半年营运低谷","question":"2026末正现金能否证明一年展望付款覆盖？","conclusion":"现金季节锚的范围桥尚未闭合；以下数字仅为Δ_A=Δ_H=Γ=0条件参照。不能。在未扣未知2027到期本金及其他净支出前，基准2027六月末集团资金池仅2.73 亿元人民币。恢复6.5亿元用途并保留15日经营缓冲时，累计融资需求截距为6.89 亿元人民币；实际融资需求须代入D、X、P及实际占用U重算，不能称该截距为已证实缺口。","mechanism":"年末回款后的上半年经营消耗、资本开支、利息和用途隔离继续占用资源。Q1复制最近同季原表；Q2毛分项仍缺同控桥，所列金额只在Δ_H=0时成立。Δ_A同时影响承接的2026年末余额。实际融资需求在范围调整及D/X/P/U未代入前为null。","status":"conditional","evidence":["ks_horizon_e_h125","ks_horizon_e_q125","ks_a_e_q1","ks_a_e_ar","ks_d_e_fund_new","ks_horizon_e_ar_scope","ks_horizon_e_decontrol_scope"],"counterevidence":["ks_a_e_q1"],"alternatives":["融资承诺落实、回款提前或可证明项目专户资金按用途支付可改善容量；必须按到款日及用途逐笔确认。"],"changes_if":"取得Δ_H、Δ_A及持续经营范围桥、真实D/X/P/U和逐日预算后按同一公式更新；未取得前不能据旧数值证明评级资金前提。若任一付款日已核实资源不足且无已落实来源，原BBB+/负面的付款覆盖前提失效。 须先核实Δ_A、Δ_H及Γ并重跑全部时点和营运缓冲；零调整选点未证明实际资金覆盖，也不构成已证实现金必然更差。","figure_refs":["ks_horizon_base_end_group_pool_before_unknown_DX","ks_horizon_base_peak_funding_intercept_U650"]}
-{"id":"ks_horizon_find_stress","title":"真实回款压力经现金和融资需要进入信用变化条件","question":"除因素分值变动外，业务压力如何影响建议？","conclusion":"现金季节锚的范围桥尚未闭合；以下数字仅为Δ_A=Δ_H=Γ=0条件参照。账龄拉长和房地产工程旧款风险支持测试收款继续延后；将预计销售收款的5%延至2027-06-30后且窗内不追收，使2026全年条件CFO从396253333.07元降至209386514.78元，并提高延伸期资金缺口。此为时点敏感性，不是5%违约概率、永久坏账或利润预测。","mechanism":"历史应收风险→预计销售收款延期→CFO下降→用途恢复后营运容量缩小→付款日前新融资需求增加；贷款若取得，其新利息和本金必须反馈进下一期现金路径。 未闭合的范围调整同时改变预计毛收款、付款和压力金额；先按版本桥重算，不能用净CFO相同消去毛额调整。 净额约束下不同毛收付折减系数仍产生现金影响；实际延期金额随调整后的客户收款重算，当前压力额不是同口径已验证金额。","status":"conditional","evidence":["ks_horizon_e_h125","ks_horizon_e_q125","ks_a_e_q1","ks_a_e_ar","ks_d_e_fund_new","ks_horizon_e_ar_scope","ks_horizon_e_decontrol_scope"],"counterevidence":["ks_a_e_q1"],"alternatives":["在同一有证据业务链上，延期收款先降低CFO及自由现金容量，再增加必须在付款日前取得的新融资；不得只将定性分数调低半分。","如果所需资金由无条件可提取授信或合法上划实际落实，并持续满足U、M和逐笔债务，支持原BBB+/负面条件建议继续作为研究分支；不构成上调证据。","如缺口不能由届时确定可得来源覆盖，或临时补流到期恢复用途挤占必要经营付款，原建议的付款覆盖前提失效，需就流动性重大弱化作个体调整/重评；若证实无法按期付款，退出常态矩阵，不用负面展望代替支付风险判断。","本压力是收款时点风险，不自动降低EBITDA或提高违约损失；补融资若以债务取得，后续利息和本金会继续压缩容量。只有新的全年可比盈利、资本及现金短债输入重算支持F5时，才进入原C/F5→BBB-分支；季度CFO不能直接映射F5。"],"changes_if":"持续恢复回款并证明付款覆盖可支持稳定展望的进一步研究；付款覆盖前提失败须重评。没有完整全年损益及债务预测，不从半年CFO或模型分数的任意±0.5直接推出评级级差。 须先核实Δ_A、Δ_H及Γ并重跑全部时点和营运缓冲；零调整选点未证明实际资金覆盖，也不构成已证实现金必然更差。","figure_refs":[]}</a:t>
+              <a:t>{"id":"ks_econ_f_chain","title":"同一材料冲击通过现金融资与利息传至权益和财务风险因素","question":"2025材料毛利改善若部分逆转，未来损益与偿债因素是否改变？","conclusion":"同季利息/补助收益、公开锚定当期税及Q1减值延续条件下，材料+5%使2026 EBITDA3.53735亿元、净利−1.27943亿元、CFO2.36903亿元、末债45.08299亿元；2027H1累计新借12.34238亿元。材料冲击相对同基准使财务分4.61625/F3→4.36625/F4，杠杆跨20和25两个阈值。","mechanism":"年报材料成本×收入预算×5%→增量采购/80%当季付款/20%应付→CFO与15天底线→期初融资和本季利息循环→利润/债务/权益→20/30/50研究适配财务因子；材料冲击只计一次。 利息/补助现金与收益对应、未知其他收現剔除；回收单列期初账面池；当期税计提及支付通过应交税滚动，历史现金税先排除代理份额再替换。","status":"conditional","evidence":["ks_econ_e_material","ks_econ_e_q1","ks_econ_fig_ebitda","ks_econ_fig_cfo","ks_econ_fig_debt","ks_r_e_finance","ks_econ_e_cash_tax"],"counterevidence":[],"alternatives":["2025减值强度延续、材料5%时，2026 EBITDA−0.71357亿元、净亏5.53036亿元，财务分3.68875/F4。","VAT全递延需累计新借12.58118亿元；当期税同季支付12.49497亿元；未来利息补助均不发生12.89331亿元。","年度比率先加权保留；零分母与混合正负EBITDA未决不伪造唯一杠杆或利用带符号均值抵销负担。"],"changes_if":"收入/采购价格、减值回收、税额抵扣、贷款条件与期限改变，须重跑同链；经营资产独立周转预测和真实可调用资金仍待核。","figure_refs":["ks_econ_fig_ebitda","ks_econ_fig_cfo","ks_econ_fig_debt"]}
+{"id":"ks_econ_f_qualitative","title":"资产质量和再融资共同相邻评分不支持唯一中心","question":"为何2024/25采用资产质量3.5/2.5、再融资5/4.5，二者共同变化怎样影响结果？","conclusion":"资产质量下调有应收准备27.50%→36.17%、3年以上23.78%→32.56%及抵债房产5.31→7.86亿元支持；但没有官方自动数值门槛。再融资中心5/4.5受同日未用额度冲突与附条件可得性限制，保留未选定。两项各±0.5，历史中心财务分3.62375/3.73625/3.84875均F4，叠加量化档内取值的联合范围[3.34875,4.12375)跨F5/F4。","mechanism":"两项权重10%和12.5%，共同±0.5使财务分±0.1125；Q1减值无涨价分支4.50375/4.61625/4.72875均F3，材料5%为4.25375/4.36625/4.47875均F4。历史联合区间及全部9格另列。","status":"conditional","evidence":["ks_a_e_ar","ks_credit_e_facilities","ks_r_e_finance","ks_r_e_history"],"counterevidence":[],"alternatives":["资产回收与银行可用额度获证支持时可选偏强相邻分支；准备不足、抵债房产/税资产变现弱或融资受限则偏弱。","仅见净应收和受限资产下降不足以证明资产改善；额度未使用不等于无条件可提款。"],"changes_if":"取得实际回收/减值充分性与银行确认后再选定分支；在此之前不以中心评级替代判断区间。","figure_refs":[]}
+{"id":"ks_econ_q_chain"}</a:t>
             </a:r>
             <a:endParaRPr lang="en-US" dirty="0"/>
           </a:p>
@@ -1601,9 +1602,9 @@
           <a:p>
             <a:r>
               <a:rPr lang="en-US" dirty="0"/>
-              <a:t>{"id":"ks_d_n_funds","title":"补流归还恢复专款用途，不新增转债本金","question":"募集资金占用和归还如何影响流动性，如何避免与本金双计？","conclusion":"年末尚未使用募集资金 13.61 亿元人民币 中，12.75 亿元人民币 已暂用于补流，专户余额为 8,643.12 万元人民币。旧一期实际使用的 13.00 亿元人民币 已于2026-01-06前归还；新一期2026-01-09批准上限 13.00 亿元人民币，实际截止日占用尚未确定。归还募集专户是恢复资金用途约束，不是新增对外金融债偿还，不能再加到转债本金上。","mechanism":"新一期从批准日起至多十二个月、项目需用时须提前归还，按日期推得最长至2027-01-09。实际占用若被营运资金锁定，会产生调回可用资金的压力；集团内部账户转移本身不减少合并现金，但会减少可自由用于一般偿债的资金。批准额度不能替代实际用款和归还流水。","status":"conditional","evidence":["ks_d_e_fund_balance","ks_d_c_fund_balance_parts","ks_d_c_fund_balance_receipts","ks_d_e_fund_return","ks_d_e_fund_new","ks_d_f_fund_temp_cutoff"],"counterevidence":["ks_d_e_fund_correction","ks_d_e_fund_delay","ks_d_e_sponsor_performance"],"alternatives":["若新一期实际支用低于批准额度，潜在需调回金额相应较低；不能预填最大额度为实际债务。","若可及时收回营运资金并恢复专户，用途恢复压力较小；这不代表资金可不受限制用于付本息。"],"changes_if":"取得截止日及到期前专户/一般户对账、逐笔支用归还、项目支付计划和资金可调回证据后量化用途恢复缺口；清除旧一期占用不能自动证明新一期占用为零。","figure_refs":["ks_d_f_fund_total","ks_d_f_fund_temp_2025","ks_d_f_fund_special_2025","ks_d_f_fund_returned","ks_d_f_fund_new_cap","ks_d_c_fund_balance_parts","ks_d_c_fund_balance_receipts","ks_d_f_fund_temp_cutoff"]}
+              <a:t>{"id":"ks_econ_f_funding","title":"按需融资成立与融资上限失败须分别进入主体债项建议","question":"相同经营冲击下，新增资金取得是否足以支持支付条件？","conclusion":"累计新增融资仅5亿元时，2027-03-31首次不能满足经营底线和用途准备，缺口3.59975亿元。按需到位、三年期新贷均为条件；材料5%矩阵保留BBB+主体及转债分支、无涨价强分支为A，实际发行人A及支付覆盖仍为空，不能由条件结果认定真实评级调整。","mechanism":"旧债账面清偿预算、现金息和债券票息与经营流同表；每季求F=(底线+用途准备−无新提款期末现金)/(1−当期新借款利息率)，受限融资不足则停止，不继续以自动贷款补平。","status":"conditional","evidence":["ks_econ_e_q1","ks_credit_e_facilities","ks_econ_fig_new_finance_h1_2027","ks_r_e_finance"],"counterevidence":[],"alternatives":["真实合同清偿与账面预算不同会改变提款时点及金额。","U/P、Δ_A/Δ_H/Γ、X、发行人A改变均可能改变日期判断；均不预填为事实。"],"changes_if":"取得按法人和银行拆分的额度确认、提款及资金调拨、合同到期及用途恢复证据后，用同一经营情景重跑；47亿元与10.8亿元未用额度不能替代确认。","figure_refs":["ks_econ_fig_new_finance_h1_2027"]}
 {"id":"ks_project_n_restore_event","title":"年度模型之后还有临时补流恢复用途的事件边界","question":"2026年末条件正现金能否证明下一次用途恢复已经覆盖？","conclusion":"现金季节锚的范围桥尚未闭合；以下数字仅为Δ_A=Δ_H=Γ=0条件参照。2026-006要求自2026-01-09批准日起不超过12个月并随项目需要提前归还。按2027-01-09的12个月边界核查，若沿用2026末基准集团现金且九日净变动、调度扣减、其他到期付款及营运底额均为零，可恢复用途的静态容量参照为7.03 亿元人民币；恢复650百万元后余5,258.35 万元人民币，按授权全额恢复则需额外资源5.97 亿元人民币。实际占用未知，以上不代表届时真实缺口或连续12个月已覆盖。","mechanism":"恢复专户先减少可自由使用资金，并不必然减少集团总现金或偿还一笔外部债务。项目付款、预留及归还记录按同一资金流去重；不能将本事件再叠加到已扣的6.5/13亿元用途预留。须将年末条件集团现金桥接到归还义务主体在事件日可调度金额，加减九日有证据收支及其他支付，不能把合并余额当母公司已到手资金。","status":"conditional","evidence":["ks_d_e_fund_new","ks_d_e_fund_return","ks_r_base_cash_end","ks_project_g_restore_max","ks_project_g_restore_cap_gap"],"counterevidence":["ks_d_e_fund_return","ks_a_e_q1"],"alternatives":["实际占用低于授权上限、已在年末归还或有可执行九日净流入，均可能关闭该事件的资源差额。","项目提前要求资金、九日其他支出或子公司现金无法上划，会把有效边界提前或降低上限；不得以未证实的下一轮补流授权弥补。"],"changes_if":"先取得实际占用和归还期限/需求、发行人可调度额及九日来源用途。当时需要恢复用途额超过经核实可调度额且无按时落实的合法安排时，重做近端流动性与承诺后果判断；不能只看年末正余额维持原判断，也不能直接把用途恢复缺口认定为债券已违约。 须先核实Δ_A、Δ_H及Γ并重跑全部时点和营运缓冲；零调整选点未证明实际资金覆盖，也不构成已证实现金必然更差。","figure_refs":["ks_project_g_restore_max","ks_project_g_restore650_after","ks_project_g_restore_cap_gap","ks_r_base_cash_end"]}
-{"id":"ks_horizon_find_horizon","title":"一年展望须跨过2027年1月恢复用途及上半年营运低谷","question":"2026末正现金能否证明一年展望付款覆盖？","conclusion":"现金季节锚的范围桥尚未闭合；以下数字仅为Δ_A=Δ_H=Γ=0条件参照。不能。在未扣未知2027到期本金及其他净支出前，基准2027六月末集团资金池仅2.73 亿元人民币。恢复6.5亿元用途并保留15日经营缓冲时，累计融资需求截距为6.89 亿元人民币；实际融资需求须代入D、X、P及实际占用U重算，不能称该截距为已证实缺口。","mechanism":"年末回款后的上半年经营消耗、资本开支、利息和用途隔离继续占用资源。Q1复制最近同季原表；Q2毛分项仍缺同控桥，所列金额只在Δ_H=0时成立。Δ_A同时影响承接的2026年末余额。实际融资需求在范围调整及D/X/P/U未代入前为null。","status":"conditional","evidence":["ks_horizon_e_h125","ks_horizon_e_q125","ks_a_e_q1","ks_a_e_ar","ks_d_e_fund_new","ks_horizon_e_ar_scope","ks_horizon_e_decontrol_scope"],"counterevidence":["ks_a_e_q1"],"alternatives":["融资承诺落实、回款提前或可证明项目专户资金按用途支付可改善容量；必须按到款日及用途逐笔确认。"],"changes_if":"取得Δ_H、Δ_A及持续经营范围桥、真实D/X/P/U和逐日预算后按同一公式更新；未取得前不能据旧数值证明评级资金前提。若任一付款日已核实资源不足且无已落实来源，原BBB+/负面的付款覆盖前提失效。 须先核实Δ_A、Δ_H及Γ并重跑全部时点和营运缓冲；零调整选点未证明实际资金覆盖，也不构成已证实现金必然更差。","figure_refs":["ks_horizon_base_end_group_pool_before_unknown_DX","ks_horizon_base_peak_funding_intercept_U650"]}</a:t>
+{"id":"ks_econ_q_chain"}</a:t>
             </a:r>
             <a:endParaRPr lang="en-US" dirty="0"/>
           </a:p>
@@ -2334,7 +2335,7 @@
                   <a:srgbClr val="D4E8E1"/>
                 </a:solidFill>
               </a:rPr>
-              <a:t>主体与普通无担保直接债项的基准研究建议</a:t>
+              <a:t>历史因素代表值下的主体与无担保债项条件分支</a:t>
             </a:r>
             <a:endParaRPr lang="en-US" sz="2300" dirty="0"/>
           </a:p>
@@ -6912,7 +6913,7 @@
                   <a:srgbClr val="213B45"/>
                 </a:solidFill>
               </a:rPr>
-              <a:t>一年条件资金容量：范围调整仍须补证</a:t>
+              <a:t>材料成本经现金与利息传至评级因素</a:t>
             </a:r>
             <a:endParaRPr lang="en-US" sz="3000" dirty="0"/>
           </a:p>
@@ -6984,38 +6985,22 @@
                   <a:srgbClr val="5C6C71"/>
                 </a:solidFill>
               </a:rPr>
-              <a:t>底稿记录：ks_horizon_find_horizon / ks_horizon_find_stress；原页、公式及完整限制见报告和Excel。</a:t>
+              <a:t>底稿记录：ks_econ_f_chain / ks_econ_f_qualitative / ks_econ_q_chain；原页、公式及完整限制见报告和Excel。</a:t>
             </a:r>
             <a:endParaRPr lang="en-US" sz="1000" dirty="0"/>
           </a:p>
         </p:txBody>
       </p:sp>
-      <p:graphicFrame>
-        <p:nvGraphicFramePr>
-          <p:cNvPr id="6" name="Chart 0" descr=""/>
-          <p:cNvGraphicFramePr/>
-          <p:nvPr/>
-        </p:nvGraphicFramePr>
-        <p:xfrm>
-          <a:off x="548640" y="1389888"/>
-          <a:ext cx="7223760" cy="3977640"/>
-        </p:xfrm>
-        <a:graphic xmlns:a="http://schemas.openxmlformats.org/drawingml/2006/main">
-          <a:graphicData uri="http://schemas.openxmlformats.org/drawingml/2006/chart">
-            <c:chart xmlns:c="http://schemas.openxmlformats.org/drawingml/2006/chart" r:id="rId1"/>
-          </a:graphicData>
-        </a:graphic>
-      </p:graphicFrame>
-      <p:sp>
-        <p:nvSpPr>
-          <p:cNvPr id="7" name="Text 3"/>
+      <p:sp>
+        <p:nvSpPr>
+          <p:cNvPr id="6" name="Text 3"/>
           <p:cNvSpPr/>
           <p:nvPr/>
         </p:nvSpPr>
         <p:spPr>
           <a:xfrm>
-            <a:off x="8183880" y="1600200"/>
-            <a:ext cx="3401568" cy="2880360"/>
+            <a:off x="548640" y="1371600"/>
+            <a:ext cx="11064240" cy="731520"/>
           </a:xfrm>
           <a:prstGeom prst="rect">
             <a:avLst/>
@@ -7031,65 +7016,1155 @@
               <a:buNone/>
             </a:pPr>
             <a:r>
-              <a:rPr lang="en-US" sz="2200" dirty="0">
+              <a:rPr lang="en-US" sz="2000" dirty="0">
                 <a:solidFill>
                   <a:srgbClr val="213B45"/>
                 </a:solidFill>
               </a:rPr>
-              <a:t>2027六月末资金池</a:t>
+              <a:t>2026全年＝实际Q1＋后三季预测；收入为季节锚98%，Q1减值强度延续、公开当期税锚，金额单位亿元人民币。</a:t>
             </a:r>
-            <a:endParaRPr lang="en-US" sz="2200" dirty="0"/>
-          </a:p>
-          <a:p>
-            <a:pPr indent="0" marL="0">
-              <a:buNone/>
-            </a:pPr>
-            <a:r>
-              <a:rPr lang="en-US" sz="2200" dirty="0">
-                <a:solidFill>
-                  <a:srgbClr val="213B45"/>
-                </a:solidFill>
-              </a:rPr>
-              <a:t>基准 2.73 亿元人民币</a:t>
-            </a:r>
-            <a:endParaRPr lang="en-US" sz="2200" dirty="0"/>
-          </a:p>
-          <a:p>
-            <a:pPr indent="0" marL="0">
-              <a:buNone/>
-            </a:pPr>
-            <a:endParaRPr lang="en-US" sz="2200" dirty="0"/>
-          </a:p>
-          <a:p>
-            <a:pPr indent="0" marL="0">
-              <a:buNone/>
-            </a:pPr>
-            <a:r>
-              <a:rPr lang="en-US" sz="2200" dirty="0">
-                <a:solidFill>
-                  <a:srgbClr val="213B45"/>
-                </a:solidFill>
-              </a:rPr>
-              <a:t>延期分支</a:t>
-            </a:r>
-            <a:endParaRPr lang="en-US" sz="2200" dirty="0"/>
-          </a:p>
-          <a:p>
-            <a:pPr indent="0" marL="0">
-              <a:buNone/>
-            </a:pPr>
-            <a:r>
-              <a:rPr lang="en-US" sz="2200" dirty="0">
-                <a:solidFill>
-                  <a:srgbClr val="213B45"/>
-                </a:solidFill>
-              </a:rPr>
-              <a:t>-6,776.78 万元人民币</a:t>
-            </a:r>
-            <a:endParaRPr lang="en-US" sz="2200" dirty="0"/>
-          </a:p>
-        </p:txBody>
-      </p:sp>
+            <a:endParaRPr lang="en-US" sz="2000" dirty="0"/>
+          </a:p>
+        </p:txBody>
+      </p:sp>
+      <p:graphicFrame>
+        <p:nvGraphicFramePr>
+          <p:cNvPr id="7" name="Table 0"/>
+          <p:cNvGraphicFramePr>
+            <a:graphicFrameLocks noGrp="1"/>
+          </p:cNvGraphicFramePr>
+          <p:nvPr>
+            <p:extLst>
+              <p:ext uri="{D42A27DB-BD31-4B8C-83A1-F6EECF244321}">
+                <p14:modId xmlns:p14="http://schemas.microsoft.com/office/powerpoint/2010/main" val="1579011935"/>
+              </p:ext>
+            </p:extLst>
+          </p:nvPr>
+        </p:nvGraphicFramePr>
+        <p:xfrm>
+          <a:off x="548640" y="2331720"/>
+          <a:ext cx="11064240" cy="914400"/>
+        </p:xfrm>
+        <a:graphic>
+          <a:graphicData uri="http://schemas.openxmlformats.org/drawingml/2006/table">
+            <a:tbl>
+              <a:tblPr/>
+              <a:tblGrid>
+                <a:gridCol w="2011680"/>
+                <a:gridCol w="1371600"/>
+                <a:gridCol w="1371600"/>
+                <a:gridCol w="1371600"/>
+                <a:gridCol w="1645920"/>
+                <a:gridCol w="3291840"/>
+              </a:tblGrid>
+              <a:tr h="438912">
+                <a:tc>
+                  <a:txBody>
+                    <a:bodyPr/>
+                    <a:lstStyle/>
+                    <a:p>
+                      <a:pPr indent="0" marL="0">
+                        <a:buNone/>
+                      </a:pPr>
+                      <a:r>
+                        <a:rPr lang="en-US" sz="1700" dirty="0">
+                          <a:solidFill>
+                            <a:srgbClr val="213B45"/>
+                          </a:solidFill>
+                        </a:rPr>
+                        <a:t>材料情景</a:t>
+                      </a:r>
+                      <a:endParaRPr lang="en-US" sz="1700" dirty="0"/>
+                    </a:p>
+                  </a:txBody>
+                  <a:tcPr marL="109728" marR="109728" marT="109728" marB="109728">
+                    <a:lnL w="6350" cap="flat" cmpd="sng" algn="ctr">
+                      <a:solidFill>
+                        <a:srgbClr val="D5DEDA"/>
+                      </a:solidFill>
+                      <a:prstDash val="solid"/>
+                      <a:round/>
+                      <a:headEnd type="none" w="med" len="med"/>
+                      <a:tailEnd type="none" w="med" len="med"/>
+                    </a:lnL>
+                    <a:lnR w="6350" cap="flat" cmpd="sng" algn="ctr">
+                      <a:solidFill>
+                        <a:srgbClr val="D5DEDA"/>
+                      </a:solidFill>
+                      <a:prstDash val="solid"/>
+                      <a:round/>
+                      <a:headEnd type="none" w="med" len="med"/>
+                      <a:tailEnd type="none" w="med" len="med"/>
+                    </a:lnR>
+                    <a:lnT w="6350" cap="flat" cmpd="sng" algn="ctr">
+                      <a:solidFill>
+                        <a:srgbClr val="D5DEDA"/>
+                      </a:solidFill>
+                      <a:prstDash val="solid"/>
+                      <a:round/>
+                      <a:headEnd type="none" w="med" len="med"/>
+                      <a:tailEnd type="none" w="med" len="med"/>
+                    </a:lnT>
+                    <a:lnB w="6350" cap="flat" cmpd="sng" algn="ctr">
+                      <a:solidFill>
+                        <a:srgbClr val="D5DEDA"/>
+                      </a:solidFill>
+                      <a:prstDash val="solid"/>
+                      <a:round/>
+                      <a:headEnd type="none" w="med" len="med"/>
+                      <a:tailEnd type="none" w="med" len="med"/>
+                    </a:lnB>
+                    <a:solidFill>
+                      <a:srgbClr val="FFFFFF"/>
+                    </a:solidFill>
+                  </a:tcPr>
+                </a:tc>
+                <a:tc>
+                  <a:txBody>
+                    <a:bodyPr/>
+                    <a:lstStyle/>
+                    <a:p>
+                      <a:pPr indent="0" marL="0">
+                        <a:buNone/>
+                      </a:pPr>
+                      <a:r>
+                        <a:rPr lang="en-US" sz="1700" dirty="0">
+                          <a:solidFill>
+                            <a:srgbClr val="213B45"/>
+                          </a:solidFill>
+                        </a:rPr>
+                        <a:t>EBITDA</a:t>
+                      </a:r>
+                      <a:endParaRPr lang="en-US" sz="1700" dirty="0"/>
+                    </a:p>
+                  </a:txBody>
+                  <a:tcPr marL="109728" marR="109728" marT="109728" marB="109728">
+                    <a:lnL w="6350" cap="flat" cmpd="sng" algn="ctr">
+                      <a:solidFill>
+                        <a:srgbClr val="D5DEDA"/>
+                      </a:solidFill>
+                      <a:prstDash val="solid"/>
+                      <a:round/>
+                      <a:headEnd type="none" w="med" len="med"/>
+                      <a:tailEnd type="none" w="med" len="med"/>
+                    </a:lnL>
+                    <a:lnR w="6350" cap="flat" cmpd="sng" algn="ctr">
+                      <a:solidFill>
+                        <a:srgbClr val="D5DEDA"/>
+                      </a:solidFill>
+                      <a:prstDash val="solid"/>
+                      <a:round/>
+                      <a:headEnd type="none" w="med" len="med"/>
+                      <a:tailEnd type="none" w="med" len="med"/>
+                    </a:lnR>
+                    <a:lnT w="6350" cap="flat" cmpd="sng" algn="ctr">
+                      <a:solidFill>
+                        <a:srgbClr val="D5DEDA"/>
+                      </a:solidFill>
+                      <a:prstDash val="solid"/>
+                      <a:round/>
+                      <a:headEnd type="none" w="med" len="med"/>
+                      <a:tailEnd type="none" w="med" len="med"/>
+                    </a:lnT>
+                    <a:lnB w="6350" cap="flat" cmpd="sng" algn="ctr">
+                      <a:solidFill>
+                        <a:srgbClr val="D5DEDA"/>
+                      </a:solidFill>
+                      <a:prstDash val="solid"/>
+                      <a:round/>
+                      <a:headEnd type="none" w="med" len="med"/>
+                      <a:tailEnd type="none" w="med" len="med"/>
+                    </a:lnB>
+                    <a:solidFill>
+                      <a:srgbClr val="FFFFFF"/>
+                    </a:solidFill>
+                  </a:tcPr>
+                </a:tc>
+                <a:tc>
+                  <a:txBody>
+                    <a:bodyPr/>
+                    <a:lstStyle/>
+                    <a:p>
+                      <a:pPr indent="0" marL="0">
+                        <a:buNone/>
+                      </a:pPr>
+                      <a:r>
+                        <a:rPr lang="en-US" sz="1700" dirty="0">
+                          <a:solidFill>
+                            <a:srgbClr val="213B45"/>
+                          </a:solidFill>
+                        </a:rPr>
+                        <a:t>净利润</a:t>
+                      </a:r>
+                      <a:endParaRPr lang="en-US" sz="1700" dirty="0"/>
+                    </a:p>
+                  </a:txBody>
+                  <a:tcPr marL="109728" marR="109728" marT="109728" marB="109728">
+                    <a:lnL w="6350" cap="flat" cmpd="sng" algn="ctr">
+                      <a:solidFill>
+                        <a:srgbClr val="D5DEDA"/>
+                      </a:solidFill>
+                      <a:prstDash val="solid"/>
+                      <a:round/>
+                      <a:headEnd type="none" w="med" len="med"/>
+                      <a:tailEnd type="none" w="med" len="med"/>
+                    </a:lnL>
+                    <a:lnR w="6350" cap="flat" cmpd="sng" algn="ctr">
+                      <a:solidFill>
+                        <a:srgbClr val="D5DEDA"/>
+                      </a:solidFill>
+                      <a:prstDash val="solid"/>
+                      <a:round/>
+                      <a:headEnd type="none" w="med" len="med"/>
+                      <a:tailEnd type="none" w="med" len="med"/>
+                    </a:lnR>
+                    <a:lnT w="6350" cap="flat" cmpd="sng" algn="ctr">
+                      <a:solidFill>
+                        <a:srgbClr val="D5DEDA"/>
+                      </a:solidFill>
+                      <a:prstDash val="solid"/>
+                      <a:round/>
+                      <a:headEnd type="none" w="med" len="med"/>
+                      <a:tailEnd type="none" w="med" len="med"/>
+                    </a:lnT>
+                    <a:lnB w="6350" cap="flat" cmpd="sng" algn="ctr">
+                      <a:solidFill>
+                        <a:srgbClr val="D5DEDA"/>
+                      </a:solidFill>
+                      <a:prstDash val="solid"/>
+                      <a:round/>
+                      <a:headEnd type="none" w="med" len="med"/>
+                      <a:tailEnd type="none" w="med" len="med"/>
+                    </a:lnB>
+                    <a:solidFill>
+                      <a:srgbClr val="FFFFFF"/>
+                    </a:solidFill>
+                  </a:tcPr>
+                </a:tc>
+                <a:tc>
+                  <a:txBody>
+                    <a:bodyPr/>
+                    <a:lstStyle/>
+                    <a:p>
+                      <a:pPr indent="0" marL="0">
+                        <a:buNone/>
+                      </a:pPr>
+                      <a:r>
+                        <a:rPr lang="en-US" sz="1700" dirty="0">
+                          <a:solidFill>
+                            <a:srgbClr val="213B45"/>
+                          </a:solidFill>
+                        </a:rPr>
+                        <a:t>CFO</a:t>
+                      </a:r>
+                      <a:endParaRPr lang="en-US" sz="1700" dirty="0"/>
+                    </a:p>
+                  </a:txBody>
+                  <a:tcPr marL="109728" marR="109728" marT="109728" marB="109728">
+                    <a:lnL w="6350" cap="flat" cmpd="sng" algn="ctr">
+                      <a:solidFill>
+                        <a:srgbClr val="D5DEDA"/>
+                      </a:solidFill>
+                      <a:prstDash val="solid"/>
+                      <a:round/>
+                      <a:headEnd type="none" w="med" len="med"/>
+                      <a:tailEnd type="none" w="med" len="med"/>
+                    </a:lnL>
+                    <a:lnR w="6350" cap="flat" cmpd="sng" algn="ctr">
+                      <a:solidFill>
+                        <a:srgbClr val="D5DEDA"/>
+                      </a:solidFill>
+                      <a:prstDash val="solid"/>
+                      <a:round/>
+                      <a:headEnd type="none" w="med" len="med"/>
+                      <a:tailEnd type="none" w="med" len="med"/>
+                    </a:lnR>
+                    <a:lnT w="6350" cap="flat" cmpd="sng" algn="ctr">
+                      <a:solidFill>
+                        <a:srgbClr val="D5DEDA"/>
+                      </a:solidFill>
+                      <a:prstDash val="solid"/>
+                      <a:round/>
+                      <a:headEnd type="none" w="med" len="med"/>
+                      <a:tailEnd type="none" w="med" len="med"/>
+                    </a:lnT>
+                    <a:lnB w="6350" cap="flat" cmpd="sng" algn="ctr">
+                      <a:solidFill>
+                        <a:srgbClr val="D5DEDA"/>
+                      </a:solidFill>
+                      <a:prstDash val="solid"/>
+                      <a:round/>
+                      <a:headEnd type="none" w="med" len="med"/>
+                      <a:tailEnd type="none" w="med" len="med"/>
+                    </a:lnB>
+                    <a:solidFill>
+                      <a:srgbClr val="FFFFFF"/>
+                    </a:solidFill>
+                  </a:tcPr>
+                </a:tc>
+                <a:tc>
+                  <a:txBody>
+                    <a:bodyPr/>
+                    <a:lstStyle/>
+                    <a:p>
+                      <a:pPr indent="0" marL="0">
+                        <a:buNone/>
+                      </a:pPr>
+                      <a:r>
+                        <a:rPr lang="en-US" sz="1700" dirty="0">
+                          <a:solidFill>
+                            <a:srgbClr val="213B45"/>
+                          </a:solidFill>
+                        </a:rPr>
+                        <a:t>期末债务</a:t>
+                      </a:r>
+                      <a:endParaRPr lang="en-US" sz="1700" dirty="0"/>
+                    </a:p>
+                  </a:txBody>
+                  <a:tcPr marL="109728" marR="109728" marT="109728" marB="109728">
+                    <a:lnL w="6350" cap="flat" cmpd="sng" algn="ctr">
+                      <a:solidFill>
+                        <a:srgbClr val="D5DEDA"/>
+                      </a:solidFill>
+                      <a:prstDash val="solid"/>
+                      <a:round/>
+                      <a:headEnd type="none" w="med" len="med"/>
+                      <a:tailEnd type="none" w="med" len="med"/>
+                    </a:lnL>
+                    <a:lnR w="6350" cap="flat" cmpd="sng" algn="ctr">
+                      <a:solidFill>
+                        <a:srgbClr val="D5DEDA"/>
+                      </a:solidFill>
+                      <a:prstDash val="solid"/>
+                      <a:round/>
+                      <a:headEnd type="none" w="med" len="med"/>
+                      <a:tailEnd type="none" w="med" len="med"/>
+                    </a:lnR>
+                    <a:lnT w="6350" cap="flat" cmpd="sng" algn="ctr">
+                      <a:solidFill>
+                        <a:srgbClr val="D5DEDA"/>
+                      </a:solidFill>
+                      <a:prstDash val="solid"/>
+                      <a:round/>
+                      <a:headEnd type="none" w="med" len="med"/>
+                      <a:tailEnd type="none" w="med" len="med"/>
+                    </a:lnT>
+                    <a:lnB w="6350" cap="flat" cmpd="sng" algn="ctr">
+                      <a:solidFill>
+                        <a:srgbClr val="D5DEDA"/>
+                      </a:solidFill>
+                      <a:prstDash val="solid"/>
+                      <a:round/>
+                      <a:headEnd type="none" w="med" len="med"/>
+                      <a:tailEnd type="none" w="med" len="med"/>
+                    </a:lnB>
+                    <a:solidFill>
+                      <a:srgbClr val="FFFFFF"/>
+                    </a:solidFill>
+                  </a:tcPr>
+                </a:tc>
+                <a:tc>
+                  <a:txBody>
+                    <a:bodyPr/>
+                    <a:lstStyle/>
+                    <a:p>
+                      <a:pPr indent="0" marL="0">
+                        <a:buNone/>
+                      </a:pPr>
+                      <a:r>
+                        <a:rPr lang="en-US" sz="1700" dirty="0">
+                          <a:solidFill>
+                            <a:srgbClr val="213B45"/>
+                          </a:solidFill>
+                        </a:rPr>
+                        <a:t>财务分 / 档</a:t>
+                      </a:r>
+                      <a:endParaRPr lang="en-US" sz="1700" dirty="0"/>
+                    </a:p>
+                  </a:txBody>
+                  <a:tcPr marL="109728" marR="109728" marT="109728" marB="109728">
+                    <a:lnL w="6350" cap="flat" cmpd="sng" algn="ctr">
+                      <a:solidFill>
+                        <a:srgbClr val="D5DEDA"/>
+                      </a:solidFill>
+                      <a:prstDash val="solid"/>
+                      <a:round/>
+                      <a:headEnd type="none" w="med" len="med"/>
+                      <a:tailEnd type="none" w="med" len="med"/>
+                    </a:lnL>
+                    <a:lnR w="6350" cap="flat" cmpd="sng" algn="ctr">
+                      <a:solidFill>
+                        <a:srgbClr val="D5DEDA"/>
+                      </a:solidFill>
+                      <a:prstDash val="solid"/>
+                      <a:round/>
+                      <a:headEnd type="none" w="med" len="med"/>
+                      <a:tailEnd type="none" w="med" len="med"/>
+                    </a:lnR>
+                    <a:lnT w="6350" cap="flat" cmpd="sng" algn="ctr">
+                      <a:solidFill>
+                        <a:srgbClr val="D5DEDA"/>
+                      </a:solidFill>
+                      <a:prstDash val="solid"/>
+                      <a:round/>
+                      <a:headEnd type="none" w="med" len="med"/>
+                      <a:tailEnd type="none" w="med" len="med"/>
+                    </a:lnT>
+                    <a:lnB w="6350" cap="flat" cmpd="sng" algn="ctr">
+                      <a:solidFill>
+                        <a:srgbClr val="D5DEDA"/>
+                      </a:solidFill>
+                      <a:prstDash val="solid"/>
+                      <a:round/>
+                      <a:headEnd type="none" w="med" len="med"/>
+                      <a:tailEnd type="none" w="med" len="med"/>
+                    </a:lnB>
+                    <a:solidFill>
+                      <a:srgbClr val="FFFFFF"/>
+                    </a:solidFill>
+                  </a:tcPr>
+                </a:tc>
+              </a:tr>
+              <a:tr h="438912">
+                <a:tc>
+                  <a:txBody>
+                    <a:bodyPr/>
+                    <a:lstStyle/>
+                    <a:p>
+                      <a:pPr indent="0" marL="0">
+                        <a:buNone/>
+                      </a:pPr>
+                      <a:r>
+                        <a:rPr lang="en-US" sz="1700" dirty="0">
+                          <a:solidFill>
+                            <a:srgbClr val="213B45"/>
+                          </a:solidFill>
+                        </a:rPr>
+                        <a:t>材料不涨价</a:t>
+                      </a:r>
+                      <a:endParaRPr lang="en-US" sz="1700" dirty="0"/>
+                    </a:p>
+                  </a:txBody>
+                  <a:tcPr marL="109728" marR="109728" marT="109728" marB="109728">
+                    <a:lnL w="6350" cap="flat" cmpd="sng" algn="ctr">
+                      <a:solidFill>
+                        <a:srgbClr val="D5DEDA"/>
+                      </a:solidFill>
+                      <a:prstDash val="solid"/>
+                      <a:round/>
+                      <a:headEnd type="none" w="med" len="med"/>
+                      <a:tailEnd type="none" w="med" len="med"/>
+                    </a:lnL>
+                    <a:lnR w="6350" cap="flat" cmpd="sng" algn="ctr">
+                      <a:solidFill>
+                        <a:srgbClr val="D5DEDA"/>
+                      </a:solidFill>
+                      <a:prstDash val="solid"/>
+                      <a:round/>
+                      <a:headEnd type="none" w="med" len="med"/>
+                      <a:tailEnd type="none" w="med" len="med"/>
+                    </a:lnR>
+                    <a:lnT w="6350" cap="flat" cmpd="sng" algn="ctr">
+                      <a:solidFill>
+                        <a:srgbClr val="D5DEDA"/>
+                      </a:solidFill>
+                      <a:prstDash val="solid"/>
+                      <a:round/>
+                      <a:headEnd type="none" w="med" len="med"/>
+                      <a:tailEnd type="none" w="med" len="med"/>
+                    </a:lnT>
+                    <a:lnB w="6350" cap="flat" cmpd="sng" algn="ctr">
+                      <a:solidFill>
+                        <a:srgbClr val="D5DEDA"/>
+                      </a:solidFill>
+                      <a:prstDash val="solid"/>
+                      <a:round/>
+                      <a:headEnd type="none" w="med" len="med"/>
+                      <a:tailEnd type="none" w="med" len="med"/>
+                    </a:lnB>
+                    <a:solidFill>
+                      <a:srgbClr val="FFFFFF"/>
+                    </a:solidFill>
+                  </a:tcPr>
+                </a:tc>
+                <a:tc>
+                  <a:txBody>
+                    <a:bodyPr/>
+                    <a:lstStyle/>
+                    <a:p>
+                      <a:pPr indent="0" marL="0">
+                        <a:buNone/>
+                      </a:pPr>
+                      <a:r>
+                        <a:rPr lang="en-US" sz="1700" dirty="0">
+                          <a:solidFill>
+                            <a:srgbClr val="213B45"/>
+                          </a:solidFill>
+                        </a:rPr>
+                        <a:t>4.59</a:t>
+                      </a:r>
+                      <a:endParaRPr lang="en-US" sz="1700" dirty="0"/>
+                    </a:p>
+                  </a:txBody>
+                  <a:tcPr marL="109728" marR="109728" marT="109728" marB="109728">
+                    <a:lnL w="6350" cap="flat" cmpd="sng" algn="ctr">
+                      <a:solidFill>
+                        <a:srgbClr val="D5DEDA"/>
+                      </a:solidFill>
+                      <a:prstDash val="solid"/>
+                      <a:round/>
+                      <a:headEnd type="none" w="med" len="med"/>
+                      <a:tailEnd type="none" w="med" len="med"/>
+                    </a:lnL>
+                    <a:lnR w="6350" cap="flat" cmpd="sng" algn="ctr">
+                      <a:solidFill>
+                        <a:srgbClr val="D5DEDA"/>
+                      </a:solidFill>
+                      <a:prstDash val="solid"/>
+                      <a:round/>
+                      <a:headEnd type="none" w="med" len="med"/>
+                      <a:tailEnd type="none" w="med" len="med"/>
+                    </a:lnR>
+                    <a:lnT w="6350" cap="flat" cmpd="sng" algn="ctr">
+                      <a:solidFill>
+                        <a:srgbClr val="D5DEDA"/>
+                      </a:solidFill>
+                      <a:prstDash val="solid"/>
+                      <a:round/>
+                      <a:headEnd type="none" w="med" len="med"/>
+                      <a:tailEnd type="none" w="med" len="med"/>
+                    </a:lnT>
+                    <a:lnB w="6350" cap="flat" cmpd="sng" algn="ctr">
+                      <a:solidFill>
+                        <a:srgbClr val="D5DEDA"/>
+                      </a:solidFill>
+                      <a:prstDash val="solid"/>
+                      <a:round/>
+                      <a:headEnd type="none" w="med" len="med"/>
+                      <a:tailEnd type="none" w="med" len="med"/>
+                    </a:lnB>
+                    <a:solidFill>
+                      <a:srgbClr val="FFFFFF"/>
+                    </a:solidFill>
+                  </a:tcPr>
+                </a:tc>
+                <a:tc>
+                  <a:txBody>
+                    <a:bodyPr/>
+                    <a:lstStyle/>
+                    <a:p>
+                      <a:pPr indent="0" marL="0">
+                        <a:buNone/>
+                      </a:pPr>
+                      <a:r>
+                        <a:rPr lang="en-US" sz="1700" dirty="0">
+                          <a:solidFill>
+                            <a:srgbClr val="213B45"/>
+                          </a:solidFill>
+                        </a:rPr>
+                        <a:t>-0.21</a:t>
+                      </a:r>
+                      <a:endParaRPr lang="en-US" sz="1700" dirty="0"/>
+                    </a:p>
+                  </a:txBody>
+                  <a:tcPr marL="109728" marR="109728" marT="109728" marB="109728">
+                    <a:lnL w="6350" cap="flat" cmpd="sng" algn="ctr">
+                      <a:solidFill>
+                        <a:srgbClr val="D5DEDA"/>
+                      </a:solidFill>
+                      <a:prstDash val="solid"/>
+                      <a:round/>
+                      <a:headEnd type="none" w="med" len="med"/>
+                      <a:tailEnd type="none" w="med" len="med"/>
+                    </a:lnL>
+                    <a:lnR w="6350" cap="flat" cmpd="sng" algn="ctr">
+                      <a:solidFill>
+                        <a:srgbClr val="D5DEDA"/>
+                      </a:solidFill>
+                      <a:prstDash val="solid"/>
+                      <a:round/>
+                      <a:headEnd type="none" w="med" len="med"/>
+                      <a:tailEnd type="none" w="med" len="med"/>
+                    </a:lnR>
+                    <a:lnT w="6350" cap="flat" cmpd="sng" algn="ctr">
+                      <a:solidFill>
+                        <a:srgbClr val="D5DEDA"/>
+                      </a:solidFill>
+                      <a:prstDash val="solid"/>
+                      <a:round/>
+                      <a:headEnd type="none" w="med" len="med"/>
+                      <a:tailEnd type="none" w="med" len="med"/>
+                    </a:lnT>
+                    <a:lnB w="6350" cap="flat" cmpd="sng" algn="ctr">
+                      <a:solidFill>
+                        <a:srgbClr val="D5DEDA"/>
+                      </a:solidFill>
+                      <a:prstDash val="solid"/>
+                      <a:round/>
+                      <a:headEnd type="none" w="med" len="med"/>
+                      <a:tailEnd type="none" w="med" len="med"/>
+                    </a:lnB>
+                    <a:solidFill>
+                      <a:srgbClr val="FFFFFF"/>
+                    </a:solidFill>
+                  </a:tcPr>
+                </a:tc>
+                <a:tc>
+                  <a:txBody>
+                    <a:bodyPr/>
+                    <a:lstStyle/>
+                    <a:p>
+                      <a:pPr indent="0" marL="0">
+                        <a:buNone/>
+                      </a:pPr>
+                      <a:r>
+                        <a:rPr lang="en-US" sz="1700" dirty="0">
+                          <a:solidFill>
+                            <a:srgbClr val="213B45"/>
+                          </a:solidFill>
+                        </a:rPr>
+                        <a:t>3.36</a:t>
+                      </a:r>
+                      <a:endParaRPr lang="en-US" sz="1700" dirty="0"/>
+                    </a:p>
+                  </a:txBody>
+                  <a:tcPr marL="109728" marR="109728" marT="109728" marB="109728">
+                    <a:lnL w="6350" cap="flat" cmpd="sng" algn="ctr">
+                      <a:solidFill>
+                        <a:srgbClr val="D5DEDA"/>
+                      </a:solidFill>
+                      <a:prstDash val="solid"/>
+                      <a:round/>
+                      <a:headEnd type="none" w="med" len="med"/>
+                      <a:tailEnd type="none" w="med" len="med"/>
+                    </a:lnL>
+                    <a:lnR w="6350" cap="flat" cmpd="sng" algn="ctr">
+                      <a:solidFill>
+                        <a:srgbClr val="D5DEDA"/>
+                      </a:solidFill>
+                      <a:prstDash val="solid"/>
+                      <a:round/>
+                      <a:headEnd type="none" w="med" len="med"/>
+                      <a:tailEnd type="none" w="med" len="med"/>
+                    </a:lnR>
+                    <a:lnT w="6350" cap="flat" cmpd="sng" algn="ctr">
+                      <a:solidFill>
+                        <a:srgbClr val="D5DEDA"/>
+                      </a:solidFill>
+                      <a:prstDash val="solid"/>
+                      <a:round/>
+                      <a:headEnd type="none" w="med" len="med"/>
+                      <a:tailEnd type="none" w="med" len="med"/>
+                    </a:lnT>
+                    <a:lnB w="6350" cap="flat" cmpd="sng" algn="ctr">
+                      <a:solidFill>
+                        <a:srgbClr val="D5DEDA"/>
+                      </a:solidFill>
+                      <a:prstDash val="solid"/>
+                      <a:round/>
+                      <a:headEnd type="none" w="med" len="med"/>
+                      <a:tailEnd type="none" w="med" len="med"/>
+                    </a:lnB>
+                    <a:solidFill>
+                      <a:srgbClr val="FFFFFF"/>
+                    </a:solidFill>
+                  </a:tcPr>
+                </a:tc>
+                <a:tc>
+                  <a:txBody>
+                    <a:bodyPr/>
+                    <a:lstStyle/>
+                    <a:p>
+                      <a:pPr indent="0" marL="0">
+                        <a:buNone/>
+                      </a:pPr>
+                      <a:r>
+                        <a:rPr lang="en-US" sz="1700" dirty="0">
+                          <a:solidFill>
+                            <a:srgbClr val="213B45"/>
+                          </a:solidFill>
+                        </a:rPr>
+                        <a:t>44.02</a:t>
+                      </a:r>
+                      <a:endParaRPr lang="en-US" sz="1700" dirty="0"/>
+                    </a:p>
+                  </a:txBody>
+                  <a:tcPr marL="109728" marR="109728" marT="109728" marB="109728">
+                    <a:lnL w="6350" cap="flat" cmpd="sng" algn="ctr">
+                      <a:solidFill>
+                        <a:srgbClr val="D5DEDA"/>
+                      </a:solidFill>
+                      <a:prstDash val="solid"/>
+                      <a:round/>
+                      <a:headEnd type="none" w="med" len="med"/>
+                      <a:tailEnd type="none" w="med" len="med"/>
+                    </a:lnL>
+                    <a:lnR w="6350" cap="flat" cmpd="sng" algn="ctr">
+                      <a:solidFill>
+                        <a:srgbClr val="D5DEDA"/>
+                      </a:solidFill>
+                      <a:prstDash val="solid"/>
+                      <a:round/>
+                      <a:headEnd type="none" w="med" len="med"/>
+                      <a:tailEnd type="none" w="med" len="med"/>
+                    </a:lnR>
+                    <a:lnT w="6350" cap="flat" cmpd="sng" algn="ctr">
+                      <a:solidFill>
+                        <a:srgbClr val="D5DEDA"/>
+                      </a:solidFill>
+                      <a:prstDash val="solid"/>
+                      <a:round/>
+                      <a:headEnd type="none" w="med" len="med"/>
+                      <a:tailEnd type="none" w="med" len="med"/>
+                    </a:lnT>
+                    <a:lnB w="6350" cap="flat" cmpd="sng" algn="ctr">
+                      <a:solidFill>
+                        <a:srgbClr val="D5DEDA"/>
+                      </a:solidFill>
+                      <a:prstDash val="solid"/>
+                      <a:round/>
+                      <a:headEnd type="none" w="med" len="med"/>
+                      <a:tailEnd type="none" w="med" len="med"/>
+                    </a:lnB>
+                    <a:solidFill>
+                      <a:srgbClr val="FFFFFF"/>
+                    </a:solidFill>
+                  </a:tcPr>
+                </a:tc>
+                <a:tc>
+                  <a:txBody>
+                    <a:bodyPr/>
+                    <a:lstStyle/>
+                    <a:p>
+                      <a:pPr indent="0" marL="0">
+                        <a:buNone/>
+                      </a:pPr>
+                      <a:r>
+                        <a:rPr lang="en-US" sz="1700" dirty="0">
+                          <a:solidFill>
+                            <a:srgbClr val="213B45"/>
+                          </a:solidFill>
+                        </a:rPr>
+                        <a:t>4.61625 / F3</a:t>
+                      </a:r>
+                      <a:endParaRPr lang="en-US" sz="1700" dirty="0"/>
+                    </a:p>
+                  </a:txBody>
+                  <a:tcPr marL="109728" marR="109728" marT="109728" marB="109728">
+                    <a:lnL w="6350" cap="flat" cmpd="sng" algn="ctr">
+                      <a:solidFill>
+                        <a:srgbClr val="D5DEDA"/>
+                      </a:solidFill>
+                      <a:prstDash val="solid"/>
+                      <a:round/>
+                      <a:headEnd type="none" w="med" len="med"/>
+                      <a:tailEnd type="none" w="med" len="med"/>
+                    </a:lnL>
+                    <a:lnR w="6350" cap="flat" cmpd="sng" algn="ctr">
+                      <a:solidFill>
+                        <a:srgbClr val="D5DEDA"/>
+                      </a:solidFill>
+                      <a:prstDash val="solid"/>
+                      <a:round/>
+                      <a:headEnd type="none" w="med" len="med"/>
+                      <a:tailEnd type="none" w="med" len="med"/>
+                    </a:lnR>
+                    <a:lnT w="6350" cap="flat" cmpd="sng" algn="ctr">
+                      <a:solidFill>
+                        <a:srgbClr val="D5DEDA"/>
+                      </a:solidFill>
+                      <a:prstDash val="solid"/>
+                      <a:round/>
+                      <a:headEnd type="none" w="med" len="med"/>
+                      <a:tailEnd type="none" w="med" len="med"/>
+                    </a:lnT>
+                    <a:lnB w="6350" cap="flat" cmpd="sng" algn="ctr">
+                      <a:solidFill>
+                        <a:srgbClr val="D5DEDA"/>
+                      </a:solidFill>
+                      <a:prstDash val="solid"/>
+                      <a:round/>
+                      <a:headEnd type="none" w="med" len="med"/>
+                      <a:tailEnd type="none" w="med" len="med"/>
+                    </a:lnB>
+                    <a:solidFill>
+                      <a:srgbClr val="FFFFFF"/>
+                    </a:solidFill>
+                  </a:tcPr>
+                </a:tc>
+              </a:tr>
+              <a:tr h="438912">
+                <a:tc>
+                  <a:txBody>
+                    <a:bodyPr/>
+                    <a:lstStyle/>
+                    <a:p>
+                      <a:pPr indent="0" marL="0">
+                        <a:buNone/>
+                      </a:pPr>
+                      <a:r>
+                        <a:rPr lang="en-US" sz="1700" dirty="0">
+                          <a:solidFill>
+                            <a:srgbClr val="213B45"/>
+                          </a:solidFill>
+                        </a:rPr>
+                        <a:t>材料+5%</a:t>
+                      </a:r>
+                      <a:endParaRPr lang="en-US" sz="1700" dirty="0"/>
+                    </a:p>
+                  </a:txBody>
+                  <a:tcPr marL="109728" marR="109728" marT="109728" marB="109728">
+                    <a:lnL w="6350" cap="flat" cmpd="sng" algn="ctr">
+                      <a:solidFill>
+                        <a:srgbClr val="D5DEDA"/>
+                      </a:solidFill>
+                      <a:prstDash val="solid"/>
+                      <a:round/>
+                      <a:headEnd type="none" w="med" len="med"/>
+                      <a:tailEnd type="none" w="med" len="med"/>
+                    </a:lnL>
+                    <a:lnR w="6350" cap="flat" cmpd="sng" algn="ctr">
+                      <a:solidFill>
+                        <a:srgbClr val="D5DEDA"/>
+                      </a:solidFill>
+                      <a:prstDash val="solid"/>
+                      <a:round/>
+                      <a:headEnd type="none" w="med" len="med"/>
+                      <a:tailEnd type="none" w="med" len="med"/>
+                    </a:lnR>
+                    <a:lnT w="6350" cap="flat" cmpd="sng" algn="ctr">
+                      <a:solidFill>
+                        <a:srgbClr val="D5DEDA"/>
+                      </a:solidFill>
+                      <a:prstDash val="solid"/>
+                      <a:round/>
+                      <a:headEnd type="none" w="med" len="med"/>
+                      <a:tailEnd type="none" w="med" len="med"/>
+                    </a:lnT>
+                    <a:lnB w="6350" cap="flat" cmpd="sng" algn="ctr">
+                      <a:solidFill>
+                        <a:srgbClr val="D5DEDA"/>
+                      </a:solidFill>
+                      <a:prstDash val="solid"/>
+                      <a:round/>
+                      <a:headEnd type="none" w="med" len="med"/>
+                      <a:tailEnd type="none" w="med" len="med"/>
+                    </a:lnB>
+                    <a:solidFill>
+                      <a:srgbClr val="FFFFFF"/>
+                    </a:solidFill>
+                  </a:tcPr>
+                </a:tc>
+                <a:tc>
+                  <a:txBody>
+                    <a:bodyPr/>
+                    <a:lstStyle/>
+                    <a:p>
+                      <a:pPr indent="0" marL="0">
+                        <a:buNone/>
+                      </a:pPr>
+                      <a:r>
+                        <a:rPr lang="en-US" sz="1700" dirty="0">
+                          <a:solidFill>
+                            <a:srgbClr val="213B45"/>
+                          </a:solidFill>
+                        </a:rPr>
+                        <a:t>3.54</a:t>
+                      </a:r>
+                      <a:endParaRPr lang="en-US" sz="1700" dirty="0"/>
+                    </a:p>
+                  </a:txBody>
+                  <a:tcPr marL="109728" marR="109728" marT="109728" marB="109728">
+                    <a:lnL w="6350" cap="flat" cmpd="sng" algn="ctr">
+                      <a:solidFill>
+                        <a:srgbClr val="D5DEDA"/>
+                      </a:solidFill>
+                      <a:prstDash val="solid"/>
+                      <a:round/>
+                      <a:headEnd type="none" w="med" len="med"/>
+                      <a:tailEnd type="none" w="med" len="med"/>
+                    </a:lnL>
+                    <a:lnR w="6350" cap="flat" cmpd="sng" algn="ctr">
+                      <a:solidFill>
+                        <a:srgbClr val="D5DEDA"/>
+                      </a:solidFill>
+                      <a:prstDash val="solid"/>
+                      <a:round/>
+                      <a:headEnd type="none" w="med" len="med"/>
+                      <a:tailEnd type="none" w="med" len="med"/>
+                    </a:lnR>
+                    <a:lnT w="6350" cap="flat" cmpd="sng" algn="ctr">
+                      <a:solidFill>
+                        <a:srgbClr val="D5DEDA"/>
+                      </a:solidFill>
+                      <a:prstDash val="solid"/>
+                      <a:round/>
+                      <a:headEnd type="none" w="med" len="med"/>
+                      <a:tailEnd type="none" w="med" len="med"/>
+                    </a:lnT>
+                    <a:lnB w="6350" cap="flat" cmpd="sng" algn="ctr">
+                      <a:solidFill>
+                        <a:srgbClr val="D5DEDA"/>
+                      </a:solidFill>
+                      <a:prstDash val="solid"/>
+                      <a:round/>
+                      <a:headEnd type="none" w="med" len="med"/>
+                      <a:tailEnd type="none" w="med" len="med"/>
+                    </a:lnB>
+                    <a:solidFill>
+                      <a:srgbClr val="FFFFFF"/>
+                    </a:solidFill>
+                  </a:tcPr>
+                </a:tc>
+                <a:tc>
+                  <a:txBody>
+                    <a:bodyPr/>
+                    <a:lstStyle/>
+                    <a:p>
+                      <a:pPr indent="0" marL="0">
+                        <a:buNone/>
+                      </a:pPr>
+                      <a:r>
+                        <a:rPr lang="en-US" sz="1700" dirty="0">
+                          <a:solidFill>
+                            <a:srgbClr val="213B45"/>
+                          </a:solidFill>
+                        </a:rPr>
+                        <a:t>-1.28</a:t>
+                      </a:r>
+                      <a:endParaRPr lang="en-US" sz="1700" dirty="0"/>
+                    </a:p>
+                  </a:txBody>
+                  <a:tcPr marL="109728" marR="109728" marT="109728" marB="109728">
+                    <a:lnL w="6350" cap="flat" cmpd="sng" algn="ctr">
+                      <a:solidFill>
+                        <a:srgbClr val="D5DEDA"/>
+                      </a:solidFill>
+                      <a:prstDash val="solid"/>
+                      <a:round/>
+                      <a:headEnd type="none" w="med" len="med"/>
+                      <a:tailEnd type="none" w="med" len="med"/>
+                    </a:lnL>
+                    <a:lnR w="6350" cap="flat" cmpd="sng" algn="ctr">
+                      <a:solidFill>
+                        <a:srgbClr val="D5DEDA"/>
+                      </a:solidFill>
+                      <a:prstDash val="solid"/>
+                      <a:round/>
+                      <a:headEnd type="none" w="med" len="med"/>
+                      <a:tailEnd type="none" w="med" len="med"/>
+                    </a:lnR>
+                    <a:lnT w="6350" cap="flat" cmpd="sng" algn="ctr">
+                      <a:solidFill>
+                        <a:srgbClr val="D5DEDA"/>
+                      </a:solidFill>
+                      <a:prstDash val="solid"/>
+                      <a:round/>
+                      <a:headEnd type="none" w="med" len="med"/>
+                      <a:tailEnd type="none" w="med" len="med"/>
+                    </a:lnT>
+                    <a:lnB w="6350" cap="flat" cmpd="sng" algn="ctr">
+                      <a:solidFill>
+                        <a:srgbClr val="D5DEDA"/>
+                      </a:solidFill>
+                      <a:prstDash val="solid"/>
+                      <a:round/>
+                      <a:headEnd type="none" w="med" len="med"/>
+                      <a:tailEnd type="none" w="med" len="med"/>
+                    </a:lnB>
+                    <a:solidFill>
+                      <a:srgbClr val="FFFFFF"/>
+                    </a:solidFill>
+                  </a:tcPr>
+                </a:tc>
+                <a:tc>
+                  <a:txBody>
+                    <a:bodyPr/>
+                    <a:lstStyle/>
+                    <a:p>
+                      <a:pPr indent="0" marL="0">
+                        <a:buNone/>
+                      </a:pPr>
+                      <a:r>
+                        <a:rPr lang="en-US" sz="1700" dirty="0">
+                          <a:solidFill>
+                            <a:srgbClr val="213B45"/>
+                          </a:solidFill>
+                        </a:rPr>
+                        <a:t>2.37</a:t>
+                      </a:r>
+                      <a:endParaRPr lang="en-US" sz="1700" dirty="0"/>
+                    </a:p>
+                  </a:txBody>
+                  <a:tcPr marL="109728" marR="109728" marT="109728" marB="109728">
+                    <a:lnL w="6350" cap="flat" cmpd="sng" algn="ctr">
+                      <a:solidFill>
+                        <a:srgbClr val="D5DEDA"/>
+                      </a:solidFill>
+                      <a:prstDash val="solid"/>
+                      <a:round/>
+                      <a:headEnd type="none" w="med" len="med"/>
+                      <a:tailEnd type="none" w="med" len="med"/>
+                    </a:lnL>
+                    <a:lnR w="6350" cap="flat" cmpd="sng" algn="ctr">
+                      <a:solidFill>
+                        <a:srgbClr val="D5DEDA"/>
+                      </a:solidFill>
+                      <a:prstDash val="solid"/>
+                      <a:round/>
+                      <a:headEnd type="none" w="med" len="med"/>
+                      <a:tailEnd type="none" w="med" len="med"/>
+                    </a:lnR>
+                    <a:lnT w="6350" cap="flat" cmpd="sng" algn="ctr">
+                      <a:solidFill>
+                        <a:srgbClr val="D5DEDA"/>
+                      </a:solidFill>
+                      <a:prstDash val="solid"/>
+                      <a:round/>
+                      <a:headEnd type="none" w="med" len="med"/>
+                      <a:tailEnd type="none" w="med" len="med"/>
+                    </a:lnT>
+                    <a:lnB w="6350" cap="flat" cmpd="sng" algn="ctr">
+                      <a:solidFill>
+                        <a:srgbClr val="D5DEDA"/>
+                      </a:solidFill>
+                      <a:prstDash val="solid"/>
+                      <a:round/>
+                      <a:headEnd type="none" w="med" len="med"/>
+                      <a:tailEnd type="none" w="med" len="med"/>
+                    </a:lnB>
+                    <a:solidFill>
+                      <a:srgbClr val="FFFFFF"/>
+                    </a:solidFill>
+                  </a:tcPr>
+                </a:tc>
+                <a:tc>
+                  <a:txBody>
+                    <a:bodyPr/>
+                    <a:lstStyle/>
+                    <a:p>
+                      <a:pPr indent="0" marL="0">
+                        <a:buNone/>
+                      </a:pPr>
+                      <a:r>
+                        <a:rPr lang="en-US" sz="1700" dirty="0">
+                          <a:solidFill>
+                            <a:srgbClr val="213B45"/>
+                          </a:solidFill>
+                        </a:rPr>
+                        <a:t>45.08</a:t>
+                      </a:r>
+                      <a:endParaRPr lang="en-US" sz="1700" dirty="0"/>
+                    </a:p>
+                  </a:txBody>
+                  <a:tcPr marL="109728" marR="109728" marT="109728" marB="109728">
+                    <a:lnL w="6350" cap="flat" cmpd="sng" algn="ctr">
+                      <a:solidFill>
+                        <a:srgbClr val="D5DEDA"/>
+                      </a:solidFill>
+                      <a:prstDash val="solid"/>
+                      <a:round/>
+                      <a:headEnd type="none" w="med" len="med"/>
+                      <a:tailEnd type="none" w="med" len="med"/>
+                    </a:lnL>
+                    <a:lnR w="6350" cap="flat" cmpd="sng" algn="ctr">
+                      <a:solidFill>
+                        <a:srgbClr val="D5DEDA"/>
+                      </a:solidFill>
+                      <a:prstDash val="solid"/>
+                      <a:round/>
+                      <a:headEnd type="none" w="med" len="med"/>
+                      <a:tailEnd type="none" w="med" len="med"/>
+                    </a:lnR>
+                    <a:lnT w="6350" cap="flat" cmpd="sng" algn="ctr">
+                      <a:solidFill>
+                        <a:srgbClr val="D5DEDA"/>
+                      </a:solidFill>
+                      <a:prstDash val="solid"/>
+                      <a:round/>
+                      <a:headEnd type="none" w="med" len="med"/>
+                      <a:tailEnd type="none" w="med" len="med"/>
+                    </a:lnT>
+                    <a:lnB w="6350" cap="flat" cmpd="sng" algn="ctr">
+                      <a:solidFill>
+                        <a:srgbClr val="D5DEDA"/>
+                      </a:solidFill>
+                      <a:prstDash val="solid"/>
+                      <a:round/>
+                      <a:headEnd type="none" w="med" len="med"/>
+                      <a:tailEnd type="none" w="med" len="med"/>
+                    </a:lnB>
+                    <a:solidFill>
+                      <a:srgbClr val="FFFFFF"/>
+                    </a:solidFill>
+                  </a:tcPr>
+                </a:tc>
+                <a:tc>
+                  <a:txBody>
+                    <a:bodyPr/>
+                    <a:lstStyle/>
+                    <a:p>
+                      <a:pPr indent="0" marL="0">
+                        <a:buNone/>
+                      </a:pPr>
+                      <a:r>
+                        <a:rPr lang="en-US" sz="1700" dirty="0">
+                          <a:solidFill>
+                            <a:srgbClr val="213B45"/>
+                          </a:solidFill>
+                        </a:rPr>
+                        <a:t>4.36625 / F4</a:t>
+                      </a:r>
+                      <a:endParaRPr lang="en-US" sz="1700" dirty="0"/>
+                    </a:p>
+                  </a:txBody>
+                  <a:tcPr marL="109728" marR="109728" marT="109728" marB="109728">
+                    <a:lnL w="6350" cap="flat" cmpd="sng" algn="ctr">
+                      <a:solidFill>
+                        <a:srgbClr val="D5DEDA"/>
+                      </a:solidFill>
+                      <a:prstDash val="solid"/>
+                      <a:round/>
+                      <a:headEnd type="none" w="med" len="med"/>
+                      <a:tailEnd type="none" w="med" len="med"/>
+                    </a:lnL>
+                    <a:lnR w="6350" cap="flat" cmpd="sng" algn="ctr">
+                      <a:solidFill>
+                        <a:srgbClr val="D5DEDA"/>
+                      </a:solidFill>
+                      <a:prstDash val="solid"/>
+                      <a:round/>
+                      <a:headEnd type="none" w="med" len="med"/>
+                      <a:tailEnd type="none" w="med" len="med"/>
+                    </a:lnR>
+                    <a:lnT w="6350" cap="flat" cmpd="sng" algn="ctr">
+                      <a:solidFill>
+                        <a:srgbClr val="D5DEDA"/>
+                      </a:solidFill>
+                      <a:prstDash val="solid"/>
+                      <a:round/>
+                      <a:headEnd type="none" w="med" len="med"/>
+                      <a:tailEnd type="none" w="med" len="med"/>
+                    </a:lnT>
+                    <a:lnB w="6350" cap="flat" cmpd="sng" algn="ctr">
+                      <a:solidFill>
+                        <a:srgbClr val="D5DEDA"/>
+                      </a:solidFill>
+                      <a:prstDash val="solid"/>
+                      <a:round/>
+                      <a:headEnd type="none" w="med" len="med"/>
+                      <a:tailEnd type="none" w="med" len="med"/>
+                    </a:lnB>
+                    <a:solidFill>
+                      <a:srgbClr val="FFFFFF"/>
+                    </a:solidFill>
+                  </a:tcPr>
+                </a:tc>
+              </a:tr>
+            </a:tbl>
+          </a:graphicData>
+        </a:graphic>
+      </p:graphicFrame>
       <p:sp>
         <p:nvSpPr>
           <p:cNvPr id="8" name="Text 4"/>
@@ -7098,8 +8173,8 @@
         </p:nvSpPr>
         <p:spPr>
           <a:xfrm>
-            <a:off x="548640" y="5495544"/>
-            <a:ext cx="11064240" cy="384048"/>
+            <a:off x="548640" y="3886200"/>
+            <a:ext cx="11064240" cy="868680"/>
           </a:xfrm>
           <a:prstGeom prst="rect">
             <a:avLst/>
@@ -7115,14 +8190,50 @@
               <a:buNone/>
             </a:pPr>
             <a:r>
-              <a:rPr lang="en-US" sz="1300" dirty="0">
+              <a:rPr lang="en-US" sz="2100" dirty="0">
+                <a:solidFill>
+                  <a:srgbClr val="213B45"/>
+                </a:solidFill>
+              </a:rPr>
+              <a:t>同一材料冲击使加权债务/EBITDA由 19.73 倍升至 25.18 倍，财务档由 F3 至 F4。经营C、其他调整不变时，矩阵较弱端为 A 与 BBB+。</a:t>
+            </a:r>
+            <a:endParaRPr lang="en-US" sz="2100" dirty="0"/>
+          </a:p>
+        </p:txBody>
+      </p:sp>
+      <p:sp>
+        <p:nvSpPr>
+          <p:cNvPr id="9" name="Text 5"/>
+          <p:cNvSpPr/>
+          <p:nvPr/>
+        </p:nvSpPr>
+        <p:spPr>
+          <a:xfrm>
+            <a:off x="548640" y="5029200"/>
+            <a:ext cx="11064240" cy="658368"/>
+          </a:xfrm>
+          <a:prstGeom prst="rect">
+            <a:avLst/>
+          </a:prstGeom>
+          <a:noFill/>
+          <a:ln/>
+        </p:spPr>
+        <p:txBody>
+          <a:bodyPr wrap="square" lIns="0" tIns="0" rIns="0" bIns="0" rtlCol="0" anchor="t"/>
+          <a:lstStyle/>
+          <a:p>
+            <a:pPr indent="0" marL="0">
+              <a:buNone/>
+            </a:pPr>
+            <a:r>
+              <a:rPr lang="en-US" sz="1700" dirty="0">
                 <a:solidFill>
                   <a:srgbClr val="A34638"/>
                 </a:solidFill>
               </a:rPr>
-              <a:t>图示固定两版历史调整ΔA=ΔH=0、持续范围调整Γ=0；实际未知。各线还须扣未核还本D、净用途X、营运缓冲及用途隔离；季度末余额不证明月内付款覆盖。</a:t>
+              <a:t>预测金额按20/30/50加权属于研究适配，另列年度比率路线。减值、税款、定性选分及融资仍有条件分支；这里的A不是实际上调结论，完整敏感性见底稿。</a:t>
             </a:r>
-            <a:endParaRPr lang="en-US" sz="1300" dirty="0"/>
+            <a:endParaRPr lang="en-US" sz="1700" dirty="0"/>
           </a:p>
         </p:txBody>
       </p:sp>
@@ -7188,7 +8299,7 @@
                   <a:srgbClr val="213B45"/>
                 </a:solidFill>
               </a:rPr>
-              <a:t>用途恢复与营运缓冲改变需要落实的融资</a:t>
+              <a:t>融资成本与融资上限必须进入同一现金链</a:t>
             </a:r>
             <a:endParaRPr lang="en-US" sz="3000" dirty="0"/>
           </a:p>
@@ -7260,47 +8371,38 @@
                   <a:srgbClr val="5C6C71"/>
                 </a:solidFill>
               </a:rPr>
-              <a:t>底稿记录：ks_d_n_funds / ks_project_n_restore_event / ks_horizon_find_horizon；原页、公式及完整限制见报告和Excel。</a:t>
+              <a:t>底稿记录：ks_econ_f_funding / ks_project_n_restore_event / ks_econ_q_chain；原页、公式及完整限制见报告和Excel。</a:t>
             </a:r>
             <a:endParaRPr lang="en-US" sz="1000" dirty="0"/>
           </a:p>
         </p:txBody>
       </p:sp>
-      <p:sp>
-        <p:nvSpPr>
-          <p:cNvPr id="6" name="Shape 3"/>
+      <p:graphicFrame>
+        <p:nvGraphicFramePr>
+          <p:cNvPr id="6" name="Chart 0" descr=""/>
+          <p:cNvGraphicFramePr/>
+          <p:nvPr/>
+        </p:nvGraphicFramePr>
+        <p:xfrm>
+          <a:off x="548640" y="1389888"/>
+          <a:ext cx="7223760" cy="3520440"/>
+        </p:xfrm>
+        <a:graphic xmlns:a="http://schemas.openxmlformats.org/drawingml/2006/main">
+          <a:graphicData uri="http://schemas.openxmlformats.org/drawingml/2006/chart">
+            <c:chart xmlns:c="http://schemas.openxmlformats.org/drawingml/2006/chart" r:id="rId1"/>
+          </a:graphicData>
+        </a:graphic>
+      </p:graphicFrame>
+      <p:sp>
+        <p:nvSpPr>
+          <p:cNvPr id="7" name="Text 3"/>
           <p:cNvSpPr/>
           <p:nvPr/>
         </p:nvSpPr>
         <p:spPr>
           <a:xfrm>
-            <a:off x="548640" y="1417320"/>
-            <a:ext cx="3474720" cy="1691640"/>
-          </a:xfrm>
-          <a:prstGeom prst="rect">
-            <a:avLst/>
-          </a:prstGeom>
-          <a:solidFill>
-            <a:srgbClr val="E6EFEC"/>
-          </a:solidFill>
-          <a:ln w="12700">
-            <a:solidFill>
-              <a:srgbClr val="E6EFEC"/>
-            </a:solidFill>
-            <a:prstDash val="solid"/>
-          </a:ln>
-        </p:spPr>
-      </p:sp>
-      <p:sp>
-        <p:nvSpPr>
-          <p:cNvPr id="7" name="Text 4"/>
-          <p:cNvSpPr/>
-          <p:nvPr/>
-        </p:nvSpPr>
-        <p:spPr>
-          <a:xfrm>
-            <a:off x="749808" y="1563624"/>
-            <a:ext cx="3072384" cy="320040"/>
+            <a:off x="8183880" y="1600200"/>
+            <a:ext cx="3401568" cy="2103120"/>
           </a:xfrm>
           <a:prstGeom prst="rect">
             <a:avLst/>
@@ -7316,401 +8418,75 @@
               <a:buNone/>
             </a:pPr>
             <a:r>
-              <a:rPr lang="en-US" sz="1400" dirty="0">
+              <a:rPr lang="en-US" sz="2100" dirty="0">
                 <a:solidFill>
                   <a:srgbClr val="213B45"/>
                 </a:solidFill>
               </a:rPr>
-              <a:t>基准：用途占用6.5亿元</a:t>
+              <a:t>累计新增贷款</a:t>
             </a:r>
-            <a:endParaRPr lang="en-US" sz="1400" dirty="0"/>
-          </a:p>
-        </p:txBody>
-      </p:sp>
-      <p:sp>
-        <p:nvSpPr>
-          <p:cNvPr id="8" name="Text 5"/>
-          <p:cNvSpPr/>
-          <p:nvPr/>
-        </p:nvSpPr>
-        <p:spPr>
-          <a:xfrm>
-            <a:off x="749808" y="1984248"/>
-            <a:ext cx="3072384" cy="530352"/>
-          </a:xfrm>
-          <a:prstGeom prst="rect">
-            <a:avLst/>
-          </a:prstGeom>
-          <a:noFill/>
-          <a:ln/>
-        </p:spPr>
-        <p:txBody>
-          <a:bodyPr wrap="square" lIns="0" tIns="0" rIns="0" bIns="0" rtlCol="0" anchor="t"/>
-          <a:lstStyle/>
+            <a:endParaRPr lang="en-US" sz="2100" dirty="0"/>
+          </a:p>
           <a:p>
             <a:pPr indent="0" marL="0">
               <a:buNone/>
             </a:pPr>
             <a:r>
-              <a:rPr lang="en-US" sz="2500" b="1" dirty="0">
+              <a:rPr lang="en-US" sz="2100" dirty="0">
                 <a:solidFill>
-                  <a:srgbClr val="237F72"/>
+                  <a:srgbClr val="213B45"/>
                 </a:solidFill>
               </a:rPr>
-              <a:t>6.89 亿元人民币</a:t>
+              <a:t>截至2027年六月</a:t>
             </a:r>
-            <a:endParaRPr lang="en-US" sz="2500" dirty="0"/>
-          </a:p>
-        </p:txBody>
-      </p:sp>
-      <p:sp>
-        <p:nvSpPr>
-          <p:cNvPr id="9" name="Text 6"/>
-          <p:cNvSpPr/>
-          <p:nvPr/>
-        </p:nvSpPr>
-        <p:spPr>
-          <a:xfrm>
-            <a:off x="749808" y="2569464"/>
-            <a:ext cx="3072384" cy="393192"/>
-          </a:xfrm>
-          <a:prstGeom prst="rect">
-            <a:avLst/>
-          </a:prstGeom>
-          <a:noFill/>
-          <a:ln/>
-        </p:spPr>
-        <p:txBody>
-          <a:bodyPr wrap="square" lIns="0" tIns="0" rIns="0" bIns="0" rtlCol="0" anchor="t"/>
-          <a:lstStyle/>
+            <a:endParaRPr lang="en-US" sz="2100" dirty="0"/>
+          </a:p>
+          <a:p>
+            <a:pPr indent="0" marL="0">
+              <a:buNone/>
+            </a:pPr>
+            <a:endParaRPr lang="en-US" sz="2100" dirty="0"/>
+          </a:p>
           <a:p>
             <a:pPr indent="0" marL="0">
               <a:buNone/>
             </a:pPr>
             <a:r>
-              <a:rPr lang="en-US" sz="1200" dirty="0">
+              <a:rPr lang="en-US" sz="2100" dirty="0">
                 <a:solidFill>
                   <a:srgbClr val="213B45"/>
                 </a:solidFill>
               </a:rPr>
-              <a:t>累计融资截距；15日研究缓冲</a:t>
+              <a:t>材料+5%</a:t>
             </a:r>
-            <a:endParaRPr lang="en-US" sz="1200" dirty="0"/>
-          </a:p>
-        </p:txBody>
-      </p:sp>
-      <p:sp>
-        <p:nvSpPr>
-          <p:cNvPr id="10" name="Shape 7"/>
-          <p:cNvSpPr/>
-          <p:nvPr/>
-        </p:nvSpPr>
-        <p:spPr>
-          <a:xfrm>
-            <a:off x="4251960" y="1417320"/>
-            <a:ext cx="3474720" cy="1691640"/>
-          </a:xfrm>
-          <a:prstGeom prst="rect">
-            <a:avLst/>
-          </a:prstGeom>
-          <a:solidFill>
-            <a:srgbClr val="E6EFEC"/>
-          </a:solidFill>
-          <a:ln w="12700">
-            <a:solidFill>
-              <a:srgbClr val="E6EFEC"/>
-            </a:solidFill>
-            <a:prstDash val="solid"/>
-          </a:ln>
-        </p:spPr>
-      </p:sp>
-      <p:sp>
-        <p:nvSpPr>
-          <p:cNvPr id="11" name="Text 8"/>
-          <p:cNvSpPr/>
-          <p:nvPr/>
-        </p:nvSpPr>
-        <p:spPr>
-          <a:xfrm>
-            <a:off x="4453128" y="1563624"/>
-            <a:ext cx="3072384" cy="320040"/>
-          </a:xfrm>
-          <a:prstGeom prst="rect">
-            <a:avLst/>
-          </a:prstGeom>
-          <a:noFill/>
-          <a:ln/>
-        </p:spPr>
-        <p:txBody>
-          <a:bodyPr wrap="square" lIns="0" tIns="0" rIns="0" bIns="0" rtlCol="0" anchor="t"/>
-          <a:lstStyle/>
+            <a:endParaRPr lang="en-US" sz="2100" dirty="0"/>
+          </a:p>
           <a:p>
             <a:pPr indent="0" marL="0">
               <a:buNone/>
             </a:pPr>
             <a:r>
-              <a:rPr lang="en-US" sz="1400" dirty="0">
+              <a:rPr lang="en-US" sz="2100" dirty="0">
                 <a:solidFill>
                   <a:srgbClr val="213B45"/>
                 </a:solidFill>
               </a:rPr>
-              <a:t>基准：用途占用13亿元</a:t>
+              <a:t>12.34 亿元人民币</a:t>
             </a:r>
-            <a:endParaRPr lang="en-US" sz="1400" dirty="0"/>
-          </a:p>
-        </p:txBody>
-      </p:sp>
-      <p:sp>
-        <p:nvSpPr>
-          <p:cNvPr id="12" name="Text 9"/>
+            <a:endParaRPr lang="en-US" sz="2100" dirty="0"/>
+          </a:p>
+        </p:txBody>
+      </p:sp>
+      <p:sp>
+        <p:nvSpPr>
+          <p:cNvPr id="8" name="Text 4"/>
           <p:cNvSpPr/>
           <p:nvPr/>
         </p:nvSpPr>
         <p:spPr>
           <a:xfrm>
-            <a:off x="4453128" y="1984248"/>
-            <a:ext cx="3072384" cy="530352"/>
-          </a:xfrm>
-          <a:prstGeom prst="rect">
-            <a:avLst/>
-          </a:prstGeom>
-          <a:noFill/>
-          <a:ln/>
-        </p:spPr>
-        <p:txBody>
-          <a:bodyPr wrap="square" lIns="0" tIns="0" rIns="0" bIns="0" rtlCol="0" anchor="t"/>
-          <a:lstStyle/>
-          <a:p>
-            <a:pPr indent="0" marL="0">
-              <a:buNone/>
-            </a:pPr>
-            <a:r>
-              <a:rPr lang="en-US" sz="2500" b="1" dirty="0">
-                <a:solidFill>
-                  <a:srgbClr val="A34638"/>
-                </a:solidFill>
-              </a:rPr>
-              <a:t>13.39 亿元人民币</a:t>
-            </a:r>
-            <a:endParaRPr lang="en-US" sz="2500" dirty="0"/>
-          </a:p>
-        </p:txBody>
-      </p:sp>
-      <p:sp>
-        <p:nvSpPr>
-          <p:cNvPr id="13" name="Text 10"/>
-          <p:cNvSpPr/>
-          <p:nvPr/>
-        </p:nvSpPr>
-        <p:spPr>
-          <a:xfrm>
-            <a:off x="4453128" y="2569464"/>
-            <a:ext cx="3072384" cy="393192"/>
-          </a:xfrm>
-          <a:prstGeom prst="rect">
-            <a:avLst/>
-          </a:prstGeom>
-          <a:noFill/>
-          <a:ln/>
-        </p:spPr>
-        <p:txBody>
-          <a:bodyPr wrap="square" lIns="0" tIns="0" rIns="0" bIns="0" rtlCol="0" anchor="t"/>
-          <a:lstStyle/>
-          <a:p>
-            <a:pPr indent="0" marL="0">
-              <a:buNone/>
-            </a:pPr>
-            <a:r>
-              <a:rPr lang="en-US" sz="1200" dirty="0">
-                <a:solidFill>
-                  <a:srgbClr val="213B45"/>
-                </a:solidFill>
-              </a:rPr>
-              <a:t>参数敏感性；非实际占用</a:t>
-            </a:r>
-            <a:endParaRPr lang="en-US" sz="1200" dirty="0"/>
-          </a:p>
-        </p:txBody>
-      </p:sp>
-      <p:sp>
-        <p:nvSpPr>
-          <p:cNvPr id="14" name="Shape 11"/>
-          <p:cNvSpPr/>
-          <p:nvPr/>
-        </p:nvSpPr>
-        <p:spPr>
-          <a:xfrm>
-            <a:off x="7955280" y="1417320"/>
-            <a:ext cx="3657600" cy="1691640"/>
-          </a:xfrm>
-          <a:prstGeom prst="rect">
-            <a:avLst/>
-          </a:prstGeom>
-          <a:solidFill>
-            <a:srgbClr val="E6EFEC"/>
-          </a:solidFill>
-          <a:ln w="12700">
-            <a:solidFill>
-              <a:srgbClr val="E6EFEC"/>
-            </a:solidFill>
-            <a:prstDash val="solid"/>
-          </a:ln>
-        </p:spPr>
-      </p:sp>
-      <p:sp>
-        <p:nvSpPr>
-          <p:cNvPr id="15" name="Text 12"/>
-          <p:cNvSpPr/>
-          <p:nvPr/>
-        </p:nvSpPr>
-        <p:spPr>
-          <a:xfrm>
-            <a:off x="8156448" y="1563624"/>
-            <a:ext cx="3255264" cy="320040"/>
-          </a:xfrm>
-          <a:prstGeom prst="rect">
-            <a:avLst/>
-          </a:prstGeom>
-          <a:noFill/>
-          <a:ln/>
-        </p:spPr>
-        <p:txBody>
-          <a:bodyPr wrap="square" lIns="0" tIns="0" rIns="0" bIns="0" rtlCol="0" anchor="t"/>
-          <a:lstStyle/>
-          <a:p>
-            <a:pPr indent="0" marL="0">
-              <a:buNone/>
-            </a:pPr>
-            <a:r>
-              <a:rPr lang="en-US" sz="1400" dirty="0">
-                <a:solidFill>
-                  <a:srgbClr val="213B45"/>
-                </a:solidFill>
-              </a:rPr>
-              <a:t>另延5%：用途占用6.5亿元</a:t>
-            </a:r>
-            <a:endParaRPr lang="en-US" sz="1400" dirty="0"/>
-          </a:p>
-        </p:txBody>
-      </p:sp>
-      <p:sp>
-        <p:nvSpPr>
-          <p:cNvPr id="16" name="Text 13"/>
-          <p:cNvSpPr/>
-          <p:nvPr/>
-        </p:nvSpPr>
-        <p:spPr>
-          <a:xfrm>
-            <a:off x="8156448" y="1984248"/>
-            <a:ext cx="3255264" cy="530352"/>
-          </a:xfrm>
-          <a:prstGeom prst="rect">
-            <a:avLst/>
-          </a:prstGeom>
-          <a:noFill/>
-          <a:ln/>
-        </p:spPr>
-        <p:txBody>
-          <a:bodyPr wrap="square" lIns="0" tIns="0" rIns="0" bIns="0" rtlCol="0" anchor="t"/>
-          <a:lstStyle/>
-          <a:p>
-            <a:pPr indent="0" marL="0">
-              <a:buNone/>
-            </a:pPr>
-            <a:r>
-              <a:rPr lang="en-US" sz="2500" b="1" dirty="0">
-                <a:solidFill>
-                  <a:srgbClr val="A34638"/>
-                </a:solidFill>
-              </a:rPr>
-              <a:t>10.30 亿元人民币</a:t>
-            </a:r>
-            <a:endParaRPr lang="en-US" sz="2500" dirty="0"/>
-          </a:p>
-        </p:txBody>
-      </p:sp>
-      <p:sp>
-        <p:nvSpPr>
-          <p:cNvPr id="17" name="Text 14"/>
-          <p:cNvSpPr/>
-          <p:nvPr/>
-        </p:nvSpPr>
-        <p:spPr>
-          <a:xfrm>
-            <a:off x="8156448" y="2569464"/>
-            <a:ext cx="3255264" cy="393192"/>
-          </a:xfrm>
-          <a:prstGeom prst="rect">
-            <a:avLst/>
-          </a:prstGeom>
-          <a:noFill/>
-          <a:ln/>
-        </p:spPr>
-        <p:txBody>
-          <a:bodyPr wrap="square" lIns="0" tIns="0" rIns="0" bIns="0" rtlCol="0" anchor="t"/>
-          <a:lstStyle/>
-          <a:p>
-            <a:pPr indent="0" marL="0">
-              <a:buNone/>
-            </a:pPr>
-            <a:r>
-              <a:rPr lang="en-US" sz="1200" dirty="0">
-                <a:solidFill>
-                  <a:srgbClr val="213B45"/>
-                </a:solidFill>
-              </a:rPr>
-              <a:t>未当作已承诺融资</a:t>
-            </a:r>
-            <a:endParaRPr lang="en-US" sz="1200" dirty="0"/>
-          </a:p>
-        </p:txBody>
-      </p:sp>
-      <p:sp>
-        <p:nvSpPr>
-          <p:cNvPr id="18" name="Text 15"/>
-          <p:cNvSpPr/>
-          <p:nvPr/>
-        </p:nvSpPr>
-        <p:spPr>
-          <a:xfrm>
-            <a:off x="548640" y="3566160"/>
-            <a:ext cx="11064240" cy="886968"/>
-          </a:xfrm>
-          <a:prstGeom prst="rect">
-            <a:avLst/>
-          </a:prstGeom>
-          <a:noFill/>
-          <a:ln/>
-        </p:spPr>
-        <p:txBody>
-          <a:bodyPr wrap="square" lIns="0" tIns="0" rIns="0" bIns="0" rtlCol="0" anchor="t"/>
-          <a:lstStyle/>
-          <a:p>
-            <a:pPr indent="0" marL="0">
-              <a:buNone/>
-            </a:pPr>
-            <a:r>
-              <a:rPr lang="en-US" sz="2200" dirty="0">
-                <a:solidFill>
-                  <a:srgbClr val="213B45"/>
-                </a:solidFill>
-              </a:rPr>
-              <a:t>临时补流须在2027-01-09十二个月边界及更早项目需要前恢复用途。归还专户是内部调度，须与已有用途预留去重；实际占用仍未知。</a:t>
-            </a:r>
-            <a:endParaRPr lang="en-US" sz="2200" dirty="0"/>
-          </a:p>
-        </p:txBody>
-      </p:sp>
-      <p:sp>
-        <p:nvSpPr>
-          <p:cNvPr id="19" name="Text 16"/>
-          <p:cNvSpPr/>
-          <p:nvPr/>
-        </p:nvSpPr>
-        <p:spPr>
-          <a:xfrm>
-            <a:off x="548640" y="4718304"/>
-            <a:ext cx="11064240" cy="731520"/>
+            <a:off x="8183880" y="3749040"/>
+            <a:ext cx="3401568" cy="1051560"/>
           </a:xfrm>
           <a:prstGeom prst="rect">
             <a:avLst/>
@@ -7731,9 +8507,109 @@
                   <a:srgbClr val="A34638"/>
                 </a:solidFill>
               </a:rPr>
-              <a:t>截距固定ΔA=ΔH=Γ=D=X=P=0，实际参数未知。范围调整须同时改变经营收付与缓冲；还本、净用途及合格项目耗用须另核并去重。实际融资需求尚不能定值。</a:t>
+              <a:t>若融资限5亿元</a:t>
             </a:r>
             <a:endParaRPr lang="en-US" sz="1900" dirty="0"/>
+          </a:p>
+          <a:p>
+            <a:pPr indent="0" marL="0">
+              <a:buNone/>
+            </a:pPr>
+            <a:r>
+              <a:rPr lang="en-US" sz="1900" dirty="0">
+                <a:solidFill>
+                  <a:srgbClr val="A34638"/>
+                </a:solidFill>
+              </a:rPr>
+              <a:t>2027-03-31</a:t>
+            </a:r>
+            <a:endParaRPr lang="en-US" sz="1900" dirty="0"/>
+          </a:p>
+          <a:p>
+            <a:pPr indent="0" marL="0">
+              <a:buNone/>
+            </a:pPr>
+            <a:r>
+              <a:rPr lang="en-US" sz="1900" dirty="0">
+                <a:solidFill>
+                  <a:srgbClr val="A34638"/>
+                </a:solidFill>
+              </a:rPr>
+              <a:t>缺口 3.60 亿元</a:t>
+            </a:r>
+            <a:endParaRPr lang="en-US" sz="1900" dirty="0"/>
+          </a:p>
+        </p:txBody>
+      </p:sp>
+      <p:sp>
+        <p:nvSpPr>
+          <p:cNvPr id="9" name="Text 5"/>
+          <p:cNvSpPr/>
+          <p:nvPr/>
+        </p:nvSpPr>
+        <p:spPr>
+          <a:xfrm>
+            <a:off x="548640" y="5074920"/>
+            <a:ext cx="11064240" cy="594360"/>
+          </a:xfrm>
+          <a:prstGeom prst="rect">
+            <a:avLst/>
+          </a:prstGeom>
+          <a:noFill/>
+          <a:ln/>
+        </p:spPr>
+        <p:txBody>
+          <a:bodyPr wrap="square" lIns="0" tIns="0" rIns="0" bIns="0" rtlCol="0" anchor="t"/>
+          <a:lstStyle/>
+          <a:p>
+            <a:pPr indent="0" marL="0">
+              <a:buNone/>
+            </a:pPr>
+            <a:r>
+              <a:rPr lang="en-US" sz="1700" dirty="0">
+                <a:solidFill>
+                  <a:srgbClr val="213B45"/>
+                </a:solidFill>
+              </a:rPr>
+              <a:t>新贷款季初到位并计息；15日经营底线、用途占用6.5亿元及1月9日前恢复预留均为条件。无法融资时停止后续完整评级，不自动填平缺口。</a:t>
+            </a:r>
+            <a:endParaRPr lang="en-US" sz="1700" dirty="0"/>
+          </a:p>
+        </p:txBody>
+      </p:sp>
+      <p:sp>
+        <p:nvSpPr>
+          <p:cNvPr id="10" name="Text 6"/>
+          <p:cNvSpPr/>
+          <p:nvPr/>
+        </p:nvSpPr>
+        <p:spPr>
+          <a:xfrm>
+            <a:off x="548640" y="5650992"/>
+            <a:ext cx="11064240" cy="246888"/>
+          </a:xfrm>
+          <a:prstGeom prst="rect">
+            <a:avLst/>
+          </a:prstGeom>
+          <a:noFill/>
+          <a:ln/>
+        </p:spPr>
+        <p:txBody>
+          <a:bodyPr wrap="square" lIns="0" tIns="0" rIns="0" bIns="0" rtlCol="0" anchor="t"/>
+          <a:lstStyle/>
+          <a:p>
+            <a:pPr indent="0" marL="0">
+              <a:buNone/>
+            </a:pPr>
+            <a:r>
+              <a:rPr lang="en-US" sz="1100" dirty="0">
+                <a:solidFill>
+                  <a:srgbClr val="A34638"/>
+                </a:solidFill>
+              </a:rPr>
+              <a:t>集团池不等于发行人可用款；历史范围修正、合同还本、实际用途及提款仍待核。旧零调整现金截距另列，不与本图累计新贷款混用。</a:t>
+            </a:r>
+            <a:endParaRPr lang="en-US" sz="1100" dirty="0"/>
           </a:p>
         </p:txBody>
       </p:sp>

</xml_diff>

<commit_message>
Reconcile issuer debt disclosures in Keshun example
</commit_message>
<xml_diff>
--- a/examples/keshun-2025/deliverables/research-brief.pptx
+++ b/examples/keshun-2025/deliverables/research-brief.pptx
@@ -1064,7 +1064,7 @@
               <a:rPr lang="en-US" dirty="0"/>
               <a:t>{"id":"ks_r_followup","title":"展望与后续评级行动有明确决定边界","question":"哪些变化真正改变建议，而不只是更新比率？","conclusion":"负面展望反映一年内的行业需求、回收、用途与融资压力。历史固定定性量化区间跨F5/F4，上端未达F3；未来经营融资的无材料涨价分支可得C/F3及A矩阵值，材料5%分支为C/F4及BBB+，均未证明实际持续改善。只有经营现金兑现、发行人资金及合同问题解决后才讨论实际上调；若付款条件失败立即重评。经营D/F4、C/F5、D/F5的既有变化分支继续保留。","mechanism":"跟踪先更新月度银行现金、实际用途占用、母公司到期表和持续承诺解释，再更新半年度/年度亏损、应收回收、订单及融资。三年完整重述和更可靠预测会改变加权依据；对应结果应重算而非沿用此次分数。没有设置后台监控、没有真实委员会投票。 临时补流按2027-01-09十二个月边界及更早项目需要核查；延伸至2027年6月的条件资金容量须代入实际还本、其他净用途、项目耗用和用途占用，再检验发行人可调度资金及可落实融资。 优先关闭10.8/47亿元额度冲突、年末39户保证至三月及六月的存续滚动，并核保证支持的实际收现和期后追偿。","status":"conditional","evidence":["ks_r_e_definitions","ks_r_e_matrix","ks_r_financial_lower","ks_r_financial_upper","ks_d_e_commitment","ks_d_e_fund_new","ks_project_e_schedule","ks_credit_e_facilities","ks_credit_e_dealer_schedule","ks_credit_e_guarantee_q1"],"counterevidence":["ks_a_e_q1"],"alternatives":["季度业绩改善可使展望转稳，但需要完整期间现金而不只是利润。","正式解释若证明承诺无新增现金后果，会关闭该项不确定性，其他经营财务风险仍需重评。"],"changes_if":"按本研究截止日安排下一次检查于下一份实际半年度披露及任何提前到期、用途变更或支持事件；若已发生应立即反映的偿付问题，不等待下一年度或用展望推迟调整。","figure_refs":["ks_r_financial_lower","ks_r_financial_upper"]}
 {"id":"ks_r_rating_chain"}
-{"id":"ks_credit_find_facilities","title":"未用借款与授信披露冲突，融资落实条件待核","question":"年末披露额度能否支持付款日的再融资假设？","conclusion":"年报未用银行借款额度10.80 亿元人民币，跟踪报告同称2025年底的银行授信总额73.00 亿元人民币、未用47.00 亿元人民币。未用披露名义差额36.20 亿元人民币，尚未解释。两来源用词不同只是待核线索，不能据此称口径已对齐，任何一项也未作为已落实现金计入。","mechanism":"按同一法人、银行及产品对应总额、已用、未用、共享或循环额度，核抵质押、保证金、财务约束、提款前提、撤销权和有效期，再将真正可用金额匹配付款日。综合授信可能包含票据、保函或其他产品，年报借款额度也可能有不同总体；这些是候选解释，不是已查明原因。现有再融资研究分5.0/4.5及加权4.65仅保留为原条件分支，金额冲突未关闭前不能证明这一赋值或BBB+资金前提充分，也不因缺资料任意另给分。","status":"unresolved","evidence":["ks_a_e_maturity","ks_credit_e_facilities","ks_credit_facility_gap"],"counterevidence":["ks_a_e_q1"],"alternatives":["一季度实际新增借款证明当季有融资发生，但不能证明六月以后的未用额度、提款条件或母公司付款能力。","若合同总体差异完整解释差额且足额资源可按时提用，可支持融资能力；若主要是可撤销、受限或非现金产品，则应降低可依赖融资并重新评估因素和资金前提。"],"changes_if":"取得两个披露总体的逐项桥及银行直接证据，列明每个付款日已承诺可提金额、条件满足状态和现金所在法人；仍未解释部分排除已落实来源。以核实结果更新再融资因素及资金情景；先检查付款前提是否失效，再决定等级和展望，不沿用4.65作为已证实结论。","figure_refs":["ks_a_undrawn","ks_credit_facility_total","ks_credit_facility_undrawn","ks_credit_facility_gap"]}</a:t>
+{"id":"ks_credit_find_facilities","title":"未用借款与授信披露冲突，融资落实条件待核","question":"年末披露额度能否支持付款日的再融资假设？","conclusion":"年报未用银行借款额度10.80 亿元人民币，跟踪报告同称2025年底的银行授信总额73.00 亿元人民币、未用47.00 亿元人民币。未用披露名义差额36.20 亿元人民币，尚未解释。两来源用词不同只是待核线索，不能据此称口径已对齐，任何一项也未作为已落实现金计入。","mechanism":"按同一法人、银行及产品对应总额、已用、未用、共享或循环额度，核抵质押、保证金、财务约束、提款前提、撤销权和有效期，再将真正可用金额匹配付款日。综合授信可能包含票据、保函或其他产品，年报借款额度也可能有不同总体；这些是候选解释，不是已查明原因。现有再融资研究分5.0/4.5及加权4.65仅保留为原条件分支，金额冲突未关闭前不能证明这一赋值或BBB+资金前提充分，也不因缺资料任意另给分。 年报第95页管理层称授信充足、可快速融资且自有资金及融资足以偿付；这与已披露季度融资形成支持线索，但未解决两个额度总体及合同可提用条件的差异。","status":"unresolved","evidence":["ks_a_e_maturity","ks_credit_e_facilities","ks_credit_facility_gap"],"counterevidence":["ks_a_e_q1","ks_a_e_bond_repayment_claim"],"alternatives":["一季度实际新增借款证明当季有融资发生，但不能证明六月以后的未用额度、提款条件或母公司付款能力。","若合同总体差异完整解释差额且足额资源可按时提用，可支持融资能力；若主要是可撤销、受限或非现金产品，则应降低可依赖融资并重新评估因素和资金前提。"],"changes_if":"取得两个披露总体的逐项桥及银行直接证据，列明每个付款日已承诺可提金额、条件满足状态和现金所在法人；仍未解释部分排除已落实来源。以核实结果更新再融资因素及资金情景；先检查付款前提是否失效，再决定等级和展望，不沿用4.65作为已证实结论。","figure_refs":["ks_a_undrawn","ks_credit_facility_total","ks_credit_facility_undrawn","ks_credit_facility_gap"]}</a:t>
             </a:r>
             <a:endParaRPr lang="en-US" dirty="0"/>
           </a:p>
@@ -1696,7 +1696,7 @@
 {"id":"ks_d_e_issue_coupon","source":"ks_d_s_m1","locator":"PDF p39–40，发行规模、期限、票面利率、还本付息条款","observation":"募集书发行规模上限219800.00万元，每张100元；债券期限2023-08-04至2029-08-03。六个计息年度票息依次为0.30%、0.50%、1.00%、1.50%、1.80%、2.00%；每满一年为付息日，节假日或休息日顺延且不另计息，登记日为付息日前一交易日，付息日后五个交易日内支付。登记日前及当日申请转股不再享有本年度及以后利息。","reliability":"官方原件正文；报告披露不等同于本次独立审计或法律鉴证。"}
 {"id":"ks_d_e_maturity_call","source":"ks_d_s_m1","locator":"PDF p43，赎回条款","observation":"到期后五个交易日内按票面面值115%赎回未转股债券，含最后一期利息。转股期内连续三十个交易日至少十五日收盘价不低于当期转股价130%，或未转股余额不足3000万元，发行人可按面值加应计利息赎回。","reliability":"官方原件正文；报告披露不等同于本次独立审计或法律鉴证。"}
 {"id":"ks_project_n_model","title":"旧项目末年测算不足以证明最终合同的偿债覆盖","question":"募集说明书项目测算是否仍能构成可用偿债来源？","conclusion":"正式合同115%已进入现有现金时间表，无需追加债务。原项目T+6测算采用104%比较额，且其中79.48%税前净现金来自固定资产余值和流动资金终期回收；扣除此两项后的原模型余额5.02 亿元人民币不是标准经营现金流。该历史项目预测不能直接列作截止日已落实的母公司偿债资金。","mechanism":"同份文件第14/67页旧预测与第43页最终条款并列。按旧表满额面值重新套用115%会改变旧表覆盖结论，但既有2026—2029需求已用115%，不再追加差额。项目末年强行变现还需税费、权属/抵押与债权顺位、出售成交和营运资金净回收日期；清算回收不能与同一资产继续经营的现金流重复计算。原表是税前、项目层及T+6相对期间，不能跳过公司层及付款日的桥。","status":"supported","evidence":["ks_project_e_old_model","ks_d_e_maturity_call","ks_project_c_terminal_share","ks_project_c_corrected_old_gap","ks_d_g_cash_2029"],"counterevidence":["ks_d_e_general_performance","ks_a_e_q1"],"alternatives":["原104%可能是募集方案定价前的示意测算沿用，现有资料不足以判断原因、修订义务或主观意图；正式合同支付价格仍按115%。","此前留存项目现金、其他业务产现、可执行融资或真实转股均可能改变发行人总体覆盖；不能把旧末年单表差额等同集团资金缺口，也不能先假定这些资源已到账。"],"changes_if":"取得与最终条款、实际工程节点和截至信息日经营假设一致的逐月税后项目及发行人来源用途表，完成净可变现及资金上划桥后才纳入偿债来源。若旧预测从未进入现有量化来源，移除其信用论据不改变现有现金数值或机械改变档位。","figure_refs":["ks_project_c_terminal_share","ks_project_c_without_terminal","ks_project_c_corrected_old_gap","ks_d_g_cash_2029"]}
-{"id":"ks_project_n_timing","title":"项目延期压缩偿债前的投产回收窗口，临时补流归还须单独排期","question":"投入进度如何传导至未来支付及评级条件？","conclusion":"2025末四项建设升级的累计募集投入比例12.63%；未投入计划额度13.34 亿元人民币不是即期负债。四项预定可使用日均延至2028-12-31，与2029-08-03合同到期相隔215个自然日；可使用不等于满产、收款或已获处置价。2026-01-09新一期临时补流批准不超过12个月且项目需要时提前归还，不能因项目延期而把该用途义务推迟至2028年。","mechanism":"需求较弱→放慢投资可减少近期资本支出，却可能使新产能经营回款晚于债项支付；建设计划恢复→先需资金及营运周转→需将暂时补流从一般经营资金中恢复用途→先查母公司可调度现金。尚未投入额度、临时补流恢复用途与债券本金不是三笔可相加的外部债务。源表38.82%包括永久补流，不能证明项目已接近四成完工。","status":"conditional","evidence":["ks_project_e_progress","ks_project_e_schedule","ks_project_e_tracking","ks_d_e_fund_new","ks_d_e_issue_coupon","ks_d_e_maturity_call"],"counterevidence":["ks_project_e_schedule","ks_d_e_fund_return","ks_d_e_general_performance"],"alternatives":["谨慎减慢建设、保留现有产能及改进自研生产线可能降低过剩产能和近期现金消耗；项目可行性须由订单、成本及投产证据验证。","需求恢复可能加快建设和回款，但首先要求资金归位、采购付款及调试；若收款晚于合同付款日，全年或全生命周期盈利不能补救时点缺口。"],"changes_if":"不从原测算差异单独推导等级或展望变更，也不重复计入已进入基础因素的需求、盈利和治理事项；若经核实恢复用途/项目付款使近期发行人资金不能覆盖，则先更新月度现金和可执行融资，再判断常态评级是否仍适用。只有新的可比前瞻导致因素跨档或基础因素未计入的现金约束，才明确新的因素/调整路径。","figure_refs":["ks_project_c_project_ratio","ks_project_c_project_remaining"]}</a:t>
+{"id":"ks_project_n_timing","title":"项目延期压缩偿债前的投产回收窗口，临时补流归还须单独排期","question":"投入进度如何传导至未来支付及评级条件？","conclusion":"2025末四项建设升级的累计募集投入比例12.63%；未投入计划额度13.34 亿元人民币不是即期负债。四项预定可使用日均延至2028-12-31，与2029-08-03合同到期相隔215个自然日；可使用不等于满产、收款或已获处置价。2026-01-09新一期临时补流批准不超过12个月且项目需要时提前归还，不能因项目延期而把该用途义务推迟至2028年。","mechanism":"需求较弱→放慢投资可减少近期资本支出，却可能使新产能经营回款晚于债项支付；建设计划恢复→先需资金及营运周转→需将暂时补流从一般经营资金中恢复用途→先查母公司可调度现金。尚未投入额度、临时补流恢复用途与债券本金不是三笔可相加的外部债务。源表38.82%包括永久补流，不能证明项目已接近四成完工。 年报第95页称募投实施已提升盈利、稳定经营现金及自有资金和融资可支付回售/赎回/到期本息；与上述实际投入、延期和资金恢复条件对照，该主张尚不能替代按法人及付款日验证的偿债来源，投入比例也不能作为项目利润或完工率的反证。 第83页四项建设/升级项目当期及累计效益均明列零，是对项目贡献的直接披露；补流项目及全部资金用途的影响范围不同，不能据此认定上述总体主张虚假，但新增项目盈利尚未由该表支持。需说明具体收益、时点及法人并与现金预算衔接。","status":"conditional","evidence":["ks_project_e_progress","ks_project_e_schedule","ks_project_e_tracking","ks_d_e_fund_new","ks_d_e_issue_coupon","ks_d_e_maturity_call","ks_a_e_bond_repayment_claim","ks_a_e_project_reported_benefits","ks_a_e_audit"],"counterevidence":["ks_project_e_schedule","ks_d_e_fund_return","ks_d_e_general_performance"],"alternatives":["谨慎减慢建设、保留现有产能及改进自研生产线可能降低过剩产能和近期现金消耗；项目可行性须由订单、成本及投产证据验证。","需求恢复可能加快建设和回款，但首先要求资金归位、采购付款及调试；若收款晚于合同付款日，全年或全生命周期盈利不能补救时点缺口。"],"changes_if":"不从原测算差异单独推导等级或展望变更，也不重复计入已进入基础因素的需求、盈利和治理事项；若经核实恢复用途/项目付款使近期发行人资金不能覆盖，则先更新月度现金和可执行融资，再判断常态评级是否仍适用。只有新的可比前瞻导致因素跨档或基础因素未计入的现金约束，才明确新的因素/调整路径。","figure_refs":["ks_project_c_project_ratio","ks_project_c_project_remaining"]}</a:t>
             </a:r>
             <a:endParaRPr lang="en-US" dirty="0"/>
           </a:p>

</xml_diff>

<commit_message>
Correct example balance contexts and brief method attribution
</commit_message>
<xml_diff>
--- a/examples/keshun-2025/deliverables/research-brief.pptx
+++ b/examples/keshun-2025/deliverables/research-brief.pptx
@@ -2385,8 +2385,8 @@
         </p:nvSpPr>
         <p:spPr>
           <a:xfrm>
-            <a:off x="640080" y="4892040"/>
-            <a:ext cx="10698480" cy="640080"/>
+            <a:off x="640080" y="4709160"/>
+            <a:ext cx="10698480" cy="1051560"/>
           </a:xfrm>
           <a:prstGeom prst="rect">
             <a:avLst/>
@@ -2402,14 +2402,28 @@
               <a:buNone/>
             </a:pPr>
             <a:r>
-              <a:rPr lang="en-US" sz="1500" dirty="0">
+              <a:rPr lang="en-US" sz="1300" dirty="0">
                 <a:solidFill>
                   <a:srgbClr val="D4E8E1"/>
                 </a:solidFill>
               </a:rPr>
-              <a:t>采用境内相对信用尺度及联合公开方法的明示研究适配；不是联合资信评级行动。完整研究及底稿另附，本汇报只提炼影响决定的事项。</a:t>
+              <a:t>采用方法：联合资信一般工商企业信用评级方法与模型V4.1.202606；联合资信企业信用评级方法总论V4.1.202605；联合资信外部支持评估方法V4.1.202605；联合资信债项评级基本方法V3.0.202207。</a:t>
             </a:r>
-            <a:endParaRPr lang="en-US" sz="1500" dirty="0"/>
+            <a:endParaRPr lang="en-US" sz="1300" dirty="0"/>
+          </a:p>
+          <a:p>
+            <a:pPr indent="0" marL="0">
+              <a:buNone/>
+            </a:pPr>
+            <a:r>
+              <a:rPr lang="en-US" sz="1300" dirty="0">
+                <a:solidFill>
+                  <a:srgbClr val="D4E8E1"/>
+                </a:solidFill>
+              </a:rPr>
+              <a:t>采用境内相对信用尺度及明示研究适配；不是联合资信评级行动。完整研究及底稿另附。</a:t>
+            </a:r>
+            <a:endParaRPr lang="en-US" sz="1300" dirty="0"/>
           </a:p>
         </p:txBody>
       </p:sp>

</xml_diff>